<commit_message>
Deck: add the team's architecture diagram as its own slide
Co-Authored-By: Claude Opus 5.5 <noreply@anthropic.com>
</commit_message>
<xml_diff>
--- a/slides/KernelTune.pptx
+++ b/slides/KernelTune.pptx
@@ -12,9 +12,10 @@
     <p:sldId id="260" r:id="rId6"/>
     <p:sldId id="261" r:id="rId7"/>
     <p:sldId id="262" r:id="rId8"/>
+    <p:sldId id="263" r:id="rId9"/>
   </p:sldIdLst>
   <p:notesMasterIdLst>
-    <p:notesMasterId r:id="rId9"/>
+    <p:notesMasterId r:id="rId10"/>
   </p:notesMasterIdLst>
   <p:sldSz cx="12192000" cy="6858000"/>
   <p:notesSz cx="6858000" cy="12192000"/>
@@ -113,7 +114,7 @@
   <p:extLst>
     <p:ext uri="{521415D9-36F7-43E2-AB2F-B90AF26B5E84}">
       <p14:sectionLst xmlns:p14="http://schemas.microsoft.com/office/powerpoint/2010/main">
-        <p14:section name="Pitch" id="{a13c02e9-22ff-b533-1858-e04f5e134589}">
+        <p14:section name="Pitch" id="{0e5e1c13-1666-cfec-7519-7e2bb727b99e}">
           <p14:sldIdLst>
             <p14:sldId id="256"/>
             <p14:sldId id="257"/>
@@ -122,6 +123,7 @@
             <p14:sldId id="260"/>
             <p14:sldId id="261"/>
             <p14:sldId id="262"/>
+            <p14:sldId id="263"/>
           </p14:sldIdLst>
         </p14:section>
       </p14:sectionLst>
@@ -1332,7 +1334,7 @@
           <a:p>
             <a:r>
               <a:rPr lang="en-US" dirty="0"/>
-              <a:t>Version one showed the model the raw profile. It lost badly to random guessing. The checker said 'increase N to 24, that reduces data movement', the chip came back two and a half times slower, and it said it again. So we changed the message, not the model. Version two showed it comparisons worked out in code. Version three gave it a menu of moves with the measured record for each. Version four caught the second model editing a line it was not asked to touch. Version five had no wasted attempts at all.</a:t>
+              <a:t>The full picture. On the left, the loop driver on our laptop starts runs. Seat 205 serves Qwen3-8B, which plays both the checker and the optimiser. Seats 206 to 209 are the measuring checker: the blocked matmul kernel runs on a NeuronCore and neuron-explorer profiles it. Every attempt is logged, and the full sweep gives the ground truth. On the right are the side measurements: traced models against the AWS compiler default, the simulator comparison, and AWS's own recommend tool. At the bottom is what we built on.</a:t>
             </a:r>
             <a:endParaRPr lang="en-US" dirty="0"/>
           </a:p>
@@ -1420,7 +1422,7 @@
           <a:p>
             <a:r>
               <a:rPr lang="en-US" dirty="0"/>
-              <a:t>Same model, same chip, same budget: by redesigning only what the checker says, we went from 3 good runs out of 30 to 29 out of 30. Random guessing gets 73%. Here is the part we did not expect: replace the model with a one-line rule on the same menu and it finds the best setting in 71% of runs. The 8B model manages 50%, random 38%. So the value is in the measured menu. Do not say the model beats random at finding the best: 50% against 38% is not conclusive at 30 runs.</a:t>
+              <a:t>Version one showed the model the raw profile. It lost badly to random guessing. The checker said 'increase N to 24, that reduces data movement', the chip came back two and a half times slower, and it said it again. So we changed the message, not the model. Version two showed it comparisons worked out in code. Version three gave it a menu of moves with the measured record for each. Version four caught the second model editing a line it was not asked to touch. Version five had no wasted attempts at all.</a:t>
             </a:r>
             <a:endParaRPr lang="en-US" dirty="0"/>
           </a:p>
@@ -1508,7 +1510,7 @@
           <a:p>
             <a:r>
               <a:rPr lang="en-US" dirty="0"/>
-              <a:t>We ran the loop on every linear-layer shape in Qwen3-8B and compared it with AWS's own compiler doing the same multiply with no hand-written kernel. Untuned, a hand-written kernel is 12 to 30 percent slower than the compiler. Tuned by the loop it is level with it on every layer. Then we ran the loop at 16-bit, the precision real models use, scored on real inference time. From as slow as 8.6 milliseconds, all five runs ended at about 2.9, within 5% of the compiler at 2.75. Say 'level with the compiler', never 'faster than'.</a:t>
+              <a:t>Same model, same chip, same budget: by redesigning only what the checker says, we went from 3 good runs out of 30 to 29 out of 30. Random guessing gets 73%. Here is the part we did not expect: replace the model with a one-line rule on the same menu and it finds the best setting in 71% of runs. The 8B model manages 50%, random 38%. So the value is in the measured menu. Do not say the model beats random at finding the best: 50% against 38% is not conclusive at 30 runs.</a:t>
             </a:r>
             <a:endParaRPr lang="en-US" dirty="0"/>
           </a:p>
@@ -1596,7 +1598,7 @@
           <a:p>
             <a:r>
               <a:rPr lang="en-US" dirty="0"/>
-              <a:t>What are we handing over? An on-chip checker this track did not have. Full ground truth at two shapes. And measured evidence of what a small-model loop needs: tell it what the chip measured, not what to think. We do not beat your compiler, and for matmul nobody needs to. The next step is to point KernelTune at the kernels people do write by hand, where there is no compiler version to fall back on.</a:t>
+              <a:t>We ran the loop on every linear-layer shape in Qwen3-8B and compared it with AWS's own compiler doing the same multiply with no hand-written kernel. Untuned, a hand-written kernel is 12 to 30 percent slower than the compiler. Tuned by the loop it is level with it on every layer. Then we ran the loop at 16-bit, the precision real models use, scored on real inference time. From as slow as 8.6 milliseconds, all five runs ended at about 2.9, within 5% of the compiler at 2.75. Say 'level with the compiler', never 'faster than'.</a:t>
             </a:r>
             <a:endParaRPr lang="en-US" dirty="0"/>
           </a:p>
@@ -1620,6 +1622,94 @@
             <a:fld id="{F7021451-1387-4CA6-816F-3879F97B5CBC}" type="slidenum">
               <a:rPr lang="en-US"/>
               <a:t>7</a:t>
+            </a:fld>
+            <a:endParaRPr lang="en-US"/>
+          </a:p>
+        </p:txBody>
+      </p:sp>
+    </p:spTree>
+    <p:extLst>
+      <p:ext uri="{BB962C8B-B14F-4D97-AF65-F5344CB8AC3E}">
+        <p14:creationId xmlns:p14="http://schemas.microsoft.com/office/powerpoint/2010/main" val="1024086991"/>
+      </p:ext>
+    </p:extLst>
+  </p:cSld>
+  <p:clrMapOvr>
+    <a:masterClrMapping/>
+  </p:clrMapOvr>
+</p:notes>
+</file>
+
+<file path=ppt/notesSlides/notesSlide8.xml><?xml version="1.0" encoding="utf-8"?>
+<p:notes xmlns:a="http://schemas.openxmlformats.org/drawingml/2006/main" xmlns:r="http://schemas.openxmlformats.org/officeDocument/2006/relationships" xmlns:p="http://schemas.openxmlformats.org/presentationml/2006/main">
+  <p:cSld>
+    <p:spTree>
+      <p:nvGrpSpPr>
+        <p:cNvPr id="1" name=""/>
+        <p:cNvGrpSpPr/>
+        <p:nvPr/>
+      </p:nvGrpSpPr>
+      <p:grpSpPr>
+        <a:xfrm>
+          <a:off x="0" y="0"/>
+          <a:ext cx="0" cy="0"/>
+          <a:chOff x="0" y="0"/>
+          <a:chExt cx="0" cy="0"/>
+        </a:xfrm>
+      </p:grpSpPr>
+      <p:sp>
+        <p:nvSpPr>
+          <p:cNvPr id="2" name="Slide Image Placeholder 1"/>
+          <p:cNvSpPr>
+            <a:spLocks noGrp="1" noRot="1" noChangeAspect="1"/>
+          </p:cNvSpPr>
+          <p:nvPr>
+            <p:ph type="sldImg"/>
+          </p:nvPr>
+        </p:nvSpPr>
+        <p:spPr/>
+      </p:sp>
+      <p:sp>
+        <p:nvSpPr>
+          <p:cNvPr id="3" name="Notes Placeholder 2"/>
+          <p:cNvSpPr>
+            <a:spLocks noGrp="1"/>
+          </p:cNvSpPr>
+          <p:nvPr>
+            <p:ph type="body" idx="1"/>
+          </p:nvPr>
+        </p:nvSpPr>
+        <p:spPr/>
+        <p:txBody>
+          <a:bodyPr/>
+          <a:lstStyle/>
+          <a:p>
+            <a:r>
+              <a:rPr lang="en-US" dirty="0"/>
+              <a:t>What are we handing over? An on-chip checker this track did not have. Full ground truth at two shapes. And measured evidence of what a small-model loop needs: tell it what the chip measured, not what to think. We do not beat your compiler, and for matmul nobody needs to. The next step is to point KernelTune at the kernels people do write by hand, where there is no compiler version to fall back on.</a:t>
+            </a:r>
+            <a:endParaRPr lang="en-US" dirty="0"/>
+          </a:p>
+        </p:txBody>
+      </p:sp>
+      <p:sp>
+        <p:nvSpPr>
+          <p:cNvPr id="4" name="Slide Number Placeholder 3"/>
+          <p:cNvSpPr>
+            <a:spLocks noGrp="1"/>
+          </p:cNvSpPr>
+          <p:nvPr>
+            <p:ph type="sldNum" sz="quarter" idx="10"/>
+          </p:nvPr>
+        </p:nvSpPr>
+        <p:spPr/>
+        <p:txBody>
+          <a:bodyPr/>
+          <a:lstStyle/>
+          <a:p>
+            <a:fld id="{F7021451-1387-4CA6-816F-3879F97B5CBC}" type="slidenum">
+              <a:rPr lang="en-US"/>
+              <a:t>8</a:t>
             </a:fld>
             <a:endParaRPr lang="en-US"/>
           </a:p>
@@ -1930,6 +2020,122 @@
 </p:sldLayout>
 </file>
 
+<file path=ppt/slideLayouts/slideLayout4.xml><?xml version="1.0" encoding="utf-8"?>
+<p:sldLayout xmlns:a="http://schemas.openxmlformats.org/drawingml/2006/main" xmlns:r="http://schemas.openxmlformats.org/officeDocument/2006/relationships" xmlns:p="http://schemas.openxmlformats.org/presentationml/2006/main" preserve="1">
+  <p:cSld name="FULL_IMAGE">
+    <p:bg>
+      <p:bgPr>
+        <a:solidFill>
+          <a:srgbClr val="FFFFFF"/>
+        </a:solidFill>
+      </p:bgPr>
+    </p:bg>
+    <p:spTree>
+      <p:nvGrpSpPr>
+        <p:cNvPr id="1" name=""/>
+        <p:cNvGrpSpPr/>
+        <p:nvPr/>
+      </p:nvGrpSpPr>
+      <p:grpSpPr>
+        <a:xfrm>
+          <a:off x="0" y="0"/>
+          <a:ext cx="0" cy="0"/>
+          <a:chOff x="0" y="0"/>
+          <a:chExt cx="0" cy="0"/>
+        </a:xfrm>
+      </p:grpSpPr>
+      <p:sp>
+        <p:nvSpPr>
+          <p:cNvPr id="2" name="Text 0"/>
+          <p:cNvSpPr/>
+          <p:nvPr>
+            <p:ph idx="100" type="title" hasCustomPrompt="1"/>
+          </p:nvPr>
+        </p:nvSpPr>
+        <p:spPr>
+          <a:xfrm>
+            <a:off x="548640" y="182880"/>
+            <a:ext cx="11064240" cy="502920"/>
+          </a:xfrm>
+          <a:prstGeom prst="rect">
+            <a:avLst/>
+          </a:prstGeom>
+          <a:noFill/>
+          <a:ln/>
+        </p:spPr>
+        <p:txBody>
+          <a:bodyPr wrap="square" rtlCol="0"/>
+          <a:lstStyle>
+            <a:lvl1pPr algn="l" indent="0" marL="0">
+              <a:buNone/>
+              <a:defRPr lang="en-US" sz="2400" b="1" dirty="0">
+                <a:solidFill>
+                  <a:schemeClr val="tx1"/>
+                </a:solidFill>
+              </a:defRPr>
+            </a:lvl1pPr>
+          </a:lstStyle>
+          <a:p>
+            <a:pPr algn="l" indent="0" marL="0">
+              <a:buNone/>
+            </a:pPr>
+            <a:endParaRPr lang="en-US" sz="2400" dirty="0"/>
+          </a:p>
+        </p:txBody>
+      </p:sp>
+      <p:sp>
+        <p:nvSpPr>
+          <p:cNvPr id="25" name="Slide Number Placeholder 0"/>
+          <p:cNvSpPr>
+            <a:spLocks noGrp="1"/>
+          </p:cNvSpPr>
+          <p:nvPr>
+            <p:ph type="sldNum" sz="quarter" idx="4294967295"/>
+          </p:nvPr>
+        </p:nvSpPr>
+        <p:spPr>
+          <a:xfrm>
+            <a:off x="11155680" y="6492240"/>
+            <a:ext cx="457200" cy="274320"/>
+          </a:xfrm>
+          <a:prstGeom prst="rect">
+            <a:avLst/>
+          </a:prstGeom>
+          <a:extLst>
+            <a:ext uri="{C572A759-6A51-4108-AA02-DFA0A04FC94B}">
+              <ma14:wrappingTextBoxFlag xmlns:ma14="http://schemas.microsoft.com/office/mac/drawingml/2011/main" val="0"/>
+            </a:ext>
+          </a:extLst>
+        </p:spPr>
+        <p:txBody>
+          <a:bodyPr/>
+          <a:lstStyle>
+            <a:lvl1pPr>
+              <a:defRPr sz="1000">
+                <a:solidFill>
+                  <a:srgbClr val="5B6B7A"/>
+                </a:solidFill>
+              </a:defRPr>
+            </a:lvl1pPr>
+          </a:lstStyle>
+          <a:p>
+            <a:pPr algn="r"/>
+            <a:fld id="{F7021451-1387-4CA6-816F-3879F97B5CBC}" type="slidenum">
+              <a:rPr b="0" lang="en-US"/>
+              <a:t>1004</a:t>
+            </a:fld>
+            <a:endParaRPr lang="en-US"/>
+          </a:p>
+        </p:txBody>
+      </p:sp>
+    </p:spTree>
+  </p:cSld>
+  <p:clrMapOvr>
+    <a:masterClrMapping/>
+  </p:clrMapOvr>
+</p:sldLayout>
+</file>
+
 <file path=ppt/slideMasters/slideMaster1.xml><?xml version="1.0" encoding="utf-8"?>
 <p:sldMaster xmlns:a="http://schemas.openxmlformats.org/drawingml/2006/main" xmlns:r="http://schemas.openxmlformats.org/officeDocument/2006/relationships" xmlns:p="http://schemas.openxmlformats.org/presentationml/2006/main">
   <p:cSld>
@@ -1999,6 +2205,7 @@
     <p:sldLayoutId id="2147483649" r:id="rId1"/>
     <p:sldLayoutId id="2147483650" r:id="rId2"/>
     <p:sldLayoutId id="2147483651" r:id="rId3"/>
+    <p:sldLayoutId id="2147483652" r:id="rId4"/>
   </p:sldLayoutIdLst>
   <p:hf sldNum="0" hdr="0" ftr="0" dt="0"/>
   <p:txStyles>
@@ -2924,7 +3131,7 @@
                   <a:schemeClr val="tx1"/>
                 </a:solidFill>
               </a:rPr>
-              <a:t>Architecture: a loop in which the chip is the judge</a:t>
+              <a:t>How it works: a loop in which the chip is the judge</a:t>
             </a:r>
             <a:endParaRPr lang="en-US" sz="3600" dirty="0"/>
           </a:p>
@@ -3722,8 +3929,8 @@
         </p:nvSpPr>
         <p:spPr>
           <a:xfrm>
-            <a:off x="548640" y="411480"/>
-            <a:ext cx="11064240" cy="822960"/>
+            <a:off x="548640" y="182880"/>
+            <a:ext cx="11064240" cy="502920"/>
           </a:xfrm>
           <a:prstGeom prst="rect">
             <a:avLst/>
@@ -3739,1408 +3946,41 @@
               <a:buNone/>
             </a:pPr>
             <a:r>
-              <a:rPr lang="en-US" sz="3600" b="1" dirty="0">
+              <a:rPr lang="en-US" sz="2400" b="1" dirty="0">
                 <a:solidFill>
                   <a:schemeClr val="tx1"/>
                 </a:solidFill>
               </a:rPr>
-              <a:t>What we tried: five checker designs, one model</a:t>
-            </a:r>
-            <a:endParaRPr lang="en-US" sz="3600" dirty="0"/>
-          </a:p>
-        </p:txBody>
-      </p:sp>
-      <p:sp>
-        <p:nvSpPr>
-          <p:cNvPr id="3" name="Design card v1"/>
-          <p:cNvSpPr/>
-          <p:nvPr/>
-        </p:nvSpPr>
-        <p:spPr>
-          <a:xfrm>
-            <a:off x="548640" y="1463040"/>
-            <a:ext cx="2084832" cy="3520440"/>
-          </a:xfrm>
-          <a:prstGeom prst="roundRect">
-            <a:avLst>
-              <a:gd name="adj" fmla="val 3509"/>
-            </a:avLst>
-          </a:prstGeom>
-          <a:solidFill>
-            <a:schemeClr val="bg2"/>
-          </a:solidFill>
-          <a:ln w="12700">
-            <a:solidFill>
-              <a:schemeClr val="bg2"/>
-            </a:solidFill>
-            <a:prstDash val="solid"/>
-          </a:ln>
-        </p:spPr>
-      </p:sp>
-      <p:sp>
-        <p:nvSpPr>
-          <p:cNvPr id="4" name="Badge v1"/>
-          <p:cNvSpPr/>
-          <p:nvPr/>
-        </p:nvSpPr>
-        <p:spPr>
-          <a:xfrm>
-            <a:off x="731520" y="1645920"/>
-            <a:ext cx="640080" cy="640080"/>
-          </a:xfrm>
-          <a:prstGeom prst="ellipse">
-            <a:avLst/>
-          </a:prstGeom>
-          <a:solidFill>
-            <a:schemeClr val="accent4"/>
-          </a:solidFill>
-          <a:ln w="12700">
-            <a:solidFill>
-              <a:schemeClr val="accent4"/>
-            </a:solidFill>
-            <a:prstDash val="solid"/>
-          </a:ln>
-        </p:spPr>
-      </p:sp>
-      <p:sp>
-        <p:nvSpPr>
-          <p:cNvPr id="5" name="Badge text v1"/>
-          <p:cNvSpPr txBox="1"/>
-          <p:nvPr/>
-        </p:nvSpPr>
-        <p:spPr>
-          <a:xfrm>
-            <a:off x="731520" y="1645920"/>
-            <a:ext cx="640080" cy="640080"/>
-          </a:xfrm>
-          <a:prstGeom prst="rect">
-            <a:avLst/>
-          </a:prstGeom>
-          <a:noFill/>
-          <a:ln/>
-        </p:spPr>
-        <p:txBody>
-          <a:bodyPr wrap="square" lIns="0" tIns="0" rIns="0" bIns="0" rtlCol="0" anchor="ctr"/>
-          <a:lstStyle/>
-          <a:p>
-            <a:pPr algn="ctr" indent="0" marL="0">
-              <a:buNone/>
-            </a:pPr>
-            <a:r>
-              <a:rPr lang="en-US" sz="1800" b="1" dirty="0">
-                <a:solidFill>
-                  <a:schemeClr val="bg1"/>
-                </a:solidFill>
-              </a:rPr>
-              <a:t>v1</a:t>
-            </a:r>
-            <a:endParaRPr lang="en-US" sz="1800" dirty="0"/>
-          </a:p>
-        </p:txBody>
-      </p:sp>
-      <p:sp>
-        <p:nvSpPr>
-          <p:cNvPr id="6" name="Shown v1"/>
-          <p:cNvSpPr txBox="1"/>
-          <p:nvPr/>
-        </p:nvSpPr>
-        <p:spPr>
-          <a:xfrm>
-            <a:off x="731520" y="2423160"/>
-            <a:ext cx="1737360" cy="914400"/>
-          </a:xfrm>
-          <a:prstGeom prst="rect">
-            <a:avLst/>
-          </a:prstGeom>
-          <a:noFill/>
-          <a:ln/>
-        </p:spPr>
-        <p:txBody>
-          <a:bodyPr wrap="square" lIns="0" tIns="0" rIns="0" bIns="0" rtlCol="0" anchor="t"/>
-          <a:lstStyle/>
-          <a:p>
-            <a:pPr indent="0" marL="0">
-              <a:buNone/>
-            </a:pPr>
-            <a:r>
-              <a:rPr lang="en-US" sz="1500" b="1" dirty="0">
-                <a:solidFill>
-                  <a:schemeClr val="tx1"/>
-                </a:solidFill>
-              </a:rPr>
-              <a:t>Raw profile numbers</a:t>
-            </a:r>
-            <a:endParaRPr lang="en-US" sz="1500" dirty="0"/>
-          </a:p>
-        </p:txBody>
-      </p:sp>
-      <p:sp>
-        <p:nvSpPr>
-          <p:cNvPr id="7" name="Time v1"/>
-          <p:cNvSpPr txBox="1"/>
-          <p:nvPr/>
-        </p:nvSpPr>
-        <p:spPr>
-          <a:xfrm>
-            <a:off x="731520" y="3383280"/>
-            <a:ext cx="1737360" cy="457200"/>
-          </a:xfrm>
-          <a:prstGeom prst="rect">
-            <a:avLst/>
-          </a:prstGeom>
-          <a:noFill/>
-          <a:ln/>
-        </p:spPr>
-        <p:txBody>
-          <a:bodyPr wrap="square" lIns="0" tIns="0" rIns="0" bIns="0" rtlCol="0" anchor="t"/>
-          <a:lstStyle/>
-          <a:p>
-            <a:pPr indent="0" marL="0">
-              <a:buNone/>
-            </a:pPr>
-            <a:r>
-              <a:rPr lang="en-US" sz="2400" b="1" dirty="0">
-                <a:solidFill>
-                  <a:schemeClr val="accent4"/>
-                </a:solidFill>
-                <a:latin typeface="Cambria" pitchFamily="34" charset="0"/>
-                <a:ea typeface="Cambria" pitchFamily="34" charset="-122"/>
-                <a:cs typeface="Cambria" pitchFamily="34" charset="-120"/>
-              </a:rPr>
-              <a:t>2,285 µs</a:t>
+              <a:t>Architecture: the tuning loop, the side measurements, and what we built on</a:t>
             </a:r>
             <a:endParaRPr lang="en-US" sz="2400" dirty="0"/>
           </a:p>
         </p:txBody>
       </p:sp>
-      <p:sp>
-        <p:nvSpPr>
-          <p:cNvPr id="8" name="Time label v1"/>
-          <p:cNvSpPr txBox="1"/>
-          <p:nvPr/>
-        </p:nvSpPr>
-        <p:spPr>
-          <a:xfrm>
-            <a:off x="731520" y="3822192"/>
-            <a:ext cx="1737360" cy="274320"/>
-          </a:xfrm>
-          <a:prstGeom prst="rect">
-            <a:avLst/>
-          </a:prstGeom>
-          <a:noFill/>
-          <a:ln/>
-        </p:spPr>
-        <p:txBody>
-          <a:bodyPr wrap="square" lIns="0" tIns="0" rIns="0" bIns="0" rtlCol="0" anchor="t"/>
-          <a:lstStyle/>
-          <a:p>
-            <a:pPr indent="0" marL="0">
-              <a:buNone/>
-            </a:pPr>
-            <a:r>
-              <a:rPr lang="en-US" sz="1100" dirty="0">
-                <a:solidFill>
-                  <a:schemeClr val="tx2"/>
-                </a:solidFill>
-              </a:rPr>
-              <a:t>median final time</a:t>
-            </a:r>
-            <a:endParaRPr lang="en-US" sz="1100" dirty="0"/>
-          </a:p>
-        </p:txBody>
-      </p:sp>
-      <p:sp>
-        <p:nvSpPr>
-          <p:cNvPr id="9" name="Wasted v1"/>
-          <p:cNvSpPr txBox="1"/>
-          <p:nvPr/>
-        </p:nvSpPr>
-        <p:spPr>
-          <a:xfrm>
-            <a:off x="731520" y="4160520"/>
-            <a:ext cx="1737360" cy="365760"/>
-          </a:xfrm>
-          <a:prstGeom prst="rect">
-            <a:avLst/>
-          </a:prstGeom>
-          <a:noFill/>
-          <a:ln/>
-        </p:spPr>
-        <p:txBody>
-          <a:bodyPr wrap="square" lIns="0" tIns="0" rIns="0" bIns="0" rtlCol="0" anchor="t"/>
-          <a:lstStyle/>
-          <a:p>
-            <a:pPr indent="0" marL="0">
-              <a:buNone/>
-            </a:pPr>
-            <a:r>
-              <a:rPr lang="en-US" sz="1800" b="1" dirty="0">
-                <a:solidFill>
-                  <a:schemeClr val="tx1"/>
-                </a:solidFill>
-              </a:rPr>
-              <a:t>66 of 100</a:t>
-            </a:r>
-            <a:endParaRPr lang="en-US" sz="1800" dirty="0"/>
-          </a:p>
-        </p:txBody>
-      </p:sp>
-      <p:sp>
-        <p:nvSpPr>
-          <p:cNvPr id="10" name="Wasted label v1"/>
-          <p:cNvSpPr txBox="1"/>
-          <p:nvPr/>
-        </p:nvSpPr>
-        <p:spPr>
-          <a:xfrm>
-            <a:off x="731520" y="4526280"/>
-            <a:ext cx="1737360" cy="365760"/>
-          </a:xfrm>
-          <a:prstGeom prst="rect">
-            <a:avLst/>
-          </a:prstGeom>
-          <a:noFill/>
-          <a:ln/>
-        </p:spPr>
-        <p:txBody>
-          <a:bodyPr wrap="square" lIns="0" tIns="0" rIns="0" bIns="0" rtlCol="0" anchor="t"/>
-          <a:lstStyle/>
-          <a:p>
-            <a:pPr indent="0" marL="0">
-              <a:buNone/>
-            </a:pPr>
-            <a:r>
-              <a:rPr lang="en-US" sz="1100" dirty="0">
-                <a:solidFill>
-                  <a:schemeClr val="tx2"/>
-                </a:solidFill>
-              </a:rPr>
-              <a:t>attempts with no measurement</a:t>
-            </a:r>
-            <a:endParaRPr lang="en-US" sz="1100" dirty="0"/>
-          </a:p>
-        </p:txBody>
-      </p:sp>
-      <p:sp>
-        <p:nvSpPr>
-          <p:cNvPr id="11" name="Design card v2"/>
-          <p:cNvSpPr/>
-          <p:nvPr/>
-        </p:nvSpPr>
-        <p:spPr>
-          <a:xfrm>
-            <a:off x="2779776" y="1463040"/>
-            <a:ext cx="2084832" cy="3520440"/>
-          </a:xfrm>
-          <a:prstGeom prst="roundRect">
-            <a:avLst>
-              <a:gd name="adj" fmla="val 3509"/>
-            </a:avLst>
-          </a:prstGeom>
-          <a:solidFill>
-            <a:schemeClr val="bg2"/>
-          </a:solidFill>
-          <a:ln w="12700">
-            <a:solidFill>
-              <a:schemeClr val="bg2"/>
-            </a:solidFill>
-            <a:prstDash val="solid"/>
-          </a:ln>
-        </p:spPr>
-      </p:sp>
-      <p:sp>
-        <p:nvSpPr>
-          <p:cNvPr id="12" name="Badge v2"/>
-          <p:cNvSpPr/>
-          <p:nvPr/>
-        </p:nvSpPr>
-        <p:spPr>
-          <a:xfrm>
-            <a:off x="2962656" y="1645920"/>
-            <a:ext cx="640080" cy="640080"/>
-          </a:xfrm>
-          <a:prstGeom prst="ellipse">
-            <a:avLst/>
-          </a:prstGeom>
-          <a:solidFill>
-            <a:schemeClr val="accent2"/>
-          </a:solidFill>
-          <a:ln w="12700">
-            <a:solidFill>
-              <a:schemeClr val="accent2"/>
-            </a:solidFill>
-            <a:prstDash val="solid"/>
-          </a:ln>
-        </p:spPr>
-      </p:sp>
-      <p:sp>
-        <p:nvSpPr>
-          <p:cNvPr id="13" name="Badge text v2"/>
-          <p:cNvSpPr txBox="1"/>
-          <p:nvPr/>
-        </p:nvSpPr>
-        <p:spPr>
-          <a:xfrm>
-            <a:off x="2962656" y="1645920"/>
-            <a:ext cx="640080" cy="640080"/>
-          </a:xfrm>
-          <a:prstGeom prst="rect">
-            <a:avLst/>
-          </a:prstGeom>
-          <a:noFill/>
-          <a:ln/>
-        </p:spPr>
-        <p:txBody>
-          <a:bodyPr wrap="square" lIns="0" tIns="0" rIns="0" bIns="0" rtlCol="0" anchor="ctr"/>
-          <a:lstStyle/>
-          <a:p>
-            <a:pPr algn="ctr" indent="0" marL="0">
-              <a:buNone/>
-            </a:pPr>
-            <a:r>
-              <a:rPr lang="en-US" sz="1800" b="1" dirty="0">
-                <a:solidFill>
-                  <a:schemeClr val="bg1"/>
-                </a:solidFill>
-              </a:rPr>
-              <a:t>v2</a:t>
-            </a:r>
-            <a:endParaRPr lang="en-US" sz="1800" dirty="0"/>
-          </a:p>
-        </p:txBody>
-      </p:sp>
-      <p:sp>
-        <p:nvSpPr>
-          <p:cNvPr id="14" name="Shown v2"/>
-          <p:cNvSpPr txBox="1"/>
-          <p:nvPr/>
-        </p:nvSpPr>
-        <p:spPr>
-          <a:xfrm>
-            <a:off x="2962656" y="2423160"/>
-            <a:ext cx="1737360" cy="914400"/>
-          </a:xfrm>
-          <a:prstGeom prst="rect">
-            <a:avLst/>
-          </a:prstGeom>
-          <a:noFill/>
-          <a:ln/>
-        </p:spPr>
-        <p:txBody>
-          <a:bodyPr wrap="square" lIns="0" tIns="0" rIns="0" bIns="0" rtlCol="0" anchor="t"/>
-          <a:lstStyle/>
-          <a:p>
-            <a:pPr indent="0" marL="0">
-              <a:buNone/>
-            </a:pPr>
-            <a:r>
-              <a:rPr lang="en-US" sz="1500" b="1" dirty="0">
-                <a:solidFill>
-                  <a:schemeClr val="tx1"/>
-                </a:solidFill>
-              </a:rPr>
-              <a:t>Comparisons worked out in code</a:t>
-            </a:r>
-            <a:endParaRPr lang="en-US" sz="1500" dirty="0"/>
-          </a:p>
-        </p:txBody>
-      </p:sp>
-      <p:sp>
-        <p:nvSpPr>
-          <p:cNvPr id="15" name="Time v2"/>
-          <p:cNvSpPr txBox="1"/>
-          <p:nvPr/>
-        </p:nvSpPr>
-        <p:spPr>
-          <a:xfrm>
-            <a:off x="2962656" y="3383280"/>
-            <a:ext cx="1737360" cy="457200"/>
-          </a:xfrm>
-          <a:prstGeom prst="rect">
-            <a:avLst/>
-          </a:prstGeom>
-          <a:noFill/>
-          <a:ln/>
-        </p:spPr>
-        <p:txBody>
-          <a:bodyPr wrap="square" lIns="0" tIns="0" rIns="0" bIns="0" rtlCol="0" anchor="t"/>
-          <a:lstStyle/>
-          <a:p>
-            <a:pPr indent="0" marL="0">
-              <a:buNone/>
-            </a:pPr>
-            <a:r>
-              <a:rPr lang="en-US" sz="2400" b="1" dirty="0">
-                <a:solidFill>
-                  <a:schemeClr val="accent2"/>
-                </a:solidFill>
-                <a:latin typeface="Cambria" pitchFamily="34" charset="0"/>
-                <a:ea typeface="Cambria" pitchFamily="34" charset="-122"/>
-                <a:cs typeface="Cambria" pitchFamily="34" charset="-120"/>
-              </a:rPr>
-              <a:t>1,553 µs</a:t>
-            </a:r>
-            <a:endParaRPr lang="en-US" sz="2400" dirty="0"/>
-          </a:p>
-        </p:txBody>
-      </p:sp>
-      <p:sp>
-        <p:nvSpPr>
-          <p:cNvPr id="16" name="Time label v2"/>
-          <p:cNvSpPr txBox="1"/>
-          <p:nvPr/>
-        </p:nvSpPr>
-        <p:spPr>
-          <a:xfrm>
-            <a:off x="2962656" y="3822192"/>
-            <a:ext cx="1737360" cy="274320"/>
-          </a:xfrm>
-          <a:prstGeom prst="rect">
-            <a:avLst/>
-          </a:prstGeom>
-          <a:noFill/>
-          <a:ln/>
-        </p:spPr>
-        <p:txBody>
-          <a:bodyPr wrap="square" lIns="0" tIns="0" rIns="0" bIns="0" rtlCol="0" anchor="t"/>
-          <a:lstStyle/>
-          <a:p>
-            <a:pPr indent="0" marL="0">
-              <a:buNone/>
-            </a:pPr>
-            <a:r>
-              <a:rPr lang="en-US" sz="1100" dirty="0">
-                <a:solidFill>
-                  <a:schemeClr val="tx2"/>
-                </a:solidFill>
-              </a:rPr>
-              <a:t>median final time</a:t>
-            </a:r>
-            <a:endParaRPr lang="en-US" sz="1100" dirty="0"/>
-          </a:p>
-        </p:txBody>
-      </p:sp>
-      <p:sp>
-        <p:nvSpPr>
-          <p:cNvPr id="17" name="Wasted v2"/>
-          <p:cNvSpPr txBox="1"/>
-          <p:nvPr/>
-        </p:nvSpPr>
-        <p:spPr>
-          <a:xfrm>
-            <a:off x="2962656" y="4160520"/>
-            <a:ext cx="1737360" cy="365760"/>
-          </a:xfrm>
-          <a:prstGeom prst="rect">
-            <a:avLst/>
-          </a:prstGeom>
-          <a:noFill/>
-          <a:ln/>
-        </p:spPr>
-        <p:txBody>
-          <a:bodyPr wrap="square" lIns="0" tIns="0" rIns="0" bIns="0" rtlCol="0" anchor="t"/>
-          <a:lstStyle/>
-          <a:p>
-            <a:pPr indent="0" marL="0">
-              <a:buNone/>
-            </a:pPr>
-            <a:r>
-              <a:rPr lang="en-US" sz="1800" b="1" dirty="0">
-                <a:solidFill>
-                  <a:schemeClr val="tx1"/>
-                </a:solidFill>
-              </a:rPr>
-              <a:t>70 of 100</a:t>
-            </a:r>
-            <a:endParaRPr lang="en-US" sz="1800" dirty="0"/>
-          </a:p>
-        </p:txBody>
-      </p:sp>
-      <p:sp>
-        <p:nvSpPr>
-          <p:cNvPr id="18" name="Wasted label v2"/>
-          <p:cNvSpPr txBox="1"/>
-          <p:nvPr/>
-        </p:nvSpPr>
-        <p:spPr>
-          <a:xfrm>
-            <a:off x="2962656" y="4526280"/>
-            <a:ext cx="1737360" cy="365760"/>
-          </a:xfrm>
-          <a:prstGeom prst="rect">
-            <a:avLst/>
-          </a:prstGeom>
-          <a:noFill/>
-          <a:ln/>
-        </p:spPr>
-        <p:txBody>
-          <a:bodyPr wrap="square" lIns="0" tIns="0" rIns="0" bIns="0" rtlCol="0" anchor="t"/>
-          <a:lstStyle/>
-          <a:p>
-            <a:pPr indent="0" marL="0">
-              <a:buNone/>
-            </a:pPr>
-            <a:r>
-              <a:rPr lang="en-US" sz="1100" dirty="0">
-                <a:solidFill>
-                  <a:schemeClr val="tx2"/>
-                </a:solidFill>
-              </a:rPr>
-              <a:t>attempts with no measurement</a:t>
-            </a:r>
-            <a:endParaRPr lang="en-US" sz="1100" dirty="0"/>
-          </a:p>
-        </p:txBody>
-      </p:sp>
-      <p:sp>
-        <p:nvSpPr>
-          <p:cNvPr id="19" name="Design card v3"/>
-          <p:cNvSpPr/>
-          <p:nvPr/>
-        </p:nvSpPr>
-        <p:spPr>
-          <a:xfrm>
-            <a:off x="5010912" y="1463040"/>
-            <a:ext cx="2084832" cy="3520440"/>
-          </a:xfrm>
-          <a:prstGeom prst="roundRect">
-            <a:avLst>
-              <a:gd name="adj" fmla="val 3509"/>
-            </a:avLst>
-          </a:prstGeom>
-          <a:solidFill>
-            <a:schemeClr val="bg2"/>
-          </a:solidFill>
-          <a:ln w="12700">
-            <a:solidFill>
-              <a:schemeClr val="bg2"/>
-            </a:solidFill>
-            <a:prstDash val="solid"/>
-          </a:ln>
-        </p:spPr>
-      </p:sp>
-      <p:sp>
-        <p:nvSpPr>
-          <p:cNvPr id="20" name="Badge v3"/>
-          <p:cNvSpPr/>
-          <p:nvPr/>
-        </p:nvSpPr>
-        <p:spPr>
-          <a:xfrm>
-            <a:off x="5193792" y="1645920"/>
-            <a:ext cx="640080" cy="640080"/>
-          </a:xfrm>
-          <a:prstGeom prst="ellipse">
-            <a:avLst/>
-          </a:prstGeom>
-          <a:solidFill>
-            <a:schemeClr val="accent3"/>
-          </a:solidFill>
-          <a:ln w="12700">
-            <a:solidFill>
-              <a:schemeClr val="accent3"/>
-            </a:solidFill>
-            <a:prstDash val="solid"/>
-          </a:ln>
-        </p:spPr>
-      </p:sp>
-      <p:sp>
-        <p:nvSpPr>
-          <p:cNvPr id="21" name="Badge text v3"/>
-          <p:cNvSpPr txBox="1"/>
-          <p:nvPr/>
-        </p:nvSpPr>
-        <p:spPr>
-          <a:xfrm>
-            <a:off x="5193792" y="1645920"/>
-            <a:ext cx="640080" cy="640080"/>
-          </a:xfrm>
-          <a:prstGeom prst="rect">
-            <a:avLst/>
-          </a:prstGeom>
-          <a:noFill/>
-          <a:ln/>
-        </p:spPr>
-        <p:txBody>
-          <a:bodyPr wrap="square" lIns="0" tIns="0" rIns="0" bIns="0" rtlCol="0" anchor="ctr"/>
-          <a:lstStyle/>
-          <a:p>
-            <a:pPr algn="ctr" indent="0" marL="0">
-              <a:buNone/>
-            </a:pPr>
-            <a:r>
-              <a:rPr lang="en-US" sz="1800" b="1" dirty="0">
-                <a:solidFill>
-                  <a:schemeClr val="bg1"/>
-                </a:solidFill>
-              </a:rPr>
-              <a:t>v3</a:t>
-            </a:r>
-            <a:endParaRPr lang="en-US" sz="1800" dirty="0"/>
-          </a:p>
-        </p:txBody>
-      </p:sp>
-      <p:sp>
-        <p:nvSpPr>
-          <p:cNvPr id="22" name="Shown v3"/>
-          <p:cNvSpPr txBox="1"/>
-          <p:nvPr/>
-        </p:nvSpPr>
-        <p:spPr>
-          <a:xfrm>
-            <a:off x="5193792" y="2423160"/>
-            <a:ext cx="1737360" cy="914400"/>
-          </a:xfrm>
-          <a:prstGeom prst="rect">
-            <a:avLst/>
-          </a:prstGeom>
-          <a:noFill/>
-          <a:ln/>
-        </p:spPr>
-        <p:txBody>
-          <a:bodyPr wrap="square" lIns="0" tIns="0" rIns="0" bIns="0" rtlCol="0" anchor="t"/>
-          <a:lstStyle/>
-          <a:p>
-            <a:pPr indent="0" marL="0">
-              <a:buNone/>
-            </a:pPr>
-            <a:r>
-              <a:rPr lang="en-US" sz="1500" b="1" dirty="0">
-                <a:solidFill>
-                  <a:schemeClr val="tx1"/>
-                </a:solidFill>
-              </a:rPr>
-              <a:t>A menu of measured moves</a:t>
-            </a:r>
-            <a:endParaRPr lang="en-US" sz="1500" dirty="0"/>
-          </a:p>
-        </p:txBody>
-      </p:sp>
-      <p:sp>
-        <p:nvSpPr>
-          <p:cNvPr id="23" name="Time v3"/>
-          <p:cNvSpPr txBox="1"/>
-          <p:nvPr/>
-        </p:nvSpPr>
-        <p:spPr>
-          <a:xfrm>
-            <a:off x="5193792" y="3383280"/>
-            <a:ext cx="1737360" cy="457200"/>
-          </a:xfrm>
-          <a:prstGeom prst="rect">
-            <a:avLst/>
-          </a:prstGeom>
-          <a:noFill/>
-          <a:ln/>
-        </p:spPr>
-        <p:txBody>
-          <a:bodyPr wrap="square" lIns="0" tIns="0" rIns="0" bIns="0" rtlCol="0" anchor="t"/>
-          <a:lstStyle/>
-          <a:p>
-            <a:pPr indent="0" marL="0">
-              <a:buNone/>
-            </a:pPr>
-            <a:r>
-              <a:rPr lang="en-US" sz="2400" b="1" dirty="0">
-                <a:solidFill>
-                  <a:schemeClr val="accent3"/>
-                </a:solidFill>
-                <a:latin typeface="Cambria" pitchFamily="34" charset="0"/>
-                <a:ea typeface="Cambria" pitchFamily="34" charset="-122"/>
-                <a:cs typeface="Cambria" pitchFamily="34" charset="-120"/>
-              </a:rPr>
-              <a:t>1,492 µs</a:t>
-            </a:r>
-            <a:endParaRPr lang="en-US" sz="2400" dirty="0"/>
-          </a:p>
-        </p:txBody>
-      </p:sp>
-      <p:sp>
-        <p:nvSpPr>
-          <p:cNvPr id="24" name="Time label v3"/>
-          <p:cNvSpPr txBox="1"/>
-          <p:nvPr/>
-        </p:nvSpPr>
-        <p:spPr>
-          <a:xfrm>
-            <a:off x="5193792" y="3822192"/>
-            <a:ext cx="1737360" cy="274320"/>
-          </a:xfrm>
-          <a:prstGeom prst="rect">
-            <a:avLst/>
-          </a:prstGeom>
-          <a:noFill/>
-          <a:ln/>
-        </p:spPr>
-        <p:txBody>
-          <a:bodyPr wrap="square" lIns="0" tIns="0" rIns="0" bIns="0" rtlCol="0" anchor="t"/>
-          <a:lstStyle/>
-          <a:p>
-            <a:pPr indent="0" marL="0">
-              <a:buNone/>
-            </a:pPr>
-            <a:r>
-              <a:rPr lang="en-US" sz="1100" dirty="0">
-                <a:solidFill>
-                  <a:schemeClr val="tx2"/>
-                </a:solidFill>
-              </a:rPr>
-              <a:t>median final time</a:t>
-            </a:r>
-            <a:endParaRPr lang="en-US" sz="1100" dirty="0"/>
-          </a:p>
-        </p:txBody>
-      </p:sp>
-      <p:sp>
-        <p:nvSpPr>
-          <p:cNvPr id="25" name="Wasted v3"/>
-          <p:cNvSpPr txBox="1"/>
-          <p:nvPr/>
-        </p:nvSpPr>
-        <p:spPr>
-          <a:xfrm>
-            <a:off x="5193792" y="4160520"/>
-            <a:ext cx="1737360" cy="365760"/>
-          </a:xfrm>
-          <a:prstGeom prst="rect">
-            <a:avLst/>
-          </a:prstGeom>
-          <a:noFill/>
-          <a:ln/>
-        </p:spPr>
-        <p:txBody>
-          <a:bodyPr wrap="square" lIns="0" tIns="0" rIns="0" bIns="0" rtlCol="0" anchor="t"/>
-          <a:lstStyle/>
-          <a:p>
-            <a:pPr indent="0" marL="0">
-              <a:buNone/>
-            </a:pPr>
-            <a:r>
-              <a:rPr lang="en-US" sz="1800" b="1" dirty="0">
-                <a:solidFill>
-                  <a:schemeClr val="tx1"/>
-                </a:solidFill>
-              </a:rPr>
-              <a:t>25 of 100</a:t>
-            </a:r>
-            <a:endParaRPr lang="en-US" sz="1800" dirty="0"/>
-          </a:p>
-        </p:txBody>
-      </p:sp>
-      <p:sp>
-        <p:nvSpPr>
-          <p:cNvPr id="26" name="Wasted label v3"/>
-          <p:cNvSpPr txBox="1"/>
-          <p:nvPr/>
-        </p:nvSpPr>
-        <p:spPr>
-          <a:xfrm>
-            <a:off x="5193792" y="4526280"/>
-            <a:ext cx="1737360" cy="365760"/>
-          </a:xfrm>
-          <a:prstGeom prst="rect">
-            <a:avLst/>
-          </a:prstGeom>
-          <a:noFill/>
-          <a:ln/>
-        </p:spPr>
-        <p:txBody>
-          <a:bodyPr wrap="square" lIns="0" tIns="0" rIns="0" bIns="0" rtlCol="0" anchor="t"/>
-          <a:lstStyle/>
-          <a:p>
-            <a:pPr indent="0" marL="0">
-              <a:buNone/>
-            </a:pPr>
-            <a:r>
-              <a:rPr lang="en-US" sz="1100" dirty="0">
-                <a:solidFill>
-                  <a:schemeClr val="tx2"/>
-                </a:solidFill>
-              </a:rPr>
-              <a:t>attempts with no measurement</a:t>
-            </a:r>
-            <a:endParaRPr lang="en-US" sz="1100" dirty="0"/>
-          </a:p>
-        </p:txBody>
-      </p:sp>
-      <p:sp>
-        <p:nvSpPr>
-          <p:cNvPr id="27" name="Design card v4"/>
-          <p:cNvSpPr/>
-          <p:nvPr/>
-        </p:nvSpPr>
-        <p:spPr>
-          <a:xfrm>
-            <a:off x="7242048" y="1463040"/>
-            <a:ext cx="2084832" cy="3520440"/>
-          </a:xfrm>
-          <a:prstGeom prst="roundRect">
-            <a:avLst>
-              <a:gd name="adj" fmla="val 3509"/>
-            </a:avLst>
-          </a:prstGeom>
-          <a:solidFill>
-            <a:schemeClr val="bg2"/>
-          </a:solidFill>
-          <a:ln w="12700">
-            <a:solidFill>
-              <a:schemeClr val="bg2"/>
-            </a:solidFill>
-            <a:prstDash val="solid"/>
-          </a:ln>
-        </p:spPr>
-      </p:sp>
-      <p:sp>
-        <p:nvSpPr>
-          <p:cNvPr id="28" name="Badge v4"/>
-          <p:cNvSpPr/>
-          <p:nvPr/>
-        </p:nvSpPr>
-        <p:spPr>
-          <a:xfrm>
-            <a:off x="7424928" y="1645920"/>
-            <a:ext cx="640080" cy="640080"/>
-          </a:xfrm>
-          <a:prstGeom prst="ellipse">
-            <a:avLst/>
-          </a:prstGeom>
-          <a:solidFill>
-            <a:schemeClr val="accent1"/>
-          </a:solidFill>
-          <a:ln w="12700">
-            <a:solidFill>
-              <a:schemeClr val="accent1"/>
-            </a:solidFill>
-            <a:prstDash val="solid"/>
-          </a:ln>
-        </p:spPr>
-      </p:sp>
-      <p:sp>
-        <p:nvSpPr>
-          <p:cNvPr id="29" name="Badge text v4"/>
-          <p:cNvSpPr txBox="1"/>
-          <p:nvPr/>
-        </p:nvSpPr>
-        <p:spPr>
-          <a:xfrm>
-            <a:off x="7424928" y="1645920"/>
-            <a:ext cx="640080" cy="640080"/>
-          </a:xfrm>
-          <a:prstGeom prst="rect">
-            <a:avLst/>
-          </a:prstGeom>
-          <a:noFill/>
-          <a:ln/>
-        </p:spPr>
-        <p:txBody>
-          <a:bodyPr wrap="square" lIns="0" tIns="0" rIns="0" bIns="0" rtlCol="0" anchor="ctr"/>
-          <a:lstStyle/>
-          <a:p>
-            <a:pPr algn="ctr" indent="0" marL="0">
-              <a:buNone/>
-            </a:pPr>
-            <a:r>
-              <a:rPr lang="en-US" sz="1800" b="1" dirty="0">
-                <a:solidFill>
-                  <a:schemeClr val="bg1"/>
-                </a:solidFill>
-              </a:rPr>
-              <a:t>v4</a:t>
-            </a:r>
-            <a:endParaRPr lang="en-US" sz="1800" dirty="0"/>
-          </a:p>
-        </p:txBody>
-      </p:sp>
-      <p:sp>
-        <p:nvSpPr>
-          <p:cNvPr id="30" name="Shown v4"/>
-          <p:cNvSpPr txBox="1"/>
-          <p:nvPr/>
-        </p:nvSpPr>
-        <p:spPr>
-          <a:xfrm>
-            <a:off x="7424928" y="2423160"/>
-            <a:ext cx="1737360" cy="914400"/>
-          </a:xfrm>
-          <a:prstGeom prst="rect">
-            <a:avLst/>
-          </a:prstGeom>
-          <a:noFill/>
-          <a:ln/>
-        </p:spPr>
-        <p:txBody>
-          <a:bodyPr wrap="square" lIns="0" tIns="0" rIns="0" bIns="0" rtlCol="0" anchor="t"/>
-          <a:lstStyle/>
-          <a:p>
-            <a:pPr indent="0" marL="0">
-              <a:buNone/>
-            </a:pPr>
-            <a:r>
-              <a:rPr lang="en-US" sz="1500" b="1" dirty="0">
-                <a:solidFill>
-                  <a:schemeClr val="tx1"/>
-                </a:solidFill>
-              </a:rPr>
-              <a:t>v3, and the edit is checked first</a:t>
-            </a:r>
-            <a:endParaRPr lang="en-US" sz="1500" dirty="0"/>
-          </a:p>
-        </p:txBody>
-      </p:sp>
-      <p:sp>
-        <p:nvSpPr>
-          <p:cNvPr id="31" name="Time v4"/>
-          <p:cNvSpPr txBox="1"/>
-          <p:nvPr/>
-        </p:nvSpPr>
-        <p:spPr>
-          <a:xfrm>
-            <a:off x="7424928" y="3383280"/>
-            <a:ext cx="1737360" cy="457200"/>
-          </a:xfrm>
-          <a:prstGeom prst="rect">
-            <a:avLst/>
-          </a:prstGeom>
-          <a:noFill/>
-          <a:ln/>
-        </p:spPr>
-        <p:txBody>
-          <a:bodyPr wrap="square" lIns="0" tIns="0" rIns="0" bIns="0" rtlCol="0" anchor="t"/>
-          <a:lstStyle/>
-          <a:p>
-            <a:pPr indent="0" marL="0">
-              <a:buNone/>
-            </a:pPr>
-            <a:r>
-              <a:rPr lang="en-US" sz="2400" b="1" dirty="0">
-                <a:solidFill>
-                  <a:schemeClr val="accent1"/>
-                </a:solidFill>
-                <a:latin typeface="Cambria" pitchFamily="34" charset="0"/>
-                <a:ea typeface="Cambria" pitchFamily="34" charset="-122"/>
-                <a:cs typeface="Cambria" pitchFamily="34" charset="-120"/>
-              </a:rPr>
-              <a:t>1,495 µs</a:t>
-            </a:r>
-            <a:endParaRPr lang="en-US" sz="2400" dirty="0"/>
-          </a:p>
-        </p:txBody>
-      </p:sp>
-      <p:sp>
-        <p:nvSpPr>
-          <p:cNvPr id="32" name="Time label v4"/>
-          <p:cNvSpPr txBox="1"/>
-          <p:nvPr/>
-        </p:nvSpPr>
-        <p:spPr>
-          <a:xfrm>
-            <a:off x="7424928" y="3822192"/>
-            <a:ext cx="1737360" cy="274320"/>
-          </a:xfrm>
-          <a:prstGeom prst="rect">
-            <a:avLst/>
-          </a:prstGeom>
-          <a:noFill/>
-          <a:ln/>
-        </p:spPr>
-        <p:txBody>
-          <a:bodyPr wrap="square" lIns="0" tIns="0" rIns="0" bIns="0" rtlCol="0" anchor="t"/>
-          <a:lstStyle/>
-          <a:p>
-            <a:pPr indent="0" marL="0">
-              <a:buNone/>
-            </a:pPr>
-            <a:r>
-              <a:rPr lang="en-US" sz="1100" dirty="0">
-                <a:solidFill>
-                  <a:schemeClr val="tx2"/>
-                </a:solidFill>
-              </a:rPr>
-              <a:t>median final time</a:t>
-            </a:r>
-            <a:endParaRPr lang="en-US" sz="1100" dirty="0"/>
-          </a:p>
-        </p:txBody>
-      </p:sp>
-      <p:sp>
-        <p:nvSpPr>
-          <p:cNvPr id="33" name="Wasted v4"/>
-          <p:cNvSpPr txBox="1"/>
-          <p:nvPr/>
-        </p:nvSpPr>
-        <p:spPr>
-          <a:xfrm>
-            <a:off x="7424928" y="4160520"/>
-            <a:ext cx="1737360" cy="365760"/>
-          </a:xfrm>
-          <a:prstGeom prst="rect">
-            <a:avLst/>
-          </a:prstGeom>
-          <a:noFill/>
-          <a:ln/>
-        </p:spPr>
-        <p:txBody>
-          <a:bodyPr wrap="square" lIns="0" tIns="0" rIns="0" bIns="0" rtlCol="0" anchor="t"/>
-          <a:lstStyle/>
-          <a:p>
-            <a:pPr indent="0" marL="0">
-              <a:buNone/>
-            </a:pPr>
-            <a:r>
-              <a:rPr lang="en-US" sz="1800" b="1" dirty="0">
-                <a:solidFill>
-                  <a:schemeClr val="tx1"/>
-                </a:solidFill>
-              </a:rPr>
-              <a:t>2 of 100</a:t>
-            </a:r>
-            <a:endParaRPr lang="en-US" sz="1800" dirty="0"/>
-          </a:p>
-        </p:txBody>
-      </p:sp>
-      <p:sp>
-        <p:nvSpPr>
-          <p:cNvPr id="34" name="Wasted label v4"/>
-          <p:cNvSpPr txBox="1"/>
-          <p:nvPr/>
-        </p:nvSpPr>
-        <p:spPr>
-          <a:xfrm>
-            <a:off x="7424928" y="4526280"/>
-            <a:ext cx="1737360" cy="365760"/>
-          </a:xfrm>
-          <a:prstGeom prst="rect">
-            <a:avLst/>
-          </a:prstGeom>
-          <a:noFill/>
-          <a:ln/>
-        </p:spPr>
-        <p:txBody>
-          <a:bodyPr wrap="square" lIns="0" tIns="0" rIns="0" bIns="0" rtlCol="0" anchor="t"/>
-          <a:lstStyle/>
-          <a:p>
-            <a:pPr indent="0" marL="0">
-              <a:buNone/>
-            </a:pPr>
-            <a:r>
-              <a:rPr lang="en-US" sz="1100" dirty="0">
-                <a:solidFill>
-                  <a:schemeClr val="tx2"/>
-                </a:solidFill>
-              </a:rPr>
-              <a:t>attempts with no measurement</a:t>
-            </a:r>
-            <a:endParaRPr lang="en-US" sz="1100" dirty="0"/>
-          </a:p>
-        </p:txBody>
-      </p:sp>
-      <p:sp>
-        <p:nvSpPr>
-          <p:cNvPr id="35" name="Design card v5"/>
-          <p:cNvSpPr/>
-          <p:nvPr/>
-        </p:nvSpPr>
-        <p:spPr>
-          <a:xfrm>
-            <a:off x="9473184" y="1463040"/>
-            <a:ext cx="2084832" cy="3520440"/>
-          </a:xfrm>
-          <a:prstGeom prst="roundRect">
-            <a:avLst>
-              <a:gd name="adj" fmla="val 3509"/>
-            </a:avLst>
-          </a:prstGeom>
-          <a:solidFill>
-            <a:schemeClr val="bg2"/>
-          </a:solidFill>
-          <a:ln w="12700">
-            <a:solidFill>
-              <a:schemeClr val="bg2"/>
-            </a:solidFill>
-            <a:prstDash val="solid"/>
-          </a:ln>
-        </p:spPr>
-      </p:sp>
-      <p:sp>
-        <p:nvSpPr>
-          <p:cNvPr id="36" name="Badge v5"/>
-          <p:cNvSpPr/>
-          <p:nvPr/>
-        </p:nvSpPr>
-        <p:spPr>
-          <a:xfrm>
-            <a:off x="9656064" y="1645920"/>
-            <a:ext cx="640080" cy="640080"/>
-          </a:xfrm>
-          <a:prstGeom prst="ellipse">
-            <a:avLst/>
-          </a:prstGeom>
-          <a:solidFill>
-            <a:schemeClr val="accent1"/>
-          </a:solidFill>
-          <a:ln w="12700">
-            <a:solidFill>
-              <a:schemeClr val="accent1"/>
-            </a:solidFill>
-            <a:prstDash val="solid"/>
-          </a:ln>
-        </p:spPr>
-      </p:sp>
-      <p:sp>
-        <p:nvSpPr>
-          <p:cNvPr id="37" name="Badge text v5"/>
-          <p:cNvSpPr txBox="1"/>
-          <p:nvPr/>
-        </p:nvSpPr>
-        <p:spPr>
-          <a:xfrm>
-            <a:off x="9656064" y="1645920"/>
-            <a:ext cx="640080" cy="640080"/>
-          </a:xfrm>
-          <a:prstGeom prst="rect">
-            <a:avLst/>
-          </a:prstGeom>
-          <a:noFill/>
-          <a:ln/>
-        </p:spPr>
-        <p:txBody>
-          <a:bodyPr wrap="square" lIns="0" tIns="0" rIns="0" bIns="0" rtlCol="0" anchor="ctr"/>
-          <a:lstStyle/>
-          <a:p>
-            <a:pPr algn="ctr" indent="0" marL="0">
-              <a:buNone/>
-            </a:pPr>
-            <a:r>
-              <a:rPr lang="en-US" sz="1800" b="1" dirty="0">
-                <a:solidFill>
-                  <a:schemeClr val="bg1"/>
-                </a:solidFill>
-              </a:rPr>
-              <a:t>v5</a:t>
-            </a:r>
-            <a:endParaRPr lang="en-US" sz="1800" dirty="0"/>
-          </a:p>
-        </p:txBody>
-      </p:sp>
-      <p:sp>
-        <p:nvSpPr>
-          <p:cNvPr id="38" name="Shown v5"/>
-          <p:cNvSpPr txBox="1"/>
-          <p:nvPr/>
-        </p:nvSpPr>
-        <p:spPr>
-          <a:xfrm>
-            <a:off x="9656064" y="2423160"/>
-            <a:ext cx="1737360" cy="914400"/>
-          </a:xfrm>
-          <a:prstGeom prst="rect">
-            <a:avLst/>
-          </a:prstGeom>
-          <a:noFill/>
-          <a:ln/>
-        </p:spPr>
-        <p:txBody>
-          <a:bodyPr wrap="square" lIns="0" tIns="0" rIns="0" bIns="0" rtlCol="0" anchor="t"/>
-          <a:lstStyle/>
-          <a:p>
-            <a:pPr indent="0" marL="0">
-              <a:buNone/>
-            </a:pPr>
-            <a:r>
-              <a:rPr lang="en-US" sz="1500" b="1" dirty="0">
-                <a:solidFill>
-                  <a:schemeClr val="tx1"/>
-                </a:solidFill>
-              </a:rPr>
-              <a:t>v4, with far moves; names its move</a:t>
-            </a:r>
-            <a:endParaRPr lang="en-US" sz="1500" dirty="0"/>
-          </a:p>
-        </p:txBody>
-      </p:sp>
-      <p:sp>
-        <p:nvSpPr>
-          <p:cNvPr id="39" name="Time v5"/>
-          <p:cNvSpPr txBox="1"/>
-          <p:nvPr/>
-        </p:nvSpPr>
-        <p:spPr>
-          <a:xfrm>
-            <a:off x="9656064" y="3383280"/>
-            <a:ext cx="1737360" cy="457200"/>
-          </a:xfrm>
-          <a:prstGeom prst="rect">
-            <a:avLst/>
-          </a:prstGeom>
-          <a:noFill/>
-          <a:ln/>
-        </p:spPr>
-        <p:txBody>
-          <a:bodyPr wrap="square" lIns="0" tIns="0" rIns="0" bIns="0" rtlCol="0" anchor="t"/>
-          <a:lstStyle/>
-          <a:p>
-            <a:pPr indent="0" marL="0">
-              <a:buNone/>
-            </a:pPr>
-            <a:r>
-              <a:rPr lang="en-US" sz="2400" b="1" dirty="0">
-                <a:solidFill>
-                  <a:schemeClr val="accent1"/>
-                </a:solidFill>
-                <a:latin typeface="Cambria" pitchFamily="34" charset="0"/>
-                <a:ea typeface="Cambria" pitchFamily="34" charset="-122"/>
-                <a:cs typeface="Cambria" pitchFamily="34" charset="-120"/>
-              </a:rPr>
-              <a:t>1,494 µs</a:t>
-            </a:r>
-            <a:endParaRPr lang="en-US" sz="2400" dirty="0"/>
-          </a:p>
-        </p:txBody>
-      </p:sp>
-      <p:sp>
-        <p:nvSpPr>
-          <p:cNvPr id="40" name="Time label v5"/>
-          <p:cNvSpPr txBox="1"/>
-          <p:nvPr/>
-        </p:nvSpPr>
-        <p:spPr>
-          <a:xfrm>
-            <a:off x="9656064" y="3822192"/>
-            <a:ext cx="1737360" cy="274320"/>
-          </a:xfrm>
-          <a:prstGeom prst="rect">
-            <a:avLst/>
-          </a:prstGeom>
-          <a:noFill/>
-          <a:ln/>
-        </p:spPr>
-        <p:txBody>
-          <a:bodyPr wrap="square" lIns="0" tIns="0" rIns="0" bIns="0" rtlCol="0" anchor="t"/>
-          <a:lstStyle/>
-          <a:p>
-            <a:pPr indent="0" marL="0">
-              <a:buNone/>
-            </a:pPr>
-            <a:r>
-              <a:rPr lang="en-US" sz="1100" dirty="0">
-                <a:solidFill>
-                  <a:schemeClr val="tx2"/>
-                </a:solidFill>
-              </a:rPr>
-              <a:t>median final time</a:t>
-            </a:r>
-            <a:endParaRPr lang="en-US" sz="1100" dirty="0"/>
-          </a:p>
-        </p:txBody>
-      </p:sp>
-      <p:sp>
-        <p:nvSpPr>
-          <p:cNvPr id="41" name="Wasted v5"/>
-          <p:cNvSpPr txBox="1"/>
-          <p:nvPr/>
-        </p:nvSpPr>
-        <p:spPr>
-          <a:xfrm>
-            <a:off x="9656064" y="4160520"/>
-            <a:ext cx="1737360" cy="365760"/>
-          </a:xfrm>
-          <a:prstGeom prst="rect">
-            <a:avLst/>
-          </a:prstGeom>
-          <a:noFill/>
-          <a:ln/>
-        </p:spPr>
-        <p:txBody>
-          <a:bodyPr wrap="square" lIns="0" tIns="0" rIns="0" bIns="0" rtlCol="0" anchor="t"/>
-          <a:lstStyle/>
-          <a:p>
-            <a:pPr indent="0" marL="0">
-              <a:buNone/>
-            </a:pPr>
-            <a:r>
-              <a:rPr lang="en-US" sz="1800" b="1" dirty="0">
-                <a:solidFill>
-                  <a:schemeClr val="tx1"/>
-                </a:solidFill>
-              </a:rPr>
-              <a:t>0 of 100</a:t>
-            </a:r>
-            <a:endParaRPr lang="en-US" sz="1800" dirty="0"/>
-          </a:p>
-        </p:txBody>
-      </p:sp>
-      <p:sp>
-        <p:nvSpPr>
-          <p:cNvPr id="42" name="Wasted label v5"/>
-          <p:cNvSpPr txBox="1"/>
-          <p:nvPr/>
-        </p:nvSpPr>
-        <p:spPr>
-          <a:xfrm>
-            <a:off x="9656064" y="4526280"/>
-            <a:ext cx="1737360" cy="365760"/>
-          </a:xfrm>
-          <a:prstGeom prst="rect">
-            <a:avLst/>
-          </a:prstGeom>
-          <a:noFill/>
-          <a:ln/>
-        </p:spPr>
-        <p:txBody>
-          <a:bodyPr wrap="square" lIns="0" tIns="0" rIns="0" bIns="0" rtlCol="0" anchor="t"/>
-          <a:lstStyle/>
-          <a:p>
-            <a:pPr indent="0" marL="0">
-              <a:buNone/>
-            </a:pPr>
-            <a:r>
-              <a:rPr lang="en-US" sz="1100" dirty="0">
-                <a:solidFill>
-                  <a:schemeClr val="tx2"/>
-                </a:solidFill>
-              </a:rPr>
-              <a:t>attempts with no measurement</a:t>
-            </a:r>
-            <a:endParaRPr lang="en-US" sz="1100" dirty="0"/>
-          </a:p>
-        </p:txBody>
-      </p:sp>
-      <p:sp>
-        <p:nvSpPr>
-          <p:cNvPr id="43" name="Design caption"/>
-          <p:cNvSpPr txBox="1"/>
-          <p:nvPr/>
-        </p:nvSpPr>
-        <p:spPr>
-          <a:xfrm>
-            <a:off x="548640" y="5257800"/>
-            <a:ext cx="11064240" cy="731520"/>
-          </a:xfrm>
-          <a:prstGeom prst="rect">
-            <a:avLst/>
-          </a:prstGeom>
-          <a:noFill/>
-          <a:ln/>
-        </p:spPr>
-        <p:txBody>
-          <a:bodyPr wrap="square" lIns="0" tIns="0" rIns="0" bIns="0" rtlCol="0" anchor="t"/>
-          <a:lstStyle/>
-          <a:p>
-            <a:pPr indent="0" marL="0">
-              <a:buNone/>
-            </a:pPr>
-            <a:r>
-              <a:rPr lang="en-US" sz="1500" dirty="0">
-                <a:solidFill>
-                  <a:schemeClr val="tx2"/>
-                </a:solidFill>
-              </a:rPr>
-              <a:t>Each design fixes a failure we read in the previous one's log. The model, Qwen3-8B, never changed. Adapter-style shape, 10 starting points: best possible 1,361 µs, random guessing 1,467 µs.</a:t>
-            </a:r>
-            <a:endParaRPr lang="en-US" sz="1500" dirty="0"/>
-          </a:p>
-        </p:txBody>
-      </p:sp>
+      <p:pic>
+        <p:nvPicPr>
+          <p:cNvPr id="3" name="Architecture diagram" descr="Architecture diagram: a loop driver sends M, N, K settings to a blocked matmul kernel on a Trainium2 NeuronCore on seats 206 to 209; neuron-explorer profiles it; the result goes to a checker model and an optimiser model, both Qwen3-8B on seat 205; side measurements on seat 170 compare traced models with the AWS compiler default; below, the hackathon repo, AWS's NKI skills and the Neuron SDK that the work builds on">    </p:cNvPr>
+          <p:cNvPicPr>
+            <a:picLocks noChangeAspect="1"/>
+          </p:cNvPicPr>
+          <p:nvPr/>
+        </p:nvPicPr>
+        <p:blipFill>
+          <a:blip r:embed="rId1"/>
+          <a:stretch>
+            <a:fillRect/>
+          </a:stretch>
+        </p:blipFill>
+        <p:spPr>
+          <a:xfrm>
+            <a:off x="1627632" y="777240"/>
+            <a:ext cx="8942832" cy="5943600"/>
+          </a:xfrm>
+          <a:prstGeom prst="rect">
+            <a:avLst/>
+          </a:prstGeom>
+        </p:spPr>
+      </p:pic>
       <p:sp>
         <p:nvSpPr>
           <p:cNvPr id="25" name="Slide Number Placeholder 0"/>
@@ -5153,7 +3993,7 @@
         </p:nvSpPr>
         <p:spPr>
           <a:xfrm>
-            <a:off x="11155680" y="6355080"/>
+            <a:off x="11155680" y="6492240"/>
             <a:ext cx="457200" cy="274320"/>
           </a:xfrm>
           <a:prstGeom prst="rect">
@@ -5243,50 +4083,26 @@
                   <a:schemeClr val="tx1"/>
                 </a:solidFill>
               </a:rPr>
-              <a:t>What we got: the checker decides, not the model</a:t>
+              <a:t>What we tried: five checker designs, one model</a:t>
             </a:r>
             <a:endParaRPr lang="en-US" sz="3600" dirty="0"/>
           </a:p>
         </p:txBody>
       </p:sp>
-      <p:pic>
-        <p:nvPicPr>
-          <p:cNvPr id="3" name="Chart: best time against attempts, 30 starts" descr="Line chart of best kernel time found against attempts on the chip, for each approach, at the adapter shape">    </p:cNvPr>
-          <p:cNvPicPr>
-            <a:picLocks noChangeAspect="1"/>
-          </p:cNvPicPr>
-          <p:nvPr/>
-        </p:nvPicPr>
-        <p:blipFill>
-          <a:blip r:embed="rId1"/>
-          <a:stretch>
-            <a:fillRect/>
-          </a:stretch>
-        </p:blipFill>
-        <p:spPr>
-          <a:xfrm>
-            <a:off x="548640" y="1417320"/>
-            <a:ext cx="6766560" cy="4663440"/>
-          </a:xfrm>
-          <a:prstGeom prst="rect">
-            <a:avLst/>
-          </a:prstGeom>
-        </p:spPr>
-      </p:pic>
-      <p:sp>
-        <p:nvSpPr>
-          <p:cNvPr id="4" name="Result card 1"/>
+      <p:sp>
+        <p:nvSpPr>
+          <p:cNvPr id="3" name="Design card v1"/>
           <p:cNvSpPr/>
           <p:nvPr/>
         </p:nvSpPr>
         <p:spPr>
           <a:xfrm>
-            <a:off x="7589520" y="1417320"/>
-            <a:ext cx="4023360" cy="1417320"/>
+            <a:off x="548640" y="1463040"/>
+            <a:ext cx="2084832" cy="3520440"/>
           </a:xfrm>
           <a:prstGeom prst="roundRect">
             <a:avLst>
-              <a:gd name="adj" fmla="val 5161"/>
+              <a:gd name="adj" fmla="val 3509"/>
             </a:avLst>
           </a:prstGeom>
           <a:solidFill>
@@ -5302,14 +4118,39 @@
       </p:sp>
       <p:sp>
         <p:nvSpPr>
-          <p:cNvPr id="5" name="Result 1"/>
+          <p:cNvPr id="4" name="Badge v1"/>
+          <p:cNvSpPr/>
+          <p:nvPr/>
+        </p:nvSpPr>
+        <p:spPr>
+          <a:xfrm>
+            <a:off x="731520" y="1645920"/>
+            <a:ext cx="640080" cy="640080"/>
+          </a:xfrm>
+          <a:prstGeom prst="ellipse">
+            <a:avLst/>
+          </a:prstGeom>
+          <a:solidFill>
+            <a:schemeClr val="accent4"/>
+          </a:solidFill>
+          <a:ln w="12700">
+            <a:solidFill>
+              <a:schemeClr val="accent4"/>
+            </a:solidFill>
+            <a:prstDash val="solid"/>
+          </a:ln>
+        </p:spPr>
+      </p:sp>
+      <p:sp>
+        <p:nvSpPr>
+          <p:cNvPr id="5" name="Badge text v1"/>
           <p:cNvSpPr txBox="1"/>
           <p:nvPr/>
         </p:nvSpPr>
         <p:spPr>
           <a:xfrm>
-            <a:off x="7818120" y="1554480"/>
-            <a:ext cx="3566160" cy="566928"/>
+            <a:off x="731520" y="1645920"/>
+            <a:ext cx="640080" cy="640080"/>
           </a:xfrm>
           <a:prstGeom prst="rect">
             <a:avLst/>
@@ -5321,34 +4162,106 @@
           <a:bodyPr wrap="square" lIns="0" tIns="0" rIns="0" bIns="0" rtlCol="0" anchor="ctr"/>
           <a:lstStyle/>
           <a:p>
+            <a:pPr algn="ctr" indent="0" marL="0">
+              <a:buNone/>
+            </a:pPr>
+            <a:r>
+              <a:rPr lang="en-US" sz="1800" b="1" dirty="0">
+                <a:solidFill>
+                  <a:schemeClr val="bg1"/>
+                </a:solidFill>
+              </a:rPr>
+              <a:t>v1</a:t>
+            </a:r>
+            <a:endParaRPr lang="en-US" sz="1800" dirty="0"/>
+          </a:p>
+        </p:txBody>
+      </p:sp>
+      <p:sp>
+        <p:nvSpPr>
+          <p:cNvPr id="6" name="Shown v1"/>
+          <p:cNvSpPr txBox="1"/>
+          <p:nvPr/>
+        </p:nvSpPr>
+        <p:spPr>
+          <a:xfrm>
+            <a:off x="731520" y="2423160"/>
+            <a:ext cx="1737360" cy="914400"/>
+          </a:xfrm>
+          <a:prstGeom prst="rect">
+            <a:avLst/>
+          </a:prstGeom>
+          <a:noFill/>
+          <a:ln/>
+        </p:spPr>
+        <p:txBody>
+          <a:bodyPr wrap="square" lIns="0" tIns="0" rIns="0" bIns="0" rtlCol="0" anchor="t"/>
+          <a:lstStyle/>
+          <a:p>
             <a:pPr indent="0" marL="0">
               <a:buNone/>
             </a:pPr>
             <a:r>
-              <a:rPr lang="en-US" sz="3000" b="1" dirty="0">
-                <a:solidFill>
-                  <a:schemeClr val="accent1"/>
+              <a:rPr lang="en-US" sz="1500" b="1" dirty="0">
+                <a:solidFill>
+                  <a:schemeClr val="tx1"/>
+                </a:solidFill>
+              </a:rPr>
+              <a:t>Raw profile numbers</a:t>
+            </a:r>
+            <a:endParaRPr lang="en-US" sz="1500" dirty="0"/>
+          </a:p>
+        </p:txBody>
+      </p:sp>
+      <p:sp>
+        <p:nvSpPr>
+          <p:cNvPr id="7" name="Time v1"/>
+          <p:cNvSpPr txBox="1"/>
+          <p:nvPr/>
+        </p:nvSpPr>
+        <p:spPr>
+          <a:xfrm>
+            <a:off x="731520" y="3383280"/>
+            <a:ext cx="1737360" cy="457200"/>
+          </a:xfrm>
+          <a:prstGeom prst="rect">
+            <a:avLst/>
+          </a:prstGeom>
+          <a:noFill/>
+          <a:ln/>
+        </p:spPr>
+        <p:txBody>
+          <a:bodyPr wrap="square" lIns="0" tIns="0" rIns="0" bIns="0" rtlCol="0" anchor="t"/>
+          <a:lstStyle/>
+          <a:p>
+            <a:pPr indent="0" marL="0">
+              <a:buNone/>
+            </a:pPr>
+            <a:r>
+              <a:rPr lang="en-US" sz="2400" b="1" dirty="0">
+                <a:solidFill>
+                  <a:schemeClr val="accent4"/>
                 </a:solidFill>
                 <a:latin typeface="Cambria" pitchFamily="34" charset="0"/>
                 <a:ea typeface="Cambria" pitchFamily="34" charset="-122"/>
                 <a:cs typeface="Cambria" pitchFamily="34" charset="-120"/>
               </a:rPr>
-              <a:t>3 → 29 of 30</a:t>
-            </a:r>
-            <a:endParaRPr lang="en-US" sz="3000" dirty="0"/>
-          </a:p>
-        </p:txBody>
-      </p:sp>
-      <p:sp>
-        <p:nvSpPr>
-          <p:cNvPr id="6" name="Result label 1"/>
+              <a:t>2,285 µs</a:t>
+            </a:r>
+            <a:endParaRPr lang="en-US" sz="2400" dirty="0"/>
+          </a:p>
+        </p:txBody>
+      </p:sp>
+      <p:sp>
+        <p:nvSpPr>
+          <p:cNvPr id="8" name="Time label v1"/>
           <p:cNvSpPr txBox="1"/>
           <p:nvPr/>
         </p:nvSpPr>
         <p:spPr>
           <a:xfrm>
-            <a:off x="7818120" y="2148840"/>
-            <a:ext cx="3566160" cy="594360"/>
+            <a:off x="731520" y="3822192"/>
+            <a:ext cx="1737360" cy="274320"/>
           </a:xfrm>
           <a:prstGeom prst="rect">
             <a:avLst/>
@@ -5364,31 +4277,103 @@
               <a:buNone/>
             </a:pPr>
             <a:r>
-              <a:rPr lang="en-US" sz="1300" dirty="0">
+              <a:rPr lang="en-US" sz="1100" dirty="0">
                 <a:solidFill>
                   <a:schemeClr val="tx2"/>
                 </a:solidFill>
               </a:rPr>
-              <a:t>runs within 10% of the best, first checker to last, same model</a:t>
-            </a:r>
-            <a:endParaRPr lang="en-US" sz="1300" dirty="0"/>
-          </a:p>
-        </p:txBody>
-      </p:sp>
-      <p:sp>
-        <p:nvSpPr>
-          <p:cNvPr id="7" name="Result card 2"/>
+              <a:t>median final time</a:t>
+            </a:r>
+            <a:endParaRPr lang="en-US" sz="1100" dirty="0"/>
+          </a:p>
+        </p:txBody>
+      </p:sp>
+      <p:sp>
+        <p:nvSpPr>
+          <p:cNvPr id="9" name="Wasted v1"/>
+          <p:cNvSpPr txBox="1"/>
+          <p:nvPr/>
+        </p:nvSpPr>
+        <p:spPr>
+          <a:xfrm>
+            <a:off x="731520" y="4160520"/>
+            <a:ext cx="1737360" cy="365760"/>
+          </a:xfrm>
+          <a:prstGeom prst="rect">
+            <a:avLst/>
+          </a:prstGeom>
+          <a:noFill/>
+          <a:ln/>
+        </p:spPr>
+        <p:txBody>
+          <a:bodyPr wrap="square" lIns="0" tIns="0" rIns="0" bIns="0" rtlCol="0" anchor="t"/>
+          <a:lstStyle/>
+          <a:p>
+            <a:pPr indent="0" marL="0">
+              <a:buNone/>
+            </a:pPr>
+            <a:r>
+              <a:rPr lang="en-US" sz="1800" b="1" dirty="0">
+                <a:solidFill>
+                  <a:schemeClr val="tx1"/>
+                </a:solidFill>
+              </a:rPr>
+              <a:t>66 of 100</a:t>
+            </a:r>
+            <a:endParaRPr lang="en-US" sz="1800" dirty="0"/>
+          </a:p>
+        </p:txBody>
+      </p:sp>
+      <p:sp>
+        <p:nvSpPr>
+          <p:cNvPr id="10" name="Wasted label v1"/>
+          <p:cNvSpPr txBox="1"/>
+          <p:nvPr/>
+        </p:nvSpPr>
+        <p:spPr>
+          <a:xfrm>
+            <a:off x="731520" y="4526280"/>
+            <a:ext cx="1737360" cy="365760"/>
+          </a:xfrm>
+          <a:prstGeom prst="rect">
+            <a:avLst/>
+          </a:prstGeom>
+          <a:noFill/>
+          <a:ln/>
+        </p:spPr>
+        <p:txBody>
+          <a:bodyPr wrap="square" lIns="0" tIns="0" rIns="0" bIns="0" rtlCol="0" anchor="t"/>
+          <a:lstStyle/>
+          <a:p>
+            <a:pPr indent="0" marL="0">
+              <a:buNone/>
+            </a:pPr>
+            <a:r>
+              <a:rPr lang="en-US" sz="1100" dirty="0">
+                <a:solidFill>
+                  <a:schemeClr val="tx2"/>
+                </a:solidFill>
+              </a:rPr>
+              <a:t>attempts with no measurement</a:t>
+            </a:r>
+            <a:endParaRPr lang="en-US" sz="1100" dirty="0"/>
+          </a:p>
+        </p:txBody>
+      </p:sp>
+      <p:sp>
+        <p:nvSpPr>
+          <p:cNvPr id="11" name="Design card v2"/>
           <p:cNvSpPr/>
           <p:nvPr/>
         </p:nvSpPr>
         <p:spPr>
           <a:xfrm>
-            <a:off x="7589520" y="2990088"/>
-            <a:ext cx="4023360" cy="1417320"/>
+            <a:off x="2779776" y="1463040"/>
+            <a:ext cx="2084832" cy="3520440"/>
           </a:xfrm>
           <a:prstGeom prst="roundRect">
             <a:avLst>
-              <a:gd name="adj" fmla="val 5161"/>
+              <a:gd name="adj" fmla="val 3509"/>
             </a:avLst>
           </a:prstGeom>
           <a:solidFill>
@@ -5404,14 +4389,39 @@
       </p:sp>
       <p:sp>
         <p:nvSpPr>
-          <p:cNvPr id="8" name="Result 2"/>
+          <p:cNvPr id="12" name="Badge v2"/>
+          <p:cNvSpPr/>
+          <p:nvPr/>
+        </p:nvSpPr>
+        <p:spPr>
+          <a:xfrm>
+            <a:off x="2962656" y="1645920"/>
+            <a:ext cx="640080" cy="640080"/>
+          </a:xfrm>
+          <a:prstGeom prst="ellipse">
+            <a:avLst/>
+          </a:prstGeom>
+          <a:solidFill>
+            <a:schemeClr val="accent2"/>
+          </a:solidFill>
+          <a:ln w="12700">
+            <a:solidFill>
+              <a:schemeClr val="accent2"/>
+            </a:solidFill>
+            <a:prstDash val="solid"/>
+          </a:ln>
+        </p:spPr>
+      </p:sp>
+      <p:sp>
+        <p:nvSpPr>
+          <p:cNvPr id="13" name="Badge text v2"/>
           <p:cNvSpPr txBox="1"/>
           <p:nvPr/>
         </p:nvSpPr>
         <p:spPr>
           <a:xfrm>
-            <a:off x="7818120" y="3127248"/>
-            <a:ext cx="3566160" cy="566928"/>
+            <a:off x="2962656" y="1645920"/>
+            <a:ext cx="640080" cy="640080"/>
           </a:xfrm>
           <a:prstGeom prst="rect">
             <a:avLst/>
@@ -5423,34 +4433,106 @@
           <a:bodyPr wrap="square" lIns="0" tIns="0" rIns="0" bIns="0" rtlCol="0" anchor="ctr"/>
           <a:lstStyle/>
           <a:p>
+            <a:pPr algn="ctr" indent="0" marL="0">
+              <a:buNone/>
+            </a:pPr>
+            <a:r>
+              <a:rPr lang="en-US" sz="1800" b="1" dirty="0">
+                <a:solidFill>
+                  <a:schemeClr val="bg1"/>
+                </a:solidFill>
+              </a:rPr>
+              <a:t>v2</a:t>
+            </a:r>
+            <a:endParaRPr lang="en-US" sz="1800" dirty="0"/>
+          </a:p>
+        </p:txBody>
+      </p:sp>
+      <p:sp>
+        <p:nvSpPr>
+          <p:cNvPr id="14" name="Shown v2"/>
+          <p:cNvSpPr txBox="1"/>
+          <p:nvPr/>
+        </p:nvSpPr>
+        <p:spPr>
+          <a:xfrm>
+            <a:off x="2962656" y="2423160"/>
+            <a:ext cx="1737360" cy="914400"/>
+          </a:xfrm>
+          <a:prstGeom prst="rect">
+            <a:avLst/>
+          </a:prstGeom>
+          <a:noFill/>
+          <a:ln/>
+        </p:spPr>
+        <p:txBody>
+          <a:bodyPr wrap="square" lIns="0" tIns="0" rIns="0" bIns="0" rtlCol="0" anchor="t"/>
+          <a:lstStyle/>
+          <a:p>
             <a:pPr indent="0" marL="0">
               <a:buNone/>
             </a:pPr>
             <a:r>
-              <a:rPr lang="en-US" sz="3000" b="1" dirty="0">
-                <a:solidFill>
-                  <a:schemeClr val="accent3"/>
+              <a:rPr lang="en-US" sz="1500" b="1" dirty="0">
+                <a:solidFill>
+                  <a:schemeClr val="tx1"/>
+                </a:solidFill>
+              </a:rPr>
+              <a:t>Comparisons worked out in code</a:t>
+            </a:r>
+            <a:endParaRPr lang="en-US" sz="1500" dirty="0"/>
+          </a:p>
+        </p:txBody>
+      </p:sp>
+      <p:sp>
+        <p:nvSpPr>
+          <p:cNvPr id="15" name="Time v2"/>
+          <p:cNvSpPr txBox="1"/>
+          <p:nvPr/>
+        </p:nvSpPr>
+        <p:spPr>
+          <a:xfrm>
+            <a:off x="2962656" y="3383280"/>
+            <a:ext cx="1737360" cy="457200"/>
+          </a:xfrm>
+          <a:prstGeom prst="rect">
+            <a:avLst/>
+          </a:prstGeom>
+          <a:noFill/>
+          <a:ln/>
+        </p:spPr>
+        <p:txBody>
+          <a:bodyPr wrap="square" lIns="0" tIns="0" rIns="0" bIns="0" rtlCol="0" anchor="t"/>
+          <a:lstStyle/>
+          <a:p>
+            <a:pPr indent="0" marL="0">
+              <a:buNone/>
+            </a:pPr>
+            <a:r>
+              <a:rPr lang="en-US" sz="2400" b="1" dirty="0">
+                <a:solidFill>
+                  <a:schemeClr val="accent2"/>
                 </a:solidFill>
                 <a:latin typeface="Cambria" pitchFamily="34" charset="0"/>
                 <a:ea typeface="Cambria" pitchFamily="34" charset="-122"/>
                 <a:cs typeface="Cambria" pitchFamily="34" charset="-120"/>
               </a:rPr>
-              <a:t>73%</a:t>
-            </a:r>
-            <a:endParaRPr lang="en-US" sz="3000" dirty="0"/>
-          </a:p>
-        </p:txBody>
-      </p:sp>
-      <p:sp>
-        <p:nvSpPr>
-          <p:cNvPr id="9" name="Result label 2"/>
+              <a:t>1,553 µs</a:t>
+            </a:r>
+            <a:endParaRPr lang="en-US" sz="2400" dirty="0"/>
+          </a:p>
+        </p:txBody>
+      </p:sp>
+      <p:sp>
+        <p:nvSpPr>
+          <p:cNvPr id="16" name="Time label v2"/>
           <p:cNvSpPr txBox="1"/>
           <p:nvPr/>
         </p:nvSpPr>
         <p:spPr>
           <a:xfrm>
-            <a:off x="7818120" y="3721608"/>
-            <a:ext cx="3566160" cy="594360"/>
+            <a:off x="2962656" y="3822192"/>
+            <a:ext cx="1737360" cy="274320"/>
           </a:xfrm>
           <a:prstGeom prst="rect">
             <a:avLst/>
@@ -5466,31 +4548,103 @@
               <a:buNone/>
             </a:pPr>
             <a:r>
-              <a:rPr lang="en-US" sz="1300" dirty="0">
+              <a:rPr lang="en-US" sz="1100" dirty="0">
                 <a:solidFill>
                   <a:schemeClr val="tx2"/>
                 </a:solidFill>
               </a:rPr>
-              <a:t>of runs within 10% of the best for random guessing</a:t>
-            </a:r>
-            <a:endParaRPr lang="en-US" sz="1300" dirty="0"/>
-          </a:p>
-        </p:txBody>
-      </p:sp>
-      <p:sp>
-        <p:nvSpPr>
-          <p:cNvPr id="10" name="Result card 3"/>
+              <a:t>median final time</a:t>
+            </a:r>
+            <a:endParaRPr lang="en-US" sz="1100" dirty="0"/>
+          </a:p>
+        </p:txBody>
+      </p:sp>
+      <p:sp>
+        <p:nvSpPr>
+          <p:cNvPr id="17" name="Wasted v2"/>
+          <p:cNvSpPr txBox="1"/>
+          <p:nvPr/>
+        </p:nvSpPr>
+        <p:spPr>
+          <a:xfrm>
+            <a:off x="2962656" y="4160520"/>
+            <a:ext cx="1737360" cy="365760"/>
+          </a:xfrm>
+          <a:prstGeom prst="rect">
+            <a:avLst/>
+          </a:prstGeom>
+          <a:noFill/>
+          <a:ln/>
+        </p:spPr>
+        <p:txBody>
+          <a:bodyPr wrap="square" lIns="0" tIns="0" rIns="0" bIns="0" rtlCol="0" anchor="t"/>
+          <a:lstStyle/>
+          <a:p>
+            <a:pPr indent="0" marL="0">
+              <a:buNone/>
+            </a:pPr>
+            <a:r>
+              <a:rPr lang="en-US" sz="1800" b="1" dirty="0">
+                <a:solidFill>
+                  <a:schemeClr val="tx1"/>
+                </a:solidFill>
+              </a:rPr>
+              <a:t>70 of 100</a:t>
+            </a:r>
+            <a:endParaRPr lang="en-US" sz="1800" dirty="0"/>
+          </a:p>
+        </p:txBody>
+      </p:sp>
+      <p:sp>
+        <p:nvSpPr>
+          <p:cNvPr id="18" name="Wasted label v2"/>
+          <p:cNvSpPr txBox="1"/>
+          <p:nvPr/>
+        </p:nvSpPr>
+        <p:spPr>
+          <a:xfrm>
+            <a:off x="2962656" y="4526280"/>
+            <a:ext cx="1737360" cy="365760"/>
+          </a:xfrm>
+          <a:prstGeom prst="rect">
+            <a:avLst/>
+          </a:prstGeom>
+          <a:noFill/>
+          <a:ln/>
+        </p:spPr>
+        <p:txBody>
+          <a:bodyPr wrap="square" lIns="0" tIns="0" rIns="0" bIns="0" rtlCol="0" anchor="t"/>
+          <a:lstStyle/>
+          <a:p>
+            <a:pPr indent="0" marL="0">
+              <a:buNone/>
+            </a:pPr>
+            <a:r>
+              <a:rPr lang="en-US" sz="1100" dirty="0">
+                <a:solidFill>
+                  <a:schemeClr val="tx2"/>
+                </a:solidFill>
+              </a:rPr>
+              <a:t>attempts with no measurement</a:t>
+            </a:r>
+            <a:endParaRPr lang="en-US" sz="1100" dirty="0"/>
+          </a:p>
+        </p:txBody>
+      </p:sp>
+      <p:sp>
+        <p:nvSpPr>
+          <p:cNvPr id="19" name="Design card v3"/>
           <p:cNvSpPr/>
           <p:nvPr/>
         </p:nvSpPr>
         <p:spPr>
           <a:xfrm>
-            <a:off x="7589520" y="4562856"/>
-            <a:ext cx="4023360" cy="1417320"/>
+            <a:off x="5010912" y="1463040"/>
+            <a:ext cx="2084832" cy="3520440"/>
           </a:xfrm>
           <a:prstGeom prst="roundRect">
             <a:avLst>
-              <a:gd name="adj" fmla="val 5161"/>
+              <a:gd name="adj" fmla="val 3509"/>
             </a:avLst>
           </a:prstGeom>
           <a:solidFill>
@@ -5506,14 +4660,39 @@
       </p:sp>
       <p:sp>
         <p:nvSpPr>
-          <p:cNvPr id="11" name="Result 3"/>
+          <p:cNvPr id="20" name="Badge v3"/>
+          <p:cNvSpPr/>
+          <p:nvPr/>
+        </p:nvSpPr>
+        <p:spPr>
+          <a:xfrm>
+            <a:off x="5193792" y="1645920"/>
+            <a:ext cx="640080" cy="640080"/>
+          </a:xfrm>
+          <a:prstGeom prst="ellipse">
+            <a:avLst/>
+          </a:prstGeom>
+          <a:solidFill>
+            <a:schemeClr val="accent3"/>
+          </a:solidFill>
+          <a:ln w="12700">
+            <a:solidFill>
+              <a:schemeClr val="accent3"/>
+            </a:solidFill>
+            <a:prstDash val="solid"/>
+          </a:ln>
+        </p:spPr>
+      </p:sp>
+      <p:sp>
+        <p:nvSpPr>
+          <p:cNvPr id="21" name="Badge text v3"/>
           <p:cNvSpPr txBox="1"/>
           <p:nvPr/>
         </p:nvSpPr>
         <p:spPr>
           <a:xfrm>
-            <a:off x="7818120" y="4700016"/>
-            <a:ext cx="3566160" cy="566928"/>
+            <a:off x="5193792" y="1645920"/>
+            <a:ext cx="640080" cy="640080"/>
           </a:xfrm>
           <a:prstGeom prst="rect">
             <a:avLst/>
@@ -5525,34 +4704,106 @@
           <a:bodyPr wrap="square" lIns="0" tIns="0" rIns="0" bIns="0" rtlCol="0" anchor="ctr"/>
           <a:lstStyle/>
           <a:p>
+            <a:pPr algn="ctr" indent="0" marL="0">
+              <a:buNone/>
+            </a:pPr>
+            <a:r>
+              <a:rPr lang="en-US" sz="1800" b="1" dirty="0">
+                <a:solidFill>
+                  <a:schemeClr val="bg1"/>
+                </a:solidFill>
+              </a:rPr>
+              <a:t>v3</a:t>
+            </a:r>
+            <a:endParaRPr lang="en-US" sz="1800" dirty="0"/>
+          </a:p>
+        </p:txBody>
+      </p:sp>
+      <p:sp>
+        <p:nvSpPr>
+          <p:cNvPr id="22" name="Shown v3"/>
+          <p:cNvSpPr txBox="1"/>
+          <p:nvPr/>
+        </p:nvSpPr>
+        <p:spPr>
+          <a:xfrm>
+            <a:off x="5193792" y="2423160"/>
+            <a:ext cx="1737360" cy="914400"/>
+          </a:xfrm>
+          <a:prstGeom prst="rect">
+            <a:avLst/>
+          </a:prstGeom>
+          <a:noFill/>
+          <a:ln/>
+        </p:spPr>
+        <p:txBody>
+          <a:bodyPr wrap="square" lIns="0" tIns="0" rIns="0" bIns="0" rtlCol="0" anchor="t"/>
+          <a:lstStyle/>
+          <a:p>
             <a:pPr indent="0" marL="0">
               <a:buNone/>
             </a:pPr>
             <a:r>
-              <a:rPr lang="en-US" sz="3000" b="1" dirty="0">
-                <a:solidFill>
-                  <a:schemeClr val="accent2"/>
+              <a:rPr lang="en-US" sz="1500" b="1" dirty="0">
+                <a:solidFill>
+                  <a:schemeClr val="tx1"/>
+                </a:solidFill>
+              </a:rPr>
+              <a:t>A menu of measured moves</a:t>
+            </a:r>
+            <a:endParaRPr lang="en-US" sz="1500" dirty="0"/>
+          </a:p>
+        </p:txBody>
+      </p:sp>
+      <p:sp>
+        <p:nvSpPr>
+          <p:cNvPr id="23" name="Time v3"/>
+          <p:cNvSpPr txBox="1"/>
+          <p:nvPr/>
+        </p:nvSpPr>
+        <p:spPr>
+          <a:xfrm>
+            <a:off x="5193792" y="3383280"/>
+            <a:ext cx="1737360" cy="457200"/>
+          </a:xfrm>
+          <a:prstGeom prst="rect">
+            <a:avLst/>
+          </a:prstGeom>
+          <a:noFill/>
+          <a:ln/>
+        </p:spPr>
+        <p:txBody>
+          <a:bodyPr wrap="square" lIns="0" tIns="0" rIns="0" bIns="0" rtlCol="0" anchor="t"/>
+          <a:lstStyle/>
+          <a:p>
+            <a:pPr indent="0" marL="0">
+              <a:buNone/>
+            </a:pPr>
+            <a:r>
+              <a:rPr lang="en-US" sz="2400" b="1" dirty="0">
+                <a:solidFill>
+                  <a:schemeClr val="accent3"/>
                 </a:solidFill>
                 <a:latin typeface="Cambria" pitchFamily="34" charset="0"/>
                 <a:ea typeface="Cambria" pitchFamily="34" charset="-122"/>
                 <a:cs typeface="Cambria" pitchFamily="34" charset="-120"/>
               </a:rPr>
-              <a:t>71% vs 50%</a:t>
-            </a:r>
-            <a:endParaRPr lang="en-US" sz="3000" dirty="0"/>
-          </a:p>
-        </p:txBody>
-      </p:sp>
-      <p:sp>
-        <p:nvSpPr>
-          <p:cNvPr id="12" name="Result label 3"/>
+              <a:t>1,492 µs</a:t>
+            </a:r>
+            <a:endParaRPr lang="en-US" sz="2400" dirty="0"/>
+          </a:p>
+        </p:txBody>
+      </p:sp>
+      <p:sp>
+        <p:nvSpPr>
+          <p:cNvPr id="24" name="Time label v3"/>
           <p:cNvSpPr txBox="1"/>
           <p:nvPr/>
         </p:nvSpPr>
         <p:spPr>
           <a:xfrm>
-            <a:off x="7818120" y="5294376"/>
-            <a:ext cx="3566160" cy="594360"/>
+            <a:off x="5193792" y="3822192"/>
+            <a:ext cx="1737360" cy="274320"/>
           </a:xfrm>
           <a:prstGeom prst="rect">
             <a:avLst/>
@@ -5568,14 +4819,664 @@
               <a:buNone/>
             </a:pPr>
             <a:r>
-              <a:rPr lang="en-US" sz="1300" dirty="0">
+              <a:rPr lang="en-US" sz="1100" dirty="0">
                 <a:solidFill>
                   <a:schemeClr val="tx2"/>
                 </a:solidFill>
               </a:rPr>
-              <a:t>runs that find the best: a one-line rule on our menu against the 8B model (random 38%)</a:t>
-            </a:r>
-            <a:endParaRPr lang="en-US" sz="1300" dirty="0"/>
+              <a:t>median final time</a:t>
+            </a:r>
+            <a:endParaRPr lang="en-US" sz="1100" dirty="0"/>
+          </a:p>
+        </p:txBody>
+      </p:sp>
+      <p:sp>
+        <p:nvSpPr>
+          <p:cNvPr id="25" name="Wasted v3"/>
+          <p:cNvSpPr txBox="1"/>
+          <p:nvPr/>
+        </p:nvSpPr>
+        <p:spPr>
+          <a:xfrm>
+            <a:off x="5193792" y="4160520"/>
+            <a:ext cx="1737360" cy="365760"/>
+          </a:xfrm>
+          <a:prstGeom prst="rect">
+            <a:avLst/>
+          </a:prstGeom>
+          <a:noFill/>
+          <a:ln/>
+        </p:spPr>
+        <p:txBody>
+          <a:bodyPr wrap="square" lIns="0" tIns="0" rIns="0" bIns="0" rtlCol="0" anchor="t"/>
+          <a:lstStyle/>
+          <a:p>
+            <a:pPr indent="0" marL="0">
+              <a:buNone/>
+            </a:pPr>
+            <a:r>
+              <a:rPr lang="en-US" sz="1800" b="1" dirty="0">
+                <a:solidFill>
+                  <a:schemeClr val="tx1"/>
+                </a:solidFill>
+              </a:rPr>
+              <a:t>25 of 100</a:t>
+            </a:r>
+            <a:endParaRPr lang="en-US" sz="1800" dirty="0"/>
+          </a:p>
+        </p:txBody>
+      </p:sp>
+      <p:sp>
+        <p:nvSpPr>
+          <p:cNvPr id="26" name="Wasted label v3"/>
+          <p:cNvSpPr txBox="1"/>
+          <p:nvPr/>
+        </p:nvSpPr>
+        <p:spPr>
+          <a:xfrm>
+            <a:off x="5193792" y="4526280"/>
+            <a:ext cx="1737360" cy="365760"/>
+          </a:xfrm>
+          <a:prstGeom prst="rect">
+            <a:avLst/>
+          </a:prstGeom>
+          <a:noFill/>
+          <a:ln/>
+        </p:spPr>
+        <p:txBody>
+          <a:bodyPr wrap="square" lIns="0" tIns="0" rIns="0" bIns="0" rtlCol="0" anchor="t"/>
+          <a:lstStyle/>
+          <a:p>
+            <a:pPr indent="0" marL="0">
+              <a:buNone/>
+            </a:pPr>
+            <a:r>
+              <a:rPr lang="en-US" sz="1100" dirty="0">
+                <a:solidFill>
+                  <a:schemeClr val="tx2"/>
+                </a:solidFill>
+              </a:rPr>
+              <a:t>attempts with no measurement</a:t>
+            </a:r>
+            <a:endParaRPr lang="en-US" sz="1100" dirty="0"/>
+          </a:p>
+        </p:txBody>
+      </p:sp>
+      <p:sp>
+        <p:nvSpPr>
+          <p:cNvPr id="27" name="Design card v4"/>
+          <p:cNvSpPr/>
+          <p:nvPr/>
+        </p:nvSpPr>
+        <p:spPr>
+          <a:xfrm>
+            <a:off x="7242048" y="1463040"/>
+            <a:ext cx="2084832" cy="3520440"/>
+          </a:xfrm>
+          <a:prstGeom prst="roundRect">
+            <a:avLst>
+              <a:gd name="adj" fmla="val 3509"/>
+            </a:avLst>
+          </a:prstGeom>
+          <a:solidFill>
+            <a:schemeClr val="bg2"/>
+          </a:solidFill>
+          <a:ln w="12700">
+            <a:solidFill>
+              <a:schemeClr val="bg2"/>
+            </a:solidFill>
+            <a:prstDash val="solid"/>
+          </a:ln>
+        </p:spPr>
+      </p:sp>
+      <p:sp>
+        <p:nvSpPr>
+          <p:cNvPr id="28" name="Badge v4"/>
+          <p:cNvSpPr/>
+          <p:nvPr/>
+        </p:nvSpPr>
+        <p:spPr>
+          <a:xfrm>
+            <a:off x="7424928" y="1645920"/>
+            <a:ext cx="640080" cy="640080"/>
+          </a:xfrm>
+          <a:prstGeom prst="ellipse">
+            <a:avLst/>
+          </a:prstGeom>
+          <a:solidFill>
+            <a:schemeClr val="accent1"/>
+          </a:solidFill>
+          <a:ln w="12700">
+            <a:solidFill>
+              <a:schemeClr val="accent1"/>
+            </a:solidFill>
+            <a:prstDash val="solid"/>
+          </a:ln>
+        </p:spPr>
+      </p:sp>
+      <p:sp>
+        <p:nvSpPr>
+          <p:cNvPr id="29" name="Badge text v4"/>
+          <p:cNvSpPr txBox="1"/>
+          <p:nvPr/>
+        </p:nvSpPr>
+        <p:spPr>
+          <a:xfrm>
+            <a:off x="7424928" y="1645920"/>
+            <a:ext cx="640080" cy="640080"/>
+          </a:xfrm>
+          <a:prstGeom prst="rect">
+            <a:avLst/>
+          </a:prstGeom>
+          <a:noFill/>
+          <a:ln/>
+        </p:spPr>
+        <p:txBody>
+          <a:bodyPr wrap="square" lIns="0" tIns="0" rIns="0" bIns="0" rtlCol="0" anchor="ctr"/>
+          <a:lstStyle/>
+          <a:p>
+            <a:pPr algn="ctr" indent="0" marL="0">
+              <a:buNone/>
+            </a:pPr>
+            <a:r>
+              <a:rPr lang="en-US" sz="1800" b="1" dirty="0">
+                <a:solidFill>
+                  <a:schemeClr val="bg1"/>
+                </a:solidFill>
+              </a:rPr>
+              <a:t>v4</a:t>
+            </a:r>
+            <a:endParaRPr lang="en-US" sz="1800" dirty="0"/>
+          </a:p>
+        </p:txBody>
+      </p:sp>
+      <p:sp>
+        <p:nvSpPr>
+          <p:cNvPr id="30" name="Shown v4"/>
+          <p:cNvSpPr txBox="1"/>
+          <p:nvPr/>
+        </p:nvSpPr>
+        <p:spPr>
+          <a:xfrm>
+            <a:off x="7424928" y="2423160"/>
+            <a:ext cx="1737360" cy="914400"/>
+          </a:xfrm>
+          <a:prstGeom prst="rect">
+            <a:avLst/>
+          </a:prstGeom>
+          <a:noFill/>
+          <a:ln/>
+        </p:spPr>
+        <p:txBody>
+          <a:bodyPr wrap="square" lIns="0" tIns="0" rIns="0" bIns="0" rtlCol="0" anchor="t"/>
+          <a:lstStyle/>
+          <a:p>
+            <a:pPr indent="0" marL="0">
+              <a:buNone/>
+            </a:pPr>
+            <a:r>
+              <a:rPr lang="en-US" sz="1500" b="1" dirty="0">
+                <a:solidFill>
+                  <a:schemeClr val="tx1"/>
+                </a:solidFill>
+              </a:rPr>
+              <a:t>v3, and the edit is checked first</a:t>
+            </a:r>
+            <a:endParaRPr lang="en-US" sz="1500" dirty="0"/>
+          </a:p>
+        </p:txBody>
+      </p:sp>
+      <p:sp>
+        <p:nvSpPr>
+          <p:cNvPr id="31" name="Time v4"/>
+          <p:cNvSpPr txBox="1"/>
+          <p:nvPr/>
+        </p:nvSpPr>
+        <p:spPr>
+          <a:xfrm>
+            <a:off x="7424928" y="3383280"/>
+            <a:ext cx="1737360" cy="457200"/>
+          </a:xfrm>
+          <a:prstGeom prst="rect">
+            <a:avLst/>
+          </a:prstGeom>
+          <a:noFill/>
+          <a:ln/>
+        </p:spPr>
+        <p:txBody>
+          <a:bodyPr wrap="square" lIns="0" tIns="0" rIns="0" bIns="0" rtlCol="0" anchor="t"/>
+          <a:lstStyle/>
+          <a:p>
+            <a:pPr indent="0" marL="0">
+              <a:buNone/>
+            </a:pPr>
+            <a:r>
+              <a:rPr lang="en-US" sz="2400" b="1" dirty="0">
+                <a:solidFill>
+                  <a:schemeClr val="accent1"/>
+                </a:solidFill>
+                <a:latin typeface="Cambria" pitchFamily="34" charset="0"/>
+                <a:ea typeface="Cambria" pitchFamily="34" charset="-122"/>
+                <a:cs typeface="Cambria" pitchFamily="34" charset="-120"/>
+              </a:rPr>
+              <a:t>1,495 µs</a:t>
+            </a:r>
+            <a:endParaRPr lang="en-US" sz="2400" dirty="0"/>
+          </a:p>
+        </p:txBody>
+      </p:sp>
+      <p:sp>
+        <p:nvSpPr>
+          <p:cNvPr id="32" name="Time label v4"/>
+          <p:cNvSpPr txBox="1"/>
+          <p:nvPr/>
+        </p:nvSpPr>
+        <p:spPr>
+          <a:xfrm>
+            <a:off x="7424928" y="3822192"/>
+            <a:ext cx="1737360" cy="274320"/>
+          </a:xfrm>
+          <a:prstGeom prst="rect">
+            <a:avLst/>
+          </a:prstGeom>
+          <a:noFill/>
+          <a:ln/>
+        </p:spPr>
+        <p:txBody>
+          <a:bodyPr wrap="square" lIns="0" tIns="0" rIns="0" bIns="0" rtlCol="0" anchor="t"/>
+          <a:lstStyle/>
+          <a:p>
+            <a:pPr indent="0" marL="0">
+              <a:buNone/>
+            </a:pPr>
+            <a:r>
+              <a:rPr lang="en-US" sz="1100" dirty="0">
+                <a:solidFill>
+                  <a:schemeClr val="tx2"/>
+                </a:solidFill>
+              </a:rPr>
+              <a:t>median final time</a:t>
+            </a:r>
+            <a:endParaRPr lang="en-US" sz="1100" dirty="0"/>
+          </a:p>
+        </p:txBody>
+      </p:sp>
+      <p:sp>
+        <p:nvSpPr>
+          <p:cNvPr id="33" name="Wasted v4"/>
+          <p:cNvSpPr txBox="1"/>
+          <p:nvPr/>
+        </p:nvSpPr>
+        <p:spPr>
+          <a:xfrm>
+            <a:off x="7424928" y="4160520"/>
+            <a:ext cx="1737360" cy="365760"/>
+          </a:xfrm>
+          <a:prstGeom prst="rect">
+            <a:avLst/>
+          </a:prstGeom>
+          <a:noFill/>
+          <a:ln/>
+        </p:spPr>
+        <p:txBody>
+          <a:bodyPr wrap="square" lIns="0" tIns="0" rIns="0" bIns="0" rtlCol="0" anchor="t"/>
+          <a:lstStyle/>
+          <a:p>
+            <a:pPr indent="0" marL="0">
+              <a:buNone/>
+            </a:pPr>
+            <a:r>
+              <a:rPr lang="en-US" sz="1800" b="1" dirty="0">
+                <a:solidFill>
+                  <a:schemeClr val="tx1"/>
+                </a:solidFill>
+              </a:rPr>
+              <a:t>2 of 100</a:t>
+            </a:r>
+            <a:endParaRPr lang="en-US" sz="1800" dirty="0"/>
+          </a:p>
+        </p:txBody>
+      </p:sp>
+      <p:sp>
+        <p:nvSpPr>
+          <p:cNvPr id="34" name="Wasted label v4"/>
+          <p:cNvSpPr txBox="1"/>
+          <p:nvPr/>
+        </p:nvSpPr>
+        <p:spPr>
+          <a:xfrm>
+            <a:off x="7424928" y="4526280"/>
+            <a:ext cx="1737360" cy="365760"/>
+          </a:xfrm>
+          <a:prstGeom prst="rect">
+            <a:avLst/>
+          </a:prstGeom>
+          <a:noFill/>
+          <a:ln/>
+        </p:spPr>
+        <p:txBody>
+          <a:bodyPr wrap="square" lIns="0" tIns="0" rIns="0" bIns="0" rtlCol="0" anchor="t"/>
+          <a:lstStyle/>
+          <a:p>
+            <a:pPr indent="0" marL="0">
+              <a:buNone/>
+            </a:pPr>
+            <a:r>
+              <a:rPr lang="en-US" sz="1100" dirty="0">
+                <a:solidFill>
+                  <a:schemeClr val="tx2"/>
+                </a:solidFill>
+              </a:rPr>
+              <a:t>attempts with no measurement</a:t>
+            </a:r>
+            <a:endParaRPr lang="en-US" sz="1100" dirty="0"/>
+          </a:p>
+        </p:txBody>
+      </p:sp>
+      <p:sp>
+        <p:nvSpPr>
+          <p:cNvPr id="35" name="Design card v5"/>
+          <p:cNvSpPr/>
+          <p:nvPr/>
+        </p:nvSpPr>
+        <p:spPr>
+          <a:xfrm>
+            <a:off x="9473184" y="1463040"/>
+            <a:ext cx="2084832" cy="3520440"/>
+          </a:xfrm>
+          <a:prstGeom prst="roundRect">
+            <a:avLst>
+              <a:gd name="adj" fmla="val 3509"/>
+            </a:avLst>
+          </a:prstGeom>
+          <a:solidFill>
+            <a:schemeClr val="bg2"/>
+          </a:solidFill>
+          <a:ln w="12700">
+            <a:solidFill>
+              <a:schemeClr val="bg2"/>
+            </a:solidFill>
+            <a:prstDash val="solid"/>
+          </a:ln>
+        </p:spPr>
+      </p:sp>
+      <p:sp>
+        <p:nvSpPr>
+          <p:cNvPr id="36" name="Badge v5"/>
+          <p:cNvSpPr/>
+          <p:nvPr/>
+        </p:nvSpPr>
+        <p:spPr>
+          <a:xfrm>
+            <a:off x="9656064" y="1645920"/>
+            <a:ext cx="640080" cy="640080"/>
+          </a:xfrm>
+          <a:prstGeom prst="ellipse">
+            <a:avLst/>
+          </a:prstGeom>
+          <a:solidFill>
+            <a:schemeClr val="accent1"/>
+          </a:solidFill>
+          <a:ln w="12700">
+            <a:solidFill>
+              <a:schemeClr val="accent1"/>
+            </a:solidFill>
+            <a:prstDash val="solid"/>
+          </a:ln>
+        </p:spPr>
+      </p:sp>
+      <p:sp>
+        <p:nvSpPr>
+          <p:cNvPr id="37" name="Badge text v5"/>
+          <p:cNvSpPr txBox="1"/>
+          <p:nvPr/>
+        </p:nvSpPr>
+        <p:spPr>
+          <a:xfrm>
+            <a:off x="9656064" y="1645920"/>
+            <a:ext cx="640080" cy="640080"/>
+          </a:xfrm>
+          <a:prstGeom prst="rect">
+            <a:avLst/>
+          </a:prstGeom>
+          <a:noFill/>
+          <a:ln/>
+        </p:spPr>
+        <p:txBody>
+          <a:bodyPr wrap="square" lIns="0" tIns="0" rIns="0" bIns="0" rtlCol="0" anchor="ctr"/>
+          <a:lstStyle/>
+          <a:p>
+            <a:pPr algn="ctr" indent="0" marL="0">
+              <a:buNone/>
+            </a:pPr>
+            <a:r>
+              <a:rPr lang="en-US" sz="1800" b="1" dirty="0">
+                <a:solidFill>
+                  <a:schemeClr val="bg1"/>
+                </a:solidFill>
+              </a:rPr>
+              <a:t>v5</a:t>
+            </a:r>
+            <a:endParaRPr lang="en-US" sz="1800" dirty="0"/>
+          </a:p>
+        </p:txBody>
+      </p:sp>
+      <p:sp>
+        <p:nvSpPr>
+          <p:cNvPr id="38" name="Shown v5"/>
+          <p:cNvSpPr txBox="1"/>
+          <p:nvPr/>
+        </p:nvSpPr>
+        <p:spPr>
+          <a:xfrm>
+            <a:off x="9656064" y="2423160"/>
+            <a:ext cx="1737360" cy="914400"/>
+          </a:xfrm>
+          <a:prstGeom prst="rect">
+            <a:avLst/>
+          </a:prstGeom>
+          <a:noFill/>
+          <a:ln/>
+        </p:spPr>
+        <p:txBody>
+          <a:bodyPr wrap="square" lIns="0" tIns="0" rIns="0" bIns="0" rtlCol="0" anchor="t"/>
+          <a:lstStyle/>
+          <a:p>
+            <a:pPr indent="0" marL="0">
+              <a:buNone/>
+            </a:pPr>
+            <a:r>
+              <a:rPr lang="en-US" sz="1500" b="1" dirty="0">
+                <a:solidFill>
+                  <a:schemeClr val="tx1"/>
+                </a:solidFill>
+              </a:rPr>
+              <a:t>v4, with far moves; names its move</a:t>
+            </a:r>
+            <a:endParaRPr lang="en-US" sz="1500" dirty="0"/>
+          </a:p>
+        </p:txBody>
+      </p:sp>
+      <p:sp>
+        <p:nvSpPr>
+          <p:cNvPr id="39" name="Time v5"/>
+          <p:cNvSpPr txBox="1"/>
+          <p:nvPr/>
+        </p:nvSpPr>
+        <p:spPr>
+          <a:xfrm>
+            <a:off x="9656064" y="3383280"/>
+            <a:ext cx="1737360" cy="457200"/>
+          </a:xfrm>
+          <a:prstGeom prst="rect">
+            <a:avLst/>
+          </a:prstGeom>
+          <a:noFill/>
+          <a:ln/>
+        </p:spPr>
+        <p:txBody>
+          <a:bodyPr wrap="square" lIns="0" tIns="0" rIns="0" bIns="0" rtlCol="0" anchor="t"/>
+          <a:lstStyle/>
+          <a:p>
+            <a:pPr indent="0" marL="0">
+              <a:buNone/>
+            </a:pPr>
+            <a:r>
+              <a:rPr lang="en-US" sz="2400" b="1" dirty="0">
+                <a:solidFill>
+                  <a:schemeClr val="accent1"/>
+                </a:solidFill>
+                <a:latin typeface="Cambria" pitchFamily="34" charset="0"/>
+                <a:ea typeface="Cambria" pitchFamily="34" charset="-122"/>
+                <a:cs typeface="Cambria" pitchFamily="34" charset="-120"/>
+              </a:rPr>
+              <a:t>1,494 µs</a:t>
+            </a:r>
+            <a:endParaRPr lang="en-US" sz="2400" dirty="0"/>
+          </a:p>
+        </p:txBody>
+      </p:sp>
+      <p:sp>
+        <p:nvSpPr>
+          <p:cNvPr id="40" name="Time label v5"/>
+          <p:cNvSpPr txBox="1"/>
+          <p:nvPr/>
+        </p:nvSpPr>
+        <p:spPr>
+          <a:xfrm>
+            <a:off x="9656064" y="3822192"/>
+            <a:ext cx="1737360" cy="274320"/>
+          </a:xfrm>
+          <a:prstGeom prst="rect">
+            <a:avLst/>
+          </a:prstGeom>
+          <a:noFill/>
+          <a:ln/>
+        </p:spPr>
+        <p:txBody>
+          <a:bodyPr wrap="square" lIns="0" tIns="0" rIns="0" bIns="0" rtlCol="0" anchor="t"/>
+          <a:lstStyle/>
+          <a:p>
+            <a:pPr indent="0" marL="0">
+              <a:buNone/>
+            </a:pPr>
+            <a:r>
+              <a:rPr lang="en-US" sz="1100" dirty="0">
+                <a:solidFill>
+                  <a:schemeClr val="tx2"/>
+                </a:solidFill>
+              </a:rPr>
+              <a:t>median final time</a:t>
+            </a:r>
+            <a:endParaRPr lang="en-US" sz="1100" dirty="0"/>
+          </a:p>
+        </p:txBody>
+      </p:sp>
+      <p:sp>
+        <p:nvSpPr>
+          <p:cNvPr id="41" name="Wasted v5"/>
+          <p:cNvSpPr txBox="1"/>
+          <p:nvPr/>
+        </p:nvSpPr>
+        <p:spPr>
+          <a:xfrm>
+            <a:off x="9656064" y="4160520"/>
+            <a:ext cx="1737360" cy="365760"/>
+          </a:xfrm>
+          <a:prstGeom prst="rect">
+            <a:avLst/>
+          </a:prstGeom>
+          <a:noFill/>
+          <a:ln/>
+        </p:spPr>
+        <p:txBody>
+          <a:bodyPr wrap="square" lIns="0" tIns="0" rIns="0" bIns="0" rtlCol="0" anchor="t"/>
+          <a:lstStyle/>
+          <a:p>
+            <a:pPr indent="0" marL="0">
+              <a:buNone/>
+            </a:pPr>
+            <a:r>
+              <a:rPr lang="en-US" sz="1800" b="1" dirty="0">
+                <a:solidFill>
+                  <a:schemeClr val="tx1"/>
+                </a:solidFill>
+              </a:rPr>
+              <a:t>0 of 100</a:t>
+            </a:r>
+            <a:endParaRPr lang="en-US" sz="1800" dirty="0"/>
+          </a:p>
+        </p:txBody>
+      </p:sp>
+      <p:sp>
+        <p:nvSpPr>
+          <p:cNvPr id="42" name="Wasted label v5"/>
+          <p:cNvSpPr txBox="1"/>
+          <p:nvPr/>
+        </p:nvSpPr>
+        <p:spPr>
+          <a:xfrm>
+            <a:off x="9656064" y="4526280"/>
+            <a:ext cx="1737360" cy="365760"/>
+          </a:xfrm>
+          <a:prstGeom prst="rect">
+            <a:avLst/>
+          </a:prstGeom>
+          <a:noFill/>
+          <a:ln/>
+        </p:spPr>
+        <p:txBody>
+          <a:bodyPr wrap="square" lIns="0" tIns="0" rIns="0" bIns="0" rtlCol="0" anchor="t"/>
+          <a:lstStyle/>
+          <a:p>
+            <a:pPr indent="0" marL="0">
+              <a:buNone/>
+            </a:pPr>
+            <a:r>
+              <a:rPr lang="en-US" sz="1100" dirty="0">
+                <a:solidFill>
+                  <a:schemeClr val="tx2"/>
+                </a:solidFill>
+              </a:rPr>
+              <a:t>attempts with no measurement</a:t>
+            </a:r>
+            <a:endParaRPr lang="en-US" sz="1100" dirty="0"/>
+          </a:p>
+        </p:txBody>
+      </p:sp>
+      <p:sp>
+        <p:nvSpPr>
+          <p:cNvPr id="43" name="Design caption"/>
+          <p:cNvSpPr txBox="1"/>
+          <p:nvPr/>
+        </p:nvSpPr>
+        <p:spPr>
+          <a:xfrm>
+            <a:off x="548640" y="5257800"/>
+            <a:ext cx="11064240" cy="731520"/>
+          </a:xfrm>
+          <a:prstGeom prst="rect">
+            <a:avLst/>
+          </a:prstGeom>
+          <a:noFill/>
+          <a:ln/>
+        </p:spPr>
+        <p:txBody>
+          <a:bodyPr wrap="square" lIns="0" tIns="0" rIns="0" bIns="0" rtlCol="0" anchor="t"/>
+          <a:lstStyle/>
+          <a:p>
+            <a:pPr indent="0" marL="0">
+              <a:buNone/>
+            </a:pPr>
+            <a:r>
+              <a:rPr lang="en-US" sz="1500" dirty="0">
+                <a:solidFill>
+                  <a:schemeClr val="tx2"/>
+                </a:solidFill>
+              </a:rPr>
+              <a:t>Each design fixes a failure we read in the previous one's log. The model, Qwen3-8B, never changed. Adapter-style shape, 10 starting points: best possible 1,361 µs, random guessing 1,467 µs.</a:t>
+            </a:r>
+            <a:endParaRPr lang="en-US" sz="1500" dirty="0"/>
           </a:p>
         </p:txBody>
       </p:sp>
@@ -5681,54 +5582,112 @@
                   <a:schemeClr val="tx1"/>
                 </a:solidFill>
               </a:rPr>
-              <a:t>Tuned, the kernel is level with AWS's compiler</a:t>
+              <a:t>What we got: the checker decides, not the model</a:t>
             </a:r>
             <a:endParaRPr lang="en-US" sz="3600" dirty="0"/>
           </a:p>
         </p:txBody>
       </p:sp>
-      <p:graphicFrame>
-        <p:nvGraphicFramePr>
-          <p:cNvPr id="3" name="Chart: 32-bit layer totals" descr=""/>
-          <p:cNvGraphicFramePr/>
-          <p:nvPr/>
-        </p:nvGraphicFramePr>
-        <p:xfrm>
-          <a:off x="548640" y="1417320"/>
-          <a:ext cx="5486400" cy="3931920"/>
-        </p:xfrm>
-        <a:graphic xmlns:a="http://schemas.openxmlformats.org/drawingml/2006/main">
-          <a:graphicData uri="http://schemas.openxmlformats.org/drawingml/2006/chart">
-            <c:chart xmlns:c="http://schemas.openxmlformats.org/drawingml/2006/chart" r:id="rId1"/>
-          </a:graphicData>
-        </a:graphic>
-      </p:graphicFrame>
-      <p:graphicFrame>
-        <p:nvGraphicFramePr>
-          <p:cNvPr id="4" name="Chart: 16-bit feed-forward block" descr=""/>
-          <p:cNvGraphicFramePr/>
-          <p:nvPr/>
-        </p:nvGraphicFramePr>
-        <p:xfrm>
-          <a:off x="6172200" y="1417320"/>
-          <a:ext cx="5486400" cy="3931920"/>
-        </p:xfrm>
-        <a:graphic xmlns:a="http://schemas.openxmlformats.org/drawingml/2006/main">
-          <a:graphicData uri="http://schemas.openxmlformats.org/drawingml/2006/chart">
-            <c:chart xmlns:c="http://schemas.openxmlformats.org/drawingml/2006/chart" r:id="rId2"/>
-          </a:graphicData>
-        </a:graphic>
-      </p:graphicFrame>
-      <p:sp>
-        <p:nvSpPr>
-          <p:cNvPr id="5" name="Chart caption"/>
+      <p:pic>
+        <p:nvPicPr>
+          <p:cNvPr id="3" name="Chart: best time against attempts, 30 starts" descr="Line chart of best kernel time found against attempts on the chip, for each approach, at the adapter shape">    </p:cNvPr>
+          <p:cNvPicPr>
+            <a:picLocks noChangeAspect="1"/>
+          </p:cNvPicPr>
+          <p:nvPr/>
+        </p:nvPicPr>
+        <p:blipFill>
+          <a:blip r:embed="rId1"/>
+          <a:stretch>
+            <a:fillRect/>
+          </a:stretch>
+        </p:blipFill>
+        <p:spPr>
+          <a:xfrm>
+            <a:off x="548640" y="1417320"/>
+            <a:ext cx="6766560" cy="4663440"/>
+          </a:xfrm>
+          <a:prstGeom prst="rect">
+            <a:avLst/>
+          </a:prstGeom>
+        </p:spPr>
+      </p:pic>
+      <p:sp>
+        <p:nvSpPr>
+          <p:cNvPr id="4" name="Result card 1"/>
+          <p:cNvSpPr/>
+          <p:nvPr/>
+        </p:nvSpPr>
+        <p:spPr>
+          <a:xfrm>
+            <a:off x="7589520" y="1417320"/>
+            <a:ext cx="4023360" cy="1417320"/>
+          </a:xfrm>
+          <a:prstGeom prst="roundRect">
+            <a:avLst>
+              <a:gd name="adj" fmla="val 5161"/>
+            </a:avLst>
+          </a:prstGeom>
+          <a:solidFill>
+            <a:schemeClr val="bg2"/>
+          </a:solidFill>
+          <a:ln w="12700">
+            <a:solidFill>
+              <a:schemeClr val="bg2"/>
+            </a:solidFill>
+            <a:prstDash val="solid"/>
+          </a:ln>
+        </p:spPr>
+      </p:sp>
+      <p:sp>
+        <p:nvSpPr>
+          <p:cNvPr id="5" name="Result 1"/>
           <p:cNvSpPr txBox="1"/>
           <p:nvPr/>
         </p:nvSpPr>
         <p:spPr>
           <a:xfrm>
-            <a:off x="548640" y="5440680"/>
-            <a:ext cx="11064240" cy="777240"/>
+            <a:off x="7818120" y="1554480"/>
+            <a:ext cx="3566160" cy="566928"/>
+          </a:xfrm>
+          <a:prstGeom prst="rect">
+            <a:avLst/>
+          </a:prstGeom>
+          <a:noFill/>
+          <a:ln/>
+        </p:spPr>
+        <p:txBody>
+          <a:bodyPr wrap="square" lIns="0" tIns="0" rIns="0" bIns="0" rtlCol="0" anchor="ctr"/>
+          <a:lstStyle/>
+          <a:p>
+            <a:pPr indent="0" marL="0">
+              <a:buNone/>
+            </a:pPr>
+            <a:r>
+              <a:rPr lang="en-US" sz="3000" b="1" dirty="0">
+                <a:solidFill>
+                  <a:schemeClr val="accent1"/>
+                </a:solidFill>
+                <a:latin typeface="Cambria" pitchFamily="34" charset="0"/>
+                <a:ea typeface="Cambria" pitchFamily="34" charset="-122"/>
+                <a:cs typeface="Cambria" pitchFamily="34" charset="-120"/>
+              </a:rPr>
+              <a:t>3 → 29 of 30</a:t>
+            </a:r>
+            <a:endParaRPr lang="en-US" sz="3000" dirty="0"/>
+          </a:p>
+        </p:txBody>
+      </p:sp>
+      <p:sp>
+        <p:nvSpPr>
+          <p:cNvPr id="6" name="Result label 1"/>
+          <p:cNvSpPr txBox="1"/>
+          <p:nvPr/>
+        </p:nvSpPr>
+        <p:spPr>
+          <a:xfrm>
+            <a:off x="7818120" y="2148840"/>
+            <a:ext cx="3566160" cy="594360"/>
           </a:xfrm>
           <a:prstGeom prst="rect">
             <a:avLst/>
@@ -5744,14 +5703,218 @@
               <a:buNone/>
             </a:pPr>
             <a:r>
-              <a:rPr lang="en-US" sz="1400" dirty="0">
+              <a:rPr lang="en-US" sz="1300" dirty="0">
                 <a:solidFill>
                   <a:schemeClr val="tx2"/>
                 </a:solidFill>
               </a:rPr>
-              <a:t>Left: sums of standalone kernel times, one loop run per layer shape. Right: a small model with random weights at Qwen3-8B's sizes; tuned bar is the median of five loop runs (2.86 to 2.89 ms). Level with the compiler at 32-bit, 4% to 5% behind at 16-bit.</a:t>
-            </a:r>
-            <a:endParaRPr lang="en-US" sz="1400" dirty="0"/>
+              <a:t>runs within 10% of the best, first checker to last, same model</a:t>
+            </a:r>
+            <a:endParaRPr lang="en-US" sz="1300" dirty="0"/>
+          </a:p>
+        </p:txBody>
+      </p:sp>
+      <p:sp>
+        <p:nvSpPr>
+          <p:cNvPr id="7" name="Result card 2"/>
+          <p:cNvSpPr/>
+          <p:nvPr/>
+        </p:nvSpPr>
+        <p:spPr>
+          <a:xfrm>
+            <a:off x="7589520" y="2990088"/>
+            <a:ext cx="4023360" cy="1417320"/>
+          </a:xfrm>
+          <a:prstGeom prst="roundRect">
+            <a:avLst>
+              <a:gd name="adj" fmla="val 5161"/>
+            </a:avLst>
+          </a:prstGeom>
+          <a:solidFill>
+            <a:schemeClr val="bg2"/>
+          </a:solidFill>
+          <a:ln w="12700">
+            <a:solidFill>
+              <a:schemeClr val="bg2"/>
+            </a:solidFill>
+            <a:prstDash val="solid"/>
+          </a:ln>
+        </p:spPr>
+      </p:sp>
+      <p:sp>
+        <p:nvSpPr>
+          <p:cNvPr id="8" name="Result 2"/>
+          <p:cNvSpPr txBox="1"/>
+          <p:nvPr/>
+        </p:nvSpPr>
+        <p:spPr>
+          <a:xfrm>
+            <a:off x="7818120" y="3127248"/>
+            <a:ext cx="3566160" cy="566928"/>
+          </a:xfrm>
+          <a:prstGeom prst="rect">
+            <a:avLst/>
+          </a:prstGeom>
+          <a:noFill/>
+          <a:ln/>
+        </p:spPr>
+        <p:txBody>
+          <a:bodyPr wrap="square" lIns="0" tIns="0" rIns="0" bIns="0" rtlCol="0" anchor="ctr"/>
+          <a:lstStyle/>
+          <a:p>
+            <a:pPr indent="0" marL="0">
+              <a:buNone/>
+            </a:pPr>
+            <a:r>
+              <a:rPr lang="en-US" sz="3000" b="1" dirty="0">
+                <a:solidFill>
+                  <a:schemeClr val="accent3"/>
+                </a:solidFill>
+                <a:latin typeface="Cambria" pitchFamily="34" charset="0"/>
+                <a:ea typeface="Cambria" pitchFamily="34" charset="-122"/>
+                <a:cs typeface="Cambria" pitchFamily="34" charset="-120"/>
+              </a:rPr>
+              <a:t>73%</a:t>
+            </a:r>
+            <a:endParaRPr lang="en-US" sz="3000" dirty="0"/>
+          </a:p>
+        </p:txBody>
+      </p:sp>
+      <p:sp>
+        <p:nvSpPr>
+          <p:cNvPr id="9" name="Result label 2"/>
+          <p:cNvSpPr txBox="1"/>
+          <p:nvPr/>
+        </p:nvSpPr>
+        <p:spPr>
+          <a:xfrm>
+            <a:off x="7818120" y="3721608"/>
+            <a:ext cx="3566160" cy="594360"/>
+          </a:xfrm>
+          <a:prstGeom prst="rect">
+            <a:avLst/>
+          </a:prstGeom>
+          <a:noFill/>
+          <a:ln/>
+        </p:spPr>
+        <p:txBody>
+          <a:bodyPr wrap="square" lIns="0" tIns="0" rIns="0" bIns="0" rtlCol="0" anchor="t"/>
+          <a:lstStyle/>
+          <a:p>
+            <a:pPr indent="0" marL="0">
+              <a:buNone/>
+            </a:pPr>
+            <a:r>
+              <a:rPr lang="en-US" sz="1300" dirty="0">
+                <a:solidFill>
+                  <a:schemeClr val="tx2"/>
+                </a:solidFill>
+              </a:rPr>
+              <a:t>of runs within 10% of the best for random guessing</a:t>
+            </a:r>
+            <a:endParaRPr lang="en-US" sz="1300" dirty="0"/>
+          </a:p>
+        </p:txBody>
+      </p:sp>
+      <p:sp>
+        <p:nvSpPr>
+          <p:cNvPr id="10" name="Result card 3"/>
+          <p:cNvSpPr/>
+          <p:nvPr/>
+        </p:nvSpPr>
+        <p:spPr>
+          <a:xfrm>
+            <a:off x="7589520" y="4562856"/>
+            <a:ext cx="4023360" cy="1417320"/>
+          </a:xfrm>
+          <a:prstGeom prst="roundRect">
+            <a:avLst>
+              <a:gd name="adj" fmla="val 5161"/>
+            </a:avLst>
+          </a:prstGeom>
+          <a:solidFill>
+            <a:schemeClr val="bg2"/>
+          </a:solidFill>
+          <a:ln w="12700">
+            <a:solidFill>
+              <a:schemeClr val="bg2"/>
+            </a:solidFill>
+            <a:prstDash val="solid"/>
+          </a:ln>
+        </p:spPr>
+      </p:sp>
+      <p:sp>
+        <p:nvSpPr>
+          <p:cNvPr id="11" name="Result 3"/>
+          <p:cNvSpPr txBox="1"/>
+          <p:nvPr/>
+        </p:nvSpPr>
+        <p:spPr>
+          <a:xfrm>
+            <a:off x="7818120" y="4700016"/>
+            <a:ext cx="3566160" cy="566928"/>
+          </a:xfrm>
+          <a:prstGeom prst="rect">
+            <a:avLst/>
+          </a:prstGeom>
+          <a:noFill/>
+          <a:ln/>
+        </p:spPr>
+        <p:txBody>
+          <a:bodyPr wrap="square" lIns="0" tIns="0" rIns="0" bIns="0" rtlCol="0" anchor="ctr"/>
+          <a:lstStyle/>
+          <a:p>
+            <a:pPr indent="0" marL="0">
+              <a:buNone/>
+            </a:pPr>
+            <a:r>
+              <a:rPr lang="en-US" sz="3000" b="1" dirty="0">
+                <a:solidFill>
+                  <a:schemeClr val="accent2"/>
+                </a:solidFill>
+                <a:latin typeface="Cambria" pitchFamily="34" charset="0"/>
+                <a:ea typeface="Cambria" pitchFamily="34" charset="-122"/>
+                <a:cs typeface="Cambria" pitchFamily="34" charset="-120"/>
+              </a:rPr>
+              <a:t>71% vs 50%</a:t>
+            </a:r>
+            <a:endParaRPr lang="en-US" sz="3000" dirty="0"/>
+          </a:p>
+        </p:txBody>
+      </p:sp>
+      <p:sp>
+        <p:nvSpPr>
+          <p:cNvPr id="12" name="Result label 3"/>
+          <p:cNvSpPr txBox="1"/>
+          <p:nvPr/>
+        </p:nvSpPr>
+        <p:spPr>
+          <a:xfrm>
+            <a:off x="7818120" y="5294376"/>
+            <a:ext cx="3566160" cy="594360"/>
+          </a:xfrm>
+          <a:prstGeom prst="rect">
+            <a:avLst/>
+          </a:prstGeom>
+          <a:noFill/>
+          <a:ln/>
+        </p:spPr>
+        <p:txBody>
+          <a:bodyPr wrap="square" lIns="0" tIns="0" rIns="0" bIns="0" rtlCol="0" anchor="t"/>
+          <a:lstStyle/>
+          <a:p>
+            <a:pPr indent="0" marL="0">
+              <a:buNone/>
+            </a:pPr>
+            <a:r>
+              <a:rPr lang="en-US" sz="1300" dirty="0">
+                <a:solidFill>
+                  <a:schemeClr val="tx2"/>
+                </a:solidFill>
+              </a:rPr>
+              <a:t>runs that find the best: a one-line rule on our menu against the 8B model (random 38%)</a:t>
+            </a:r>
+            <a:endParaRPr lang="en-US" sz="1300" dirty="0"/>
           </a:p>
         </p:txBody>
       </p:sp>
@@ -5857,6 +6020,182 @@
                   <a:schemeClr val="tx1"/>
                 </a:solidFill>
               </a:rPr>
+              <a:t>Tuned, the kernel is level with AWS's compiler</a:t>
+            </a:r>
+            <a:endParaRPr lang="en-US" sz="3600" dirty="0"/>
+          </a:p>
+        </p:txBody>
+      </p:sp>
+      <p:graphicFrame>
+        <p:nvGraphicFramePr>
+          <p:cNvPr id="3" name="Chart: 32-bit layer totals" descr=""/>
+          <p:cNvGraphicFramePr/>
+          <p:nvPr/>
+        </p:nvGraphicFramePr>
+        <p:xfrm>
+          <a:off x="548640" y="1417320"/>
+          <a:ext cx="5486400" cy="3931920"/>
+        </p:xfrm>
+        <a:graphic xmlns:a="http://schemas.openxmlformats.org/drawingml/2006/main">
+          <a:graphicData uri="http://schemas.openxmlformats.org/drawingml/2006/chart">
+            <c:chart xmlns:c="http://schemas.openxmlformats.org/drawingml/2006/chart" r:id="rId1"/>
+          </a:graphicData>
+        </a:graphic>
+      </p:graphicFrame>
+      <p:graphicFrame>
+        <p:nvGraphicFramePr>
+          <p:cNvPr id="4" name="Chart: 16-bit feed-forward block" descr=""/>
+          <p:cNvGraphicFramePr/>
+          <p:nvPr/>
+        </p:nvGraphicFramePr>
+        <p:xfrm>
+          <a:off x="6172200" y="1417320"/>
+          <a:ext cx="5486400" cy="3931920"/>
+        </p:xfrm>
+        <a:graphic xmlns:a="http://schemas.openxmlformats.org/drawingml/2006/main">
+          <a:graphicData uri="http://schemas.openxmlformats.org/drawingml/2006/chart">
+            <c:chart xmlns:c="http://schemas.openxmlformats.org/drawingml/2006/chart" r:id="rId2"/>
+          </a:graphicData>
+        </a:graphic>
+      </p:graphicFrame>
+      <p:sp>
+        <p:nvSpPr>
+          <p:cNvPr id="5" name="Chart caption"/>
+          <p:cNvSpPr txBox="1"/>
+          <p:nvPr/>
+        </p:nvSpPr>
+        <p:spPr>
+          <a:xfrm>
+            <a:off x="548640" y="5440680"/>
+            <a:ext cx="11064240" cy="777240"/>
+          </a:xfrm>
+          <a:prstGeom prst="rect">
+            <a:avLst/>
+          </a:prstGeom>
+          <a:noFill/>
+          <a:ln/>
+        </p:spPr>
+        <p:txBody>
+          <a:bodyPr wrap="square" lIns="0" tIns="0" rIns="0" bIns="0" rtlCol="0" anchor="t"/>
+          <a:lstStyle/>
+          <a:p>
+            <a:pPr indent="0" marL="0">
+              <a:buNone/>
+            </a:pPr>
+            <a:r>
+              <a:rPr lang="en-US" sz="1400" dirty="0">
+                <a:solidFill>
+                  <a:schemeClr val="tx2"/>
+                </a:solidFill>
+              </a:rPr>
+              <a:t>Left: sums of standalone kernel times, one loop run per layer shape. Right: a small model with random weights at Qwen3-8B's sizes; tuned bar is the median of five loop runs (2.86 to 2.89 ms). Level with the compiler at 32-bit, 4% to 5% behind at 16-bit.</a:t>
+            </a:r>
+            <a:endParaRPr lang="en-US" sz="1400" dirty="0"/>
+          </a:p>
+        </p:txBody>
+      </p:sp>
+      <p:sp>
+        <p:nvSpPr>
+          <p:cNvPr id="25" name="Slide Number Placeholder 0"/>
+          <p:cNvSpPr>
+            <a:spLocks noGrp="1"/>
+          </p:cNvSpPr>
+          <p:nvPr>
+            <p:ph type="sldNum" sz="quarter" idx="4294967295"/>
+          </p:nvPr>
+        </p:nvSpPr>
+        <p:spPr>
+          <a:xfrm>
+            <a:off x="11155680" y="6355080"/>
+            <a:ext cx="457200" cy="274320"/>
+          </a:xfrm>
+          <a:prstGeom prst="rect">
+            <a:avLst/>
+          </a:prstGeom>
+          <a:extLst>
+            <a:ext uri="{C572A759-6A51-4108-AA02-DFA0A04FC94B}">
+              <ma14:wrappingTextBoxFlag xmlns:ma14="http://schemas.microsoft.com/office/mac/drawingml/2011/main" val="0"/>
+            </a:ext>
+          </a:extLst>
+        </p:spPr>
+        <p:txBody>
+          <a:bodyPr/>
+          <a:lstStyle>
+            <a:lvl1pPr>
+              <a:defRPr sz="1000">
+                <a:solidFill>
+                  <a:srgbClr val="5B6B7A"/>
+                </a:solidFill>
+              </a:defRPr>
+            </a:lvl1pPr>
+          </a:lstStyle>
+          <a:p>
+            <a:pPr algn="r"/>
+            <a:fld id="{F7021451-1387-4CA6-816F-3879F97B5CBC}" type="slidenum">
+              <a:rPr b="0" lang="en-US"/>
+              <a:t>7</a:t>
+            </a:fld>
+            <a:endParaRPr lang="en-US"/>
+          </a:p>
+        </p:txBody>
+      </p:sp>
+    </p:spTree>
+  </p:cSld>
+  <p:clrMapOvr>
+    <a:masterClrMapping/>
+  </p:clrMapOvr>
+</p:sld>
+</file>
+
+<file path=ppt/slides/slide8.xml><?xml version="1.0" encoding="utf-8"?>
+<p:sld xmlns:a="http://schemas.openxmlformats.org/drawingml/2006/main" xmlns:r="http://schemas.openxmlformats.org/officeDocument/2006/relationships" xmlns:p="http://schemas.openxmlformats.org/presentationml/2006/main">
+  <p:cSld name="Slide 8">
+    <p:spTree>
+      <p:nvGrpSpPr>
+        <p:cNvPr id="1" name=""/>
+        <p:cNvGrpSpPr/>
+        <p:nvPr/>
+      </p:nvGrpSpPr>
+      <p:grpSpPr>
+        <a:xfrm>
+          <a:off x="0" y="0"/>
+          <a:ext cx="0" cy="0"/>
+          <a:chOff x="0" y="0"/>
+          <a:chExt cx="0" cy="0"/>
+        </a:xfrm>
+      </p:grpSpPr>
+      <p:sp>
+        <p:nvSpPr>
+          <p:cNvPr id="2" name="Text 0"/>
+          <p:cNvSpPr/>
+          <p:nvPr>
+            <p:ph idx="100" type="title" hasCustomPrompt="1"/>
+          </p:nvPr>
+        </p:nvSpPr>
+        <p:spPr>
+          <a:xfrm>
+            <a:off x="548640" y="411480"/>
+            <a:ext cx="11064240" cy="822960"/>
+          </a:xfrm>
+          <a:prstGeom prst="rect">
+            <a:avLst/>
+          </a:prstGeom>
+          <a:noFill/>
+          <a:ln/>
+        </p:spPr>
+        <p:txBody>
+          <a:bodyPr wrap="square" lIns="0" tIns="0" rIns="0" bIns="0" rtlCol="0" anchor="ctr"/>
+          <a:lstStyle/>
+          <a:p>
+            <a:pPr algn="l" indent="0" marL="0">
+              <a:buNone/>
+            </a:pPr>
+            <a:r>
+              <a:rPr lang="en-US" sz="3600" b="1" dirty="0">
+                <a:solidFill>
+                  <a:schemeClr val="tx1"/>
+                </a:solidFill>
+              </a:rPr>
               <a:t>What we do not claim, and what comes next</a:t>
             </a:r>
             <a:endParaRPr lang="en-US" sz="3600" dirty="0"/>
@@ -6197,7 +6536,7 @@
             <a:pPr algn="r"/>
             <a:fld id="{F7021451-1387-4CA6-816F-3879F97B5CBC}" type="slidenum">
               <a:rPr b="0" lang="en-US"/>
-              <a:t>7</a:t>
+              <a:t>8</a:t>
             </a:fld>
             <a:endParaRPr lang="en-US"/>
           </a:p>

</xml_diff>

<commit_message>
Deck: slide on the AWS profiling tools used
Co-Authored-By: Claude Opus 5.5 <noreply@anthropic.com>
</commit_message>
<xml_diff>
--- a/slides/KernelTune.pptx
+++ b/slides/KernelTune.pptx
@@ -13,9 +13,10 @@
     <p:sldId id="261" r:id="rId7"/>
     <p:sldId id="262" r:id="rId8"/>
     <p:sldId id="263" r:id="rId9"/>
+    <p:sldId id="264" r:id="rId10"/>
   </p:sldIdLst>
   <p:notesMasterIdLst>
-    <p:notesMasterId r:id="rId10"/>
+    <p:notesMasterId r:id="rId11"/>
   </p:notesMasterIdLst>
   <p:sldSz cx="12192000" cy="6858000"/>
   <p:notesSz cx="6858000" cy="12192000"/>
@@ -114,7 +115,7 @@
   <p:extLst>
     <p:ext uri="{521415D9-36F7-43E2-AB2F-B90AF26B5E84}">
       <p14:sectionLst xmlns:p14="http://schemas.microsoft.com/office/powerpoint/2010/main">
-        <p14:section name="Pitch" id="{0e5e1c13-1666-cfec-7519-7e2bb727b99e}">
+        <p14:section name="Pitch" id="{0f1aa51f-6c34-dec3-81d8-dd0b9113385d}">
           <p14:sldIdLst>
             <p14:sldId id="256"/>
             <p14:sldId id="257"/>
@@ -124,6 +125,7 @@
             <p14:sldId id="261"/>
             <p14:sldId id="262"/>
             <p14:sldId id="263"/>
+            <p14:sldId id="264"/>
           </p14:sldIdLst>
         </p14:section>
       </p14:sectionLst>
@@ -1422,7 +1424,7 @@
           <a:p>
             <a:r>
               <a:rPr lang="en-US" dirty="0"/>
-              <a:t>Version one showed the model the raw profile. It lost badly to random guessing. The checker said 'increase N to 24, that reduces data movement', the chip came back two and a half times slower, and it said it again. So we changed the message, not the model. Version two showed it comparisons worked out in code. Version three gave it a menu of moves with the measured record for each. Version four caught the second model editing a line it was not asked to touch. Version five had no wasted attempts at all.</a:t>
+              <a:t>Every time in this deck comes from AWS's own profiler. neuron-explorer capture records a hardware trace of the compiled kernel on one core, and neuron-explorer view turns it into a summary with 115 fields; we read time, how busy the tensor engine and data movement were, and bytes and transfers. NKI and the neuronx-cc compiler build and run the kernel standalone. We followed the profiling recipe from AWS's agentic skills, adapted because the pods have no torch_neuronx. We also looked at neuron-explorer recommend, AWS's Bedrock-powered advisor, in print-only mode: it sends a 155,604-character prompt and advises a person, so it is not in our loop. The pods expose no power reading, so we have no energy figures.</a:t>
             </a:r>
             <a:endParaRPr lang="en-US" dirty="0"/>
           </a:p>
@@ -1510,7 +1512,7 @@
           <a:p>
             <a:r>
               <a:rPr lang="en-US" dirty="0"/>
-              <a:t>Same model, same chip, same budget: by redesigning only what the checker says, we went from 3 good runs out of 30 to 29 out of 30. Random guessing gets 73%. Here is the part we did not expect: replace the model with a one-line rule on the same menu and it finds the best setting in 71% of runs. The 8B model manages 50%, random 38%. So the value is in the measured menu. Do not say the model beats random at finding the best: 50% against 38% is not conclusive at 30 runs.</a:t>
+              <a:t>Version one showed the model the raw profile. It lost badly to random guessing. The checker said 'increase N to 24, that reduces data movement', the chip came back two and a half times slower, and it said it again. So we changed the message, not the model. Version two showed it comparisons worked out in code. Version three gave it a menu of moves with the measured record for each. Version four caught the second model editing a line it was not asked to touch. Version five had no wasted attempts at all.</a:t>
             </a:r>
             <a:endParaRPr lang="en-US" dirty="0"/>
           </a:p>
@@ -1598,7 +1600,7 @@
           <a:p>
             <a:r>
               <a:rPr lang="en-US" dirty="0"/>
-              <a:t>We ran the loop on every linear-layer shape in Qwen3-8B and compared it with AWS's own compiler doing the same multiply with no hand-written kernel. Untuned, a hand-written kernel is 12 to 30 percent slower than the compiler. Tuned by the loop it is level with it on every layer. Then we ran the loop at 16-bit, the precision real models use, scored on real inference time. From as slow as 8.6 milliseconds, all five runs ended at about 2.9, within 5% of the compiler at 2.75. Say 'level with the compiler', never 'faster than'.</a:t>
+              <a:t>Same model, same chip, same budget: by redesigning only what the checker says, we went from 3 good runs out of 30 to 29 out of 30. Random guessing gets 73%. Here is the part we did not expect: replace the model with a one-line rule on the same menu and it finds the best setting in 71% of runs. The 8B model manages 50%, random 38%. So the value is in the measured menu. Do not say the model beats random at finding the best: 50% against 38% is not conclusive at 30 runs.</a:t>
             </a:r>
             <a:endParaRPr lang="en-US" dirty="0"/>
           </a:p>
@@ -1686,7 +1688,7 @@
           <a:p>
             <a:r>
               <a:rPr lang="en-US" dirty="0"/>
-              <a:t>What are we handing over? An on-chip checker this track did not have. Full ground truth at two shapes. And measured evidence of what a small-model loop needs: tell it what the chip measured, not what to think. We do not beat your compiler, and for matmul nobody needs to. The next step is to point KernelTune at the kernels people do write by hand, where there is no compiler version to fall back on.</a:t>
+              <a:t>We ran the loop on every linear-layer shape in Qwen3-8B and compared it with AWS's own compiler doing the same multiply with no hand-written kernel. Untuned, a hand-written kernel is 12 to 30 percent slower than the compiler. Tuned by the loop it is level with it on every layer. Then we ran the loop at 16-bit, the precision real models use, scored on real inference time. From as slow as 8.6 milliseconds, all five runs ended at about 2.9, within 5% of the compiler at 2.75. Say 'level with the compiler', never 'faster than'.</a:t>
             </a:r>
             <a:endParaRPr lang="en-US" dirty="0"/>
           </a:p>
@@ -1710,6 +1712,94 @@
             <a:fld id="{F7021451-1387-4CA6-816F-3879F97B5CBC}" type="slidenum">
               <a:rPr lang="en-US"/>
               <a:t>8</a:t>
+            </a:fld>
+            <a:endParaRPr lang="en-US"/>
+          </a:p>
+        </p:txBody>
+      </p:sp>
+    </p:spTree>
+    <p:extLst>
+      <p:ext uri="{BB962C8B-B14F-4D97-AF65-F5344CB8AC3E}">
+        <p14:creationId xmlns:p14="http://schemas.microsoft.com/office/powerpoint/2010/main" val="1024086991"/>
+      </p:ext>
+    </p:extLst>
+  </p:cSld>
+  <p:clrMapOvr>
+    <a:masterClrMapping/>
+  </p:clrMapOvr>
+</p:notes>
+</file>
+
+<file path=ppt/notesSlides/notesSlide9.xml><?xml version="1.0" encoding="utf-8"?>
+<p:notes xmlns:a="http://schemas.openxmlformats.org/drawingml/2006/main" xmlns:r="http://schemas.openxmlformats.org/officeDocument/2006/relationships" xmlns:p="http://schemas.openxmlformats.org/presentationml/2006/main">
+  <p:cSld>
+    <p:spTree>
+      <p:nvGrpSpPr>
+        <p:cNvPr id="1" name=""/>
+        <p:cNvGrpSpPr/>
+        <p:nvPr/>
+      </p:nvGrpSpPr>
+      <p:grpSpPr>
+        <a:xfrm>
+          <a:off x="0" y="0"/>
+          <a:ext cx="0" cy="0"/>
+          <a:chOff x="0" y="0"/>
+          <a:chExt cx="0" cy="0"/>
+        </a:xfrm>
+      </p:grpSpPr>
+      <p:sp>
+        <p:nvSpPr>
+          <p:cNvPr id="2" name="Slide Image Placeholder 1"/>
+          <p:cNvSpPr>
+            <a:spLocks noGrp="1" noRot="1" noChangeAspect="1"/>
+          </p:cNvSpPr>
+          <p:nvPr>
+            <p:ph type="sldImg"/>
+          </p:nvPr>
+        </p:nvSpPr>
+        <p:spPr/>
+      </p:sp>
+      <p:sp>
+        <p:nvSpPr>
+          <p:cNvPr id="3" name="Notes Placeholder 2"/>
+          <p:cNvSpPr>
+            <a:spLocks noGrp="1"/>
+          </p:cNvSpPr>
+          <p:nvPr>
+            <p:ph type="body" idx="1"/>
+          </p:nvPr>
+        </p:nvSpPr>
+        <p:spPr/>
+        <p:txBody>
+          <a:bodyPr/>
+          <a:lstStyle/>
+          <a:p>
+            <a:r>
+              <a:rPr lang="en-US" dirty="0"/>
+              <a:t>What are we handing over? An on-chip checker this track did not have. Full ground truth at two shapes. And measured evidence of what a small-model loop needs: tell it what the chip measured, not what to think. We do not beat your compiler, and for matmul nobody needs to. The next step is to point KernelTune at the kernels people do write by hand, where there is no compiler version to fall back on.</a:t>
+            </a:r>
+            <a:endParaRPr lang="en-US" dirty="0"/>
+          </a:p>
+        </p:txBody>
+      </p:sp>
+      <p:sp>
+        <p:nvSpPr>
+          <p:cNvPr id="4" name="Slide Number Placeholder 3"/>
+          <p:cNvSpPr>
+            <a:spLocks noGrp="1"/>
+          </p:cNvSpPr>
+          <p:nvPr>
+            <p:ph type="sldNum" sz="quarter" idx="10"/>
+          </p:nvPr>
+        </p:nvSpPr>
+        <p:spPr/>
+        <p:txBody>
+          <a:bodyPr/>
+          <a:lstStyle/>
+          <a:p>
+            <a:fld id="{F7021451-1387-4CA6-816F-3879F97B5CBC}" type="slidenum">
+              <a:rPr lang="en-US"/>
+              <a:t>9</a:t>
             </a:fld>
             <a:endParaRPr lang="en-US"/>
           </a:p>
@@ -4083,7 +4173,7 @@
                   <a:schemeClr val="tx1"/>
                 </a:solidFill>
               </a:rPr>
-              <a:t>What we tried: five checker designs, one model</a:t>
+              <a:t>The AWS profiling tools behind every number</a:t>
             </a:r>
             <a:endParaRPr lang="en-US" sz="3600" dirty="0"/>
           </a:p>
@@ -4091,26 +4181,24 @@
       </p:sp>
       <p:sp>
         <p:nvSpPr>
-          <p:cNvPr id="3" name="Design card v1"/>
+          <p:cNvPr id="3" name="Tool badge 1"/>
           <p:cNvSpPr/>
           <p:nvPr/>
         </p:nvSpPr>
         <p:spPr>
           <a:xfrm>
-            <a:off x="548640" y="1463040"/>
-            <a:ext cx="2084832" cy="3520440"/>
-          </a:xfrm>
-          <a:prstGeom prst="roundRect">
-            <a:avLst>
-              <a:gd name="adj" fmla="val 3509"/>
-            </a:avLst>
+            <a:off x="548640" y="1536192"/>
+            <a:ext cx="457200" cy="457200"/>
+          </a:xfrm>
+          <a:prstGeom prst="ellipse">
+            <a:avLst/>
           </a:prstGeom>
           <a:solidFill>
-            <a:schemeClr val="bg2"/>
+            <a:schemeClr val="accent1"/>
           </a:solidFill>
           <a:ln w="12700">
             <a:solidFill>
-              <a:schemeClr val="bg2"/>
+              <a:schemeClr val="accent1"/>
             </a:solidFill>
             <a:prstDash val="solid"/>
           </a:ln>
@@ -4118,24 +4206,132 @@
       </p:sp>
       <p:sp>
         <p:nvSpPr>
-          <p:cNvPr id="4" name="Badge v1"/>
+          <p:cNvPr id="4" name="Tool number 1"/>
+          <p:cNvSpPr txBox="1"/>
+          <p:nvPr/>
+        </p:nvSpPr>
+        <p:spPr>
+          <a:xfrm>
+            <a:off x="548640" y="1536192"/>
+            <a:ext cx="457200" cy="457200"/>
+          </a:xfrm>
+          <a:prstGeom prst="rect">
+            <a:avLst/>
+          </a:prstGeom>
+          <a:noFill/>
+          <a:ln/>
+        </p:spPr>
+        <p:txBody>
+          <a:bodyPr wrap="square" lIns="0" tIns="0" rIns="0" bIns="0" rtlCol="0" anchor="ctr"/>
+          <a:lstStyle/>
+          <a:p>
+            <a:pPr algn="ctr" indent="0" marL="0">
+              <a:buNone/>
+            </a:pPr>
+            <a:r>
+              <a:rPr lang="en-US" sz="1600" b="1" dirty="0">
+                <a:solidFill>
+                  <a:schemeClr val="bg1"/>
+                </a:solidFill>
+              </a:rPr>
+              <a:t>1</a:t>
+            </a:r>
+            <a:endParaRPr lang="en-US" sz="1600" dirty="0"/>
+          </a:p>
+        </p:txBody>
+      </p:sp>
+      <p:sp>
+        <p:nvSpPr>
+          <p:cNvPr id="5" name="Tool name 1"/>
+          <p:cNvSpPr txBox="1"/>
+          <p:nvPr/>
+        </p:nvSpPr>
+        <p:spPr>
+          <a:xfrm>
+            <a:off x="1188720" y="1463040"/>
+            <a:ext cx="5669280" cy="329184"/>
+          </a:xfrm>
+          <a:prstGeom prst="rect">
+            <a:avLst/>
+          </a:prstGeom>
+          <a:noFill/>
+          <a:ln/>
+        </p:spPr>
+        <p:txBody>
+          <a:bodyPr wrap="square" lIns="0" tIns="0" rIns="0" bIns="0" rtlCol="0" anchor="t"/>
+          <a:lstStyle/>
+          <a:p>
+            <a:pPr indent="0" marL="0">
+              <a:buNone/>
+            </a:pPr>
+            <a:r>
+              <a:rPr lang="en-US" sz="1700" b="1" dirty="0">
+                <a:solidFill>
+                  <a:schemeClr val="tx1"/>
+                </a:solidFill>
+              </a:rPr>
+              <a:t>neuron-explorer capture</a:t>
+            </a:r>
+            <a:endParaRPr lang="en-US" sz="1700" dirty="0"/>
+          </a:p>
+        </p:txBody>
+      </p:sp>
+      <p:sp>
+        <p:nvSpPr>
+          <p:cNvPr id="6" name="Tool use 1"/>
+          <p:cNvSpPr txBox="1"/>
+          <p:nvPr/>
+        </p:nvSpPr>
+        <p:spPr>
+          <a:xfrm>
+            <a:off x="1188720" y="1801368"/>
+            <a:ext cx="5669280" cy="530352"/>
+          </a:xfrm>
+          <a:prstGeom prst="rect">
+            <a:avLst/>
+          </a:prstGeom>
+          <a:noFill/>
+          <a:ln/>
+        </p:spPr>
+        <p:txBody>
+          <a:bodyPr wrap="square" lIns="0" tIns="0" rIns="0" bIns="0" rtlCol="0" anchor="t"/>
+          <a:lstStyle/>
+          <a:p>
+            <a:pPr indent="0" marL="0">
+              <a:buNone/>
+            </a:pPr>
+            <a:r>
+              <a:rPr lang="en-US" sz="1400" dirty="0">
+                <a:solidFill>
+                  <a:schemeClr val="tx2"/>
+                </a:solidFill>
+              </a:rPr>
+              <a:t>Records a hardware trace of the compiled kernel on one NeuronCore. We take the median of three captures.</a:t>
+            </a:r>
+            <a:endParaRPr lang="en-US" sz="1400" dirty="0"/>
+          </a:p>
+        </p:txBody>
+      </p:sp>
+      <p:sp>
+        <p:nvSpPr>
+          <p:cNvPr id="7" name="Tool badge 2"/>
           <p:cNvSpPr/>
           <p:nvPr/>
         </p:nvSpPr>
         <p:spPr>
           <a:xfrm>
-            <a:off x="731520" y="1645920"/>
-            <a:ext cx="640080" cy="640080"/>
+            <a:off x="548640" y="2468880"/>
+            <a:ext cx="457200" cy="457200"/>
           </a:xfrm>
           <a:prstGeom prst="ellipse">
             <a:avLst/>
           </a:prstGeom>
           <a:solidFill>
-            <a:schemeClr val="accent4"/>
+            <a:schemeClr val="accent1"/>
           </a:solidFill>
           <a:ln w="12700">
             <a:solidFill>
-              <a:schemeClr val="accent4"/>
+              <a:schemeClr val="accent1"/>
             </a:solidFill>
             <a:prstDash val="solid"/>
           </a:ln>
@@ -4143,14 +4339,14 @@
       </p:sp>
       <p:sp>
         <p:nvSpPr>
-          <p:cNvPr id="5" name="Badge text v1"/>
-          <p:cNvSpPr txBox="1"/>
-          <p:nvPr/>
-        </p:nvSpPr>
-        <p:spPr>
-          <a:xfrm>
-            <a:off x="731520" y="1645920"/>
-            <a:ext cx="640080" cy="640080"/>
+          <p:cNvPr id="8" name="Tool number 2"/>
+          <p:cNvSpPr txBox="1"/>
+          <p:nvPr/>
+        </p:nvSpPr>
+        <p:spPr>
+          <a:xfrm>
+            <a:off x="548640" y="2468880"/>
+            <a:ext cx="457200" cy="457200"/>
           </a:xfrm>
           <a:prstGeom prst="rect">
             <a:avLst/>
@@ -4166,27 +4362,27 @@
               <a:buNone/>
             </a:pPr>
             <a:r>
-              <a:rPr lang="en-US" sz="1800" b="1" dirty="0">
+              <a:rPr lang="en-US" sz="1600" b="1" dirty="0">
                 <a:solidFill>
                   <a:schemeClr val="bg1"/>
                 </a:solidFill>
               </a:rPr>
-              <a:t>v1</a:t>
-            </a:r>
-            <a:endParaRPr lang="en-US" sz="1800" dirty="0"/>
-          </a:p>
-        </p:txBody>
-      </p:sp>
-      <p:sp>
-        <p:nvSpPr>
-          <p:cNvPr id="6" name="Shown v1"/>
-          <p:cNvSpPr txBox="1"/>
-          <p:nvPr/>
-        </p:nvSpPr>
-        <p:spPr>
-          <a:xfrm>
-            <a:off x="731520" y="2423160"/>
-            <a:ext cx="1737360" cy="914400"/>
+              <a:t>2</a:t>
+            </a:r>
+            <a:endParaRPr lang="en-US" sz="1600" dirty="0"/>
+          </a:p>
+        </p:txBody>
+      </p:sp>
+      <p:sp>
+        <p:nvSpPr>
+          <p:cNvPr id="9" name="Tool name 2"/>
+          <p:cNvSpPr txBox="1"/>
+          <p:nvPr/>
+        </p:nvSpPr>
+        <p:spPr>
+          <a:xfrm>
+            <a:off x="1188720" y="2395728"/>
+            <a:ext cx="5669280" cy="329184"/>
           </a:xfrm>
           <a:prstGeom prst="rect">
             <a:avLst/>
@@ -4202,27 +4398,27 @@
               <a:buNone/>
             </a:pPr>
             <a:r>
-              <a:rPr lang="en-US" sz="1500" b="1" dirty="0">
+              <a:rPr lang="en-US" sz="1700" b="1" dirty="0">
                 <a:solidFill>
                   <a:schemeClr val="tx1"/>
                 </a:solidFill>
               </a:rPr>
-              <a:t>Raw profile numbers</a:t>
-            </a:r>
-            <a:endParaRPr lang="en-US" sz="1500" dirty="0"/>
-          </a:p>
-        </p:txBody>
-      </p:sp>
-      <p:sp>
-        <p:nvSpPr>
-          <p:cNvPr id="7" name="Time v1"/>
-          <p:cNvSpPr txBox="1"/>
-          <p:nvPr/>
-        </p:nvSpPr>
-        <p:spPr>
-          <a:xfrm>
-            <a:off x="731520" y="3383280"/>
-            <a:ext cx="1737360" cy="457200"/>
+              <a:t>neuron-explorer view</a:t>
+            </a:r>
+            <a:endParaRPr lang="en-US" sz="1700" dirty="0"/>
+          </a:p>
+        </p:txBody>
+      </p:sp>
+      <p:sp>
+        <p:nvSpPr>
+          <p:cNvPr id="10" name="Tool use 2"/>
+          <p:cNvSpPr txBox="1"/>
+          <p:nvPr/>
+        </p:nvSpPr>
+        <p:spPr>
+          <a:xfrm>
+            <a:off x="1188720" y="2734056"/>
+            <a:ext cx="5669280" cy="530352"/>
           </a:xfrm>
           <a:prstGeom prst="rect">
             <a:avLst/>
@@ -4238,150 +4434,37 @@
               <a:buNone/>
             </a:pPr>
             <a:r>
-              <a:rPr lang="en-US" sz="2400" b="1" dirty="0">
-                <a:solidFill>
-                  <a:schemeClr val="accent4"/>
-                </a:solidFill>
-                <a:latin typeface="Cambria" pitchFamily="34" charset="0"/>
-                <a:ea typeface="Cambria" pitchFamily="34" charset="-122"/>
-                <a:cs typeface="Cambria" pitchFamily="34" charset="-120"/>
-              </a:rPr>
-              <a:t>2,285 µs</a:t>
-            </a:r>
-            <a:endParaRPr lang="en-US" sz="2400" dirty="0"/>
-          </a:p>
-        </p:txBody>
-      </p:sp>
-      <p:sp>
-        <p:nvSpPr>
-          <p:cNvPr id="8" name="Time label v1"/>
-          <p:cNvSpPr txBox="1"/>
-          <p:nvPr/>
-        </p:nvSpPr>
-        <p:spPr>
-          <a:xfrm>
-            <a:off x="731520" y="3822192"/>
-            <a:ext cx="1737360" cy="274320"/>
-          </a:xfrm>
-          <a:prstGeom prst="rect">
-            <a:avLst/>
-          </a:prstGeom>
-          <a:noFill/>
-          <a:ln/>
-        </p:spPr>
-        <p:txBody>
-          <a:bodyPr wrap="square" lIns="0" tIns="0" rIns="0" bIns="0" rtlCol="0" anchor="t"/>
-          <a:lstStyle/>
-          <a:p>
-            <a:pPr indent="0" marL="0">
-              <a:buNone/>
-            </a:pPr>
-            <a:r>
-              <a:rPr lang="en-US" sz="1100" dirty="0">
+              <a:rPr lang="en-US" sz="1400" dirty="0">
                 <a:solidFill>
                   <a:schemeClr val="tx2"/>
                 </a:solidFill>
               </a:rPr>
-              <a:t>median final time</a:t>
-            </a:r>
-            <a:endParaRPr lang="en-US" sz="1100" dirty="0"/>
-          </a:p>
-        </p:txBody>
-      </p:sp>
-      <p:sp>
-        <p:nvSpPr>
-          <p:cNvPr id="9" name="Wasted v1"/>
-          <p:cNvSpPr txBox="1"/>
-          <p:nvPr/>
-        </p:nvSpPr>
-        <p:spPr>
-          <a:xfrm>
-            <a:off x="731520" y="4160520"/>
-            <a:ext cx="1737360" cy="365760"/>
-          </a:xfrm>
-          <a:prstGeom prst="rect">
-            <a:avLst/>
-          </a:prstGeom>
-          <a:noFill/>
-          <a:ln/>
-        </p:spPr>
-        <p:txBody>
-          <a:bodyPr wrap="square" lIns="0" tIns="0" rIns="0" bIns="0" rtlCol="0" anchor="t"/>
-          <a:lstStyle/>
-          <a:p>
-            <a:pPr indent="0" marL="0">
-              <a:buNone/>
-            </a:pPr>
-            <a:r>
-              <a:rPr lang="en-US" sz="1800" b="1" dirty="0">
-                <a:solidFill>
-                  <a:schemeClr val="tx1"/>
-                </a:solidFill>
-              </a:rPr>
-              <a:t>66 of 100</a:t>
-            </a:r>
-            <a:endParaRPr lang="en-US" sz="1800" dirty="0"/>
-          </a:p>
-        </p:txBody>
-      </p:sp>
-      <p:sp>
-        <p:nvSpPr>
-          <p:cNvPr id="10" name="Wasted label v1"/>
-          <p:cNvSpPr txBox="1"/>
-          <p:nvPr/>
-        </p:nvSpPr>
-        <p:spPr>
-          <a:xfrm>
-            <a:off x="731520" y="4526280"/>
-            <a:ext cx="1737360" cy="365760"/>
-          </a:xfrm>
-          <a:prstGeom prst="rect">
-            <a:avLst/>
-          </a:prstGeom>
-          <a:noFill/>
-          <a:ln/>
-        </p:spPr>
-        <p:txBody>
-          <a:bodyPr wrap="square" lIns="0" tIns="0" rIns="0" bIns="0" rtlCol="0" anchor="t"/>
-          <a:lstStyle/>
-          <a:p>
-            <a:pPr indent="0" marL="0">
-              <a:buNone/>
-            </a:pPr>
-            <a:r>
-              <a:rPr lang="en-US" sz="1100" dirty="0">
-                <a:solidFill>
-                  <a:schemeClr val="tx2"/>
-                </a:solidFill>
-              </a:rPr>
-              <a:t>attempts with no measurement</a:t>
-            </a:r>
-            <a:endParaRPr lang="en-US" sz="1100" dirty="0"/>
-          </a:p>
-        </p:txBody>
-      </p:sp>
-      <p:sp>
-        <p:nvSpPr>
-          <p:cNvPr id="11" name="Design card v2"/>
+              <a:t>Turns the trace into a 115-field summary. We read time, engine busy, data-movement busy, bytes and transfers.</a:t>
+            </a:r>
+            <a:endParaRPr lang="en-US" sz="1400" dirty="0"/>
+          </a:p>
+        </p:txBody>
+      </p:sp>
+      <p:sp>
+        <p:nvSpPr>
+          <p:cNvPr id="11" name="Tool badge 3"/>
           <p:cNvSpPr/>
           <p:nvPr/>
         </p:nvSpPr>
         <p:spPr>
           <a:xfrm>
-            <a:off x="2779776" y="1463040"/>
-            <a:ext cx="2084832" cy="3520440"/>
-          </a:xfrm>
-          <a:prstGeom prst="roundRect">
-            <a:avLst>
-              <a:gd name="adj" fmla="val 3509"/>
-            </a:avLst>
+            <a:off x="548640" y="3401568"/>
+            <a:ext cx="457200" cy="457200"/>
+          </a:xfrm>
+          <a:prstGeom prst="ellipse">
+            <a:avLst/>
           </a:prstGeom>
           <a:solidFill>
-            <a:schemeClr val="bg2"/>
+            <a:schemeClr val="accent1"/>
           </a:solidFill>
           <a:ln w="12700">
             <a:solidFill>
-              <a:schemeClr val="bg2"/>
+              <a:schemeClr val="accent1"/>
             </a:solidFill>
             <a:prstDash val="solid"/>
           </a:ln>
@@ -4389,24 +4472,132 @@
       </p:sp>
       <p:sp>
         <p:nvSpPr>
-          <p:cNvPr id="12" name="Badge v2"/>
+          <p:cNvPr id="12" name="Tool number 3"/>
+          <p:cNvSpPr txBox="1"/>
+          <p:nvPr/>
+        </p:nvSpPr>
+        <p:spPr>
+          <a:xfrm>
+            <a:off x="548640" y="3401568"/>
+            <a:ext cx="457200" cy="457200"/>
+          </a:xfrm>
+          <a:prstGeom prst="rect">
+            <a:avLst/>
+          </a:prstGeom>
+          <a:noFill/>
+          <a:ln/>
+        </p:spPr>
+        <p:txBody>
+          <a:bodyPr wrap="square" lIns="0" tIns="0" rIns="0" bIns="0" rtlCol="0" anchor="ctr"/>
+          <a:lstStyle/>
+          <a:p>
+            <a:pPr algn="ctr" indent="0" marL="0">
+              <a:buNone/>
+            </a:pPr>
+            <a:r>
+              <a:rPr lang="en-US" sz="1600" b="1" dirty="0">
+                <a:solidFill>
+                  <a:schemeClr val="bg1"/>
+                </a:solidFill>
+              </a:rPr>
+              <a:t>3</a:t>
+            </a:r>
+            <a:endParaRPr lang="en-US" sz="1600" dirty="0"/>
+          </a:p>
+        </p:txBody>
+      </p:sp>
+      <p:sp>
+        <p:nvSpPr>
+          <p:cNvPr id="13" name="Tool name 3"/>
+          <p:cNvSpPr txBox="1"/>
+          <p:nvPr/>
+        </p:nvSpPr>
+        <p:spPr>
+          <a:xfrm>
+            <a:off x="1188720" y="3328416"/>
+            <a:ext cx="5669280" cy="329184"/>
+          </a:xfrm>
+          <a:prstGeom prst="rect">
+            <a:avLst/>
+          </a:prstGeom>
+          <a:noFill/>
+          <a:ln/>
+        </p:spPr>
+        <p:txBody>
+          <a:bodyPr wrap="square" lIns="0" tIns="0" rIns="0" bIns="0" rtlCol="0" anchor="t"/>
+          <a:lstStyle/>
+          <a:p>
+            <a:pPr indent="0" marL="0">
+              <a:buNone/>
+            </a:pPr>
+            <a:r>
+              <a:rPr lang="en-US" sz="1700" b="1" dirty="0">
+                <a:solidFill>
+                  <a:schemeClr val="tx1"/>
+                </a:solidFill>
+              </a:rPr>
+              <a:t>NKI and neuronx-cc</a:t>
+            </a:r>
+            <a:endParaRPr lang="en-US" sz="1700" dirty="0"/>
+          </a:p>
+        </p:txBody>
+      </p:sp>
+      <p:sp>
+        <p:nvSpPr>
+          <p:cNvPr id="14" name="Tool use 3"/>
+          <p:cNvSpPr txBox="1"/>
+          <p:nvPr/>
+        </p:nvSpPr>
+        <p:spPr>
+          <a:xfrm>
+            <a:off x="1188720" y="3666744"/>
+            <a:ext cx="5669280" cy="530352"/>
+          </a:xfrm>
+          <a:prstGeom prst="rect">
+            <a:avLst/>
+          </a:prstGeom>
+          <a:noFill/>
+          <a:ln/>
+        </p:spPr>
+        <p:txBody>
+          <a:bodyPr wrap="square" lIns="0" tIns="0" rIns="0" bIns="0" rtlCol="0" anchor="t"/>
+          <a:lstStyle/>
+          <a:p>
+            <a:pPr indent="0" marL="0">
+              <a:buNone/>
+            </a:pPr>
+            <a:r>
+              <a:rPr lang="en-US" sz="1400" dirty="0">
+                <a:solidFill>
+                  <a:schemeClr val="tx2"/>
+                </a:solidFill>
+              </a:rPr>
+              <a:t>Compile and run the kernel standalone on the chip. The CPU simulator, nki.simulate, was our comparison.</a:t>
+            </a:r>
+            <a:endParaRPr lang="en-US" sz="1400" dirty="0"/>
+          </a:p>
+        </p:txBody>
+      </p:sp>
+      <p:sp>
+        <p:nvSpPr>
+          <p:cNvPr id="15" name="Tool badge 4"/>
           <p:cNvSpPr/>
           <p:nvPr/>
         </p:nvSpPr>
         <p:spPr>
           <a:xfrm>
-            <a:off x="2962656" y="1645920"/>
-            <a:ext cx="640080" cy="640080"/>
+            <a:off x="548640" y="4334256"/>
+            <a:ext cx="457200" cy="457200"/>
           </a:xfrm>
           <a:prstGeom prst="ellipse">
             <a:avLst/>
           </a:prstGeom>
           <a:solidFill>
-            <a:schemeClr val="accent2"/>
+            <a:schemeClr val="accent1"/>
           </a:solidFill>
           <a:ln w="12700">
             <a:solidFill>
-              <a:schemeClr val="accent2"/>
+              <a:schemeClr val="accent1"/>
             </a:solidFill>
             <a:prstDash val="solid"/>
           </a:ln>
@@ -4414,14 +4605,14 @@
       </p:sp>
       <p:sp>
         <p:nvSpPr>
-          <p:cNvPr id="13" name="Badge text v2"/>
-          <p:cNvSpPr txBox="1"/>
-          <p:nvPr/>
-        </p:nvSpPr>
-        <p:spPr>
-          <a:xfrm>
-            <a:off x="2962656" y="1645920"/>
-            <a:ext cx="640080" cy="640080"/>
+          <p:cNvPr id="16" name="Tool number 4"/>
+          <p:cNvSpPr txBox="1"/>
+          <p:nvPr/>
+        </p:nvSpPr>
+        <p:spPr>
+          <a:xfrm>
+            <a:off x="548640" y="4334256"/>
+            <a:ext cx="457200" cy="457200"/>
           </a:xfrm>
           <a:prstGeom prst="rect">
             <a:avLst/>
@@ -4437,27 +4628,27 @@
               <a:buNone/>
             </a:pPr>
             <a:r>
-              <a:rPr lang="en-US" sz="1800" b="1" dirty="0">
+              <a:rPr lang="en-US" sz="1600" b="1" dirty="0">
                 <a:solidFill>
                   <a:schemeClr val="bg1"/>
                 </a:solidFill>
               </a:rPr>
-              <a:t>v2</a:t>
-            </a:r>
-            <a:endParaRPr lang="en-US" sz="1800" dirty="0"/>
-          </a:p>
-        </p:txBody>
-      </p:sp>
-      <p:sp>
-        <p:nvSpPr>
-          <p:cNvPr id="14" name="Shown v2"/>
-          <p:cNvSpPr txBox="1"/>
-          <p:nvPr/>
-        </p:nvSpPr>
-        <p:spPr>
-          <a:xfrm>
-            <a:off x="2962656" y="2423160"/>
-            <a:ext cx="1737360" cy="914400"/>
+              <a:t>4</a:t>
+            </a:r>
+            <a:endParaRPr lang="en-US" sz="1600" dirty="0"/>
+          </a:p>
+        </p:txBody>
+      </p:sp>
+      <p:sp>
+        <p:nvSpPr>
+          <p:cNvPr id="17" name="Tool name 4"/>
+          <p:cNvSpPr txBox="1"/>
+          <p:nvPr/>
+        </p:nvSpPr>
+        <p:spPr>
+          <a:xfrm>
+            <a:off x="1188720" y="4261104"/>
+            <a:ext cx="5669280" cy="329184"/>
           </a:xfrm>
           <a:prstGeom prst="rect">
             <a:avLst/>
@@ -4473,27 +4664,27 @@
               <a:buNone/>
             </a:pPr>
             <a:r>
-              <a:rPr lang="en-US" sz="1500" b="1" dirty="0">
+              <a:rPr lang="en-US" sz="1700" b="1" dirty="0">
                 <a:solidFill>
                   <a:schemeClr val="tx1"/>
                 </a:solidFill>
               </a:rPr>
-              <a:t>Comparisons worked out in code</a:t>
-            </a:r>
-            <a:endParaRPr lang="en-US" sz="1500" dirty="0"/>
-          </a:p>
-        </p:txBody>
-      </p:sp>
-      <p:sp>
-        <p:nvSpPr>
-          <p:cNvPr id="15" name="Time v2"/>
-          <p:cNvSpPr txBox="1"/>
-          <p:nvPr/>
-        </p:nvSpPr>
-        <p:spPr>
-          <a:xfrm>
-            <a:off x="2962656" y="3383280"/>
-            <a:ext cx="1737360" cy="457200"/>
+              <a:t>Neuron agentic skills</a:t>
+            </a:r>
+            <a:endParaRPr lang="en-US" sz="1700" dirty="0"/>
+          </a:p>
+        </p:txBody>
+      </p:sp>
+      <p:sp>
+        <p:nvSpPr>
+          <p:cNvPr id="18" name="Tool use 4"/>
+          <p:cNvSpPr txBox="1"/>
+          <p:nvPr/>
+        </p:nvSpPr>
+        <p:spPr>
+          <a:xfrm>
+            <a:off x="1188720" y="4599432"/>
+            <a:ext cx="5669280" cy="530352"/>
           </a:xfrm>
           <a:prstGeom prst="rect">
             <a:avLst/>
@@ -4509,165 +4700,27 @@
               <a:buNone/>
             </a:pPr>
             <a:r>
-              <a:rPr lang="en-US" sz="2400" b="1" dirty="0">
-                <a:solidFill>
-                  <a:schemeClr val="accent2"/>
-                </a:solidFill>
-                <a:latin typeface="Cambria" pitchFamily="34" charset="0"/>
-                <a:ea typeface="Cambria" pitchFamily="34" charset="-122"/>
-                <a:cs typeface="Cambria" pitchFamily="34" charset="-120"/>
-              </a:rPr>
-              <a:t>1,553 µs</a:t>
-            </a:r>
-            <a:endParaRPr lang="en-US" sz="2400" dirty="0"/>
-          </a:p>
-        </p:txBody>
-      </p:sp>
-      <p:sp>
-        <p:nvSpPr>
-          <p:cNvPr id="16" name="Time label v2"/>
-          <p:cNvSpPr txBox="1"/>
-          <p:nvPr/>
-        </p:nvSpPr>
-        <p:spPr>
-          <a:xfrm>
-            <a:off x="2962656" y="3822192"/>
-            <a:ext cx="1737360" cy="274320"/>
-          </a:xfrm>
-          <a:prstGeom prst="rect">
-            <a:avLst/>
-          </a:prstGeom>
-          <a:noFill/>
-          <a:ln/>
-        </p:spPr>
-        <p:txBody>
-          <a:bodyPr wrap="square" lIns="0" tIns="0" rIns="0" bIns="0" rtlCol="0" anchor="t"/>
-          <a:lstStyle/>
-          <a:p>
-            <a:pPr indent="0" marL="0">
-              <a:buNone/>
-            </a:pPr>
-            <a:r>
-              <a:rPr lang="en-US" sz="1100" dirty="0">
+              <a:rPr lang="en-US" sz="1400" dirty="0">
                 <a:solidFill>
                   <a:schemeClr val="tx2"/>
                 </a:solidFill>
               </a:rPr>
-              <a:t>median final time</a:t>
-            </a:r>
-            <a:endParaRPr lang="en-US" sz="1100" dirty="0"/>
-          </a:p>
-        </p:txBody>
-      </p:sp>
-      <p:sp>
-        <p:nvSpPr>
-          <p:cNvPr id="17" name="Wasted v2"/>
-          <p:cNvSpPr txBox="1"/>
-          <p:nvPr/>
-        </p:nvSpPr>
-        <p:spPr>
-          <a:xfrm>
-            <a:off x="2962656" y="4160520"/>
-            <a:ext cx="1737360" cy="365760"/>
-          </a:xfrm>
-          <a:prstGeom prst="rect">
-            <a:avLst/>
-          </a:prstGeom>
-          <a:noFill/>
-          <a:ln/>
-        </p:spPr>
-        <p:txBody>
-          <a:bodyPr wrap="square" lIns="0" tIns="0" rIns="0" bIns="0" rtlCol="0" anchor="t"/>
-          <a:lstStyle/>
-          <a:p>
-            <a:pPr indent="0" marL="0">
-              <a:buNone/>
-            </a:pPr>
-            <a:r>
-              <a:rPr lang="en-US" sz="1800" b="1" dirty="0">
-                <a:solidFill>
-                  <a:schemeClr val="tx1"/>
-                </a:solidFill>
-              </a:rPr>
-              <a:t>70 of 100</a:t>
-            </a:r>
-            <a:endParaRPr lang="en-US" sz="1800" dirty="0"/>
-          </a:p>
-        </p:txBody>
-      </p:sp>
-      <p:sp>
-        <p:nvSpPr>
-          <p:cNvPr id="18" name="Wasted label v2"/>
-          <p:cNvSpPr txBox="1"/>
-          <p:nvPr/>
-        </p:nvSpPr>
-        <p:spPr>
-          <a:xfrm>
-            <a:off x="2962656" y="4526280"/>
-            <a:ext cx="1737360" cy="365760"/>
-          </a:xfrm>
-          <a:prstGeom prst="rect">
-            <a:avLst/>
-          </a:prstGeom>
-          <a:noFill/>
-          <a:ln/>
-        </p:spPr>
-        <p:txBody>
-          <a:bodyPr wrap="square" lIns="0" tIns="0" rIns="0" bIns="0" rtlCol="0" anchor="t"/>
-          <a:lstStyle/>
-          <a:p>
-            <a:pPr indent="0" marL="0">
-              <a:buNone/>
-            </a:pPr>
-            <a:r>
-              <a:rPr lang="en-US" sz="1100" dirty="0">
-                <a:solidFill>
-                  <a:schemeClr val="tx2"/>
-                </a:solidFill>
-              </a:rPr>
-              <a:t>attempts with no measurement</a:t>
-            </a:r>
-            <a:endParaRPr lang="en-US" sz="1100" dirty="0"/>
-          </a:p>
-        </p:txBody>
-      </p:sp>
-      <p:sp>
-        <p:nvSpPr>
-          <p:cNvPr id="19" name="Design card v3"/>
+              <a:t>AWS's NKI profiling recipe and profile-querying guide, adapted because the pods lack torch_neuronx.</a:t>
+            </a:r>
+            <a:endParaRPr lang="en-US" sz="1400" dirty="0"/>
+          </a:p>
+        </p:txBody>
+      </p:sp>
+      <p:sp>
+        <p:nvSpPr>
+          <p:cNvPr id="19" name="Tool badge 5"/>
           <p:cNvSpPr/>
           <p:nvPr/>
         </p:nvSpPr>
         <p:spPr>
           <a:xfrm>
-            <a:off x="5010912" y="1463040"/>
-            <a:ext cx="2084832" cy="3520440"/>
-          </a:xfrm>
-          <a:prstGeom prst="roundRect">
-            <a:avLst>
-              <a:gd name="adj" fmla="val 3509"/>
-            </a:avLst>
-          </a:prstGeom>
-          <a:solidFill>
-            <a:schemeClr val="bg2"/>
-          </a:solidFill>
-          <a:ln w="12700">
-            <a:solidFill>
-              <a:schemeClr val="bg2"/>
-            </a:solidFill>
-            <a:prstDash val="solid"/>
-          </a:ln>
-        </p:spPr>
-      </p:sp>
-      <p:sp>
-        <p:nvSpPr>
-          <p:cNvPr id="20" name="Badge v3"/>
-          <p:cNvSpPr/>
-          <p:nvPr/>
-        </p:nvSpPr>
-        <p:spPr>
-          <a:xfrm>
-            <a:off x="5193792" y="1645920"/>
-            <a:ext cx="640080" cy="640080"/>
+            <a:off x="548640" y="5266944"/>
+            <a:ext cx="457200" cy="457200"/>
           </a:xfrm>
           <a:prstGeom prst="ellipse">
             <a:avLst/>
@@ -4685,14 +4738,14 @@
       </p:sp>
       <p:sp>
         <p:nvSpPr>
-          <p:cNvPr id="21" name="Badge text v3"/>
-          <p:cNvSpPr txBox="1"/>
-          <p:nvPr/>
-        </p:nvSpPr>
-        <p:spPr>
-          <a:xfrm>
-            <a:off x="5193792" y="1645920"/>
-            <a:ext cx="640080" cy="640080"/>
+          <p:cNvPr id="20" name="Tool number 5"/>
+          <p:cNvSpPr txBox="1"/>
+          <p:nvPr/>
+        </p:nvSpPr>
+        <p:spPr>
+          <a:xfrm>
+            <a:off x="548640" y="5266944"/>
+            <a:ext cx="457200" cy="457200"/>
           </a:xfrm>
           <a:prstGeom prst="rect">
             <a:avLst/>
@@ -4708,27 +4761,27 @@
               <a:buNone/>
             </a:pPr>
             <a:r>
-              <a:rPr lang="en-US" sz="1800" b="1" dirty="0">
+              <a:rPr lang="en-US" sz="1600" b="1" dirty="0">
                 <a:solidFill>
                   <a:schemeClr val="bg1"/>
                 </a:solidFill>
               </a:rPr>
-              <a:t>v3</a:t>
-            </a:r>
-            <a:endParaRPr lang="en-US" sz="1800" dirty="0"/>
-          </a:p>
-        </p:txBody>
-      </p:sp>
-      <p:sp>
-        <p:nvSpPr>
-          <p:cNvPr id="22" name="Shown v3"/>
-          <p:cNvSpPr txBox="1"/>
-          <p:nvPr/>
-        </p:nvSpPr>
-        <p:spPr>
-          <a:xfrm>
-            <a:off x="5193792" y="2423160"/>
-            <a:ext cx="1737360" cy="914400"/>
+              <a:t>5</a:t>
+            </a:r>
+            <a:endParaRPr lang="en-US" sz="1600" dirty="0"/>
+          </a:p>
+        </p:txBody>
+      </p:sp>
+      <p:sp>
+        <p:nvSpPr>
+          <p:cNvPr id="21" name="Tool name 5"/>
+          <p:cNvSpPr txBox="1"/>
+          <p:nvPr/>
+        </p:nvSpPr>
+        <p:spPr>
+          <a:xfrm>
+            <a:off x="1188720" y="5193792"/>
+            <a:ext cx="5669280" cy="329184"/>
           </a:xfrm>
           <a:prstGeom prst="rect">
             <a:avLst/>
@@ -4744,27 +4797,27 @@
               <a:buNone/>
             </a:pPr>
             <a:r>
-              <a:rPr lang="en-US" sz="1500" b="1" dirty="0">
+              <a:rPr lang="en-US" sz="1700" b="1" dirty="0">
                 <a:solidFill>
                   <a:schemeClr val="tx1"/>
                 </a:solidFill>
               </a:rPr>
-              <a:t>A menu of measured moves</a:t>
-            </a:r>
-            <a:endParaRPr lang="en-US" sz="1500" dirty="0"/>
-          </a:p>
-        </p:txBody>
-      </p:sp>
-      <p:sp>
-        <p:nvSpPr>
-          <p:cNvPr id="23" name="Time v3"/>
-          <p:cNvSpPr txBox="1"/>
-          <p:nvPr/>
-        </p:nvSpPr>
-        <p:spPr>
-          <a:xfrm>
-            <a:off x="5193792" y="3383280"/>
-            <a:ext cx="1737360" cy="457200"/>
+              <a:t>neuron-explorer recommend</a:t>
+            </a:r>
+            <a:endParaRPr lang="en-US" sz="1700" dirty="0"/>
+          </a:p>
+        </p:txBody>
+      </p:sp>
+      <p:sp>
+        <p:nvSpPr>
+          <p:cNvPr id="22" name="Tool use 5"/>
+          <p:cNvSpPr txBox="1"/>
+          <p:nvPr/>
+        </p:nvSpPr>
+        <p:spPr>
+          <a:xfrm>
+            <a:off x="1188720" y="5532120"/>
+            <a:ext cx="5669280" cy="530352"/>
           </a:xfrm>
           <a:prstGeom prst="rect">
             <a:avLst/>
@@ -4780,30 +4833,93 @@
               <a:buNone/>
             </a:pPr>
             <a:r>
-              <a:rPr lang="en-US" sz="2400" b="1" dirty="0">
-                <a:solidFill>
-                  <a:schemeClr val="accent3"/>
+              <a:rPr lang="en-US" sz="1400" dirty="0">
+                <a:solidFill>
+                  <a:schemeClr val="tx2"/>
+                </a:solidFill>
+              </a:rPr>
+              <a:t>AWS's Bedrock-powered advisor. Read in print-only mode (a 155,604-character prompt); not used in the loop.</a:t>
+            </a:r>
+            <a:endParaRPr lang="en-US" sz="1400" dirty="0"/>
+          </a:p>
+        </p:txBody>
+      </p:sp>
+      <p:sp>
+        <p:nvSpPr>
+          <p:cNvPr id="23" name="Profile card"/>
+          <p:cNvSpPr/>
+          <p:nvPr/>
+        </p:nvSpPr>
+        <p:spPr>
+          <a:xfrm>
+            <a:off x="7315200" y="1463040"/>
+            <a:ext cx="4297680" cy="4572000"/>
+          </a:xfrm>
+          <a:prstGeom prst="roundRect">
+            <a:avLst>
+              <a:gd name="adj" fmla="val 1702"/>
+            </a:avLst>
+          </a:prstGeom>
+          <a:solidFill>
+            <a:schemeClr val="tx1"/>
+          </a:solidFill>
+          <a:ln w="12700">
+            <a:solidFill>
+              <a:schemeClr val="tx1"/>
+            </a:solidFill>
+            <a:prstDash val="solid"/>
+          </a:ln>
+        </p:spPr>
+      </p:sp>
+      <p:sp>
+        <p:nvSpPr>
+          <p:cNvPr id="24" name="Profile heading"/>
+          <p:cNvSpPr txBox="1"/>
+          <p:nvPr/>
+        </p:nvSpPr>
+        <p:spPr>
+          <a:xfrm>
+            <a:off x="7589520" y="1645920"/>
+            <a:ext cx="3749040" cy="411480"/>
+          </a:xfrm>
+          <a:prstGeom prst="rect">
+            <a:avLst/>
+          </a:prstGeom>
+          <a:noFill/>
+          <a:ln/>
+        </p:spPr>
+        <p:txBody>
+          <a:bodyPr wrap="square" lIns="0" tIns="0" rIns="0" bIns="0" rtlCol="0" anchor="t"/>
+          <a:lstStyle/>
+          <a:p>
+            <a:pPr indent="0" marL="0">
+              <a:buNone/>
+            </a:pPr>
+            <a:r>
+              <a:rPr lang="en-US" sz="2000" b="1" dirty="0">
+                <a:solidFill>
+                  <a:schemeClr val="accent5"/>
                 </a:solidFill>
                 <a:latin typeface="Cambria" pitchFamily="34" charset="0"/>
                 <a:ea typeface="Cambria" pitchFamily="34" charset="-122"/>
                 <a:cs typeface="Cambria" pitchFamily="34" charset="-120"/>
               </a:rPr>
-              <a:t>1,492 µs</a:t>
-            </a:r>
-            <a:endParaRPr lang="en-US" sz="2400" dirty="0"/>
-          </a:p>
-        </p:txBody>
-      </p:sp>
-      <p:sp>
-        <p:nvSpPr>
-          <p:cNvPr id="24" name="Time label v3"/>
-          <p:cNvSpPr txBox="1"/>
-          <p:nvPr/>
-        </p:nvSpPr>
-        <p:spPr>
-          <a:xfrm>
-            <a:off x="5193792" y="3822192"/>
-            <a:ext cx="1737360" cy="274320"/>
+              <a:t>One profile, in numbers</a:t>
+            </a:r>
+            <a:endParaRPr lang="en-US" sz="2000" dirty="0"/>
+          </a:p>
+        </p:txBody>
+      </p:sp>
+      <p:sp>
+        <p:nvSpPr>
+          <p:cNvPr id="25" name="Profile subject"/>
+          <p:cNvSpPr txBox="1"/>
+          <p:nvPr/>
+        </p:nvSpPr>
+        <p:spPr>
+          <a:xfrm>
+            <a:off x="7589520" y="2084832"/>
+            <a:ext cx="3749040" cy="502920"/>
           </a:xfrm>
           <a:prstGeom prst="rect">
             <a:avLst/>
@@ -4819,664 +4935,314 @@
               <a:buNone/>
             </a:pPr>
             <a:r>
-              <a:rPr lang="en-US" sz="1100" dirty="0">
-                <a:solidFill>
-                  <a:schemeClr val="tx2"/>
-                </a:solidFill>
-              </a:rPr>
-              <a:t>median final time</a:t>
-            </a:r>
-            <a:endParaRPr lang="en-US" sz="1100" dirty="0"/>
-          </a:p>
-        </p:txBody>
-      </p:sp>
-      <p:sp>
-        <p:nvSpPr>
-          <p:cNvPr id="25" name="Wasted v3"/>
-          <p:cNvSpPr txBox="1"/>
-          <p:nvPr/>
-        </p:nvSpPr>
-        <p:spPr>
-          <a:xfrm>
-            <a:off x="5193792" y="4160520"/>
-            <a:ext cx="1737360" cy="365760"/>
-          </a:xfrm>
-          <a:prstGeom prst="rect">
-            <a:avLst/>
-          </a:prstGeom>
-          <a:noFill/>
-          <a:ln/>
-        </p:spPr>
-        <p:txBody>
-          <a:bodyPr wrap="square" lIns="0" tIns="0" rIns="0" bIns="0" rtlCol="0" anchor="t"/>
+              <a:rPr lang="en-US" sz="1300" dirty="0">
+                <a:solidFill>
+                  <a:schemeClr val="accent5"/>
+                </a:solidFill>
+              </a:rPr>
+              <a:t>AWS's fully optimised matmul at 2048, on the chip</a:t>
+            </a:r>
+            <a:endParaRPr lang="en-US" sz="1300" dirty="0"/>
+          </a:p>
+        </p:txBody>
+      </p:sp>
+      <p:sp>
+        <p:nvSpPr>
+          <p:cNvPr id="26" name="Profile value 1"/>
+          <p:cNvSpPr txBox="1"/>
+          <p:nvPr/>
+        </p:nvSpPr>
+        <p:spPr>
+          <a:xfrm>
+            <a:off x="7589520" y="2743200"/>
+            <a:ext cx="1920240" cy="640080"/>
+          </a:xfrm>
+          <a:prstGeom prst="rect">
+            <a:avLst/>
+          </a:prstGeom>
+          <a:noFill/>
+          <a:ln/>
+        </p:spPr>
+        <p:txBody>
+          <a:bodyPr wrap="square" lIns="0" tIns="0" rIns="0" bIns="0" rtlCol="0" anchor="ctr"/>
           <a:lstStyle/>
           <a:p>
             <a:pPr indent="0" marL="0">
               <a:buNone/>
             </a:pPr>
             <a:r>
-              <a:rPr lang="en-US" sz="1800" b="1" dirty="0">
-                <a:solidFill>
-                  <a:schemeClr val="tx1"/>
-                </a:solidFill>
-              </a:rPr>
-              <a:t>25 of 100</a:t>
-            </a:r>
-            <a:endParaRPr lang="en-US" sz="1800" dirty="0"/>
-          </a:p>
-        </p:txBody>
-      </p:sp>
-      <p:sp>
-        <p:nvSpPr>
-          <p:cNvPr id="26" name="Wasted label v3"/>
-          <p:cNvSpPr txBox="1"/>
-          <p:nvPr/>
-        </p:nvSpPr>
-        <p:spPr>
-          <a:xfrm>
-            <a:off x="5193792" y="4526280"/>
-            <a:ext cx="1737360" cy="365760"/>
-          </a:xfrm>
-          <a:prstGeom prst="rect">
-            <a:avLst/>
-          </a:prstGeom>
-          <a:noFill/>
-          <a:ln/>
-        </p:spPr>
-        <p:txBody>
-          <a:bodyPr wrap="square" lIns="0" tIns="0" rIns="0" bIns="0" rtlCol="0" anchor="t"/>
-          <a:lstStyle/>
-          <a:p>
-            <a:pPr indent="0" marL="0">
-              <a:buNone/>
-            </a:pPr>
-            <a:r>
-              <a:rPr lang="en-US" sz="1100" dirty="0">
-                <a:solidFill>
-                  <a:schemeClr val="tx2"/>
-                </a:solidFill>
-              </a:rPr>
-              <a:t>attempts with no measurement</a:t>
-            </a:r>
-            <a:endParaRPr lang="en-US" sz="1100" dirty="0"/>
-          </a:p>
-        </p:txBody>
-      </p:sp>
-      <p:sp>
-        <p:nvSpPr>
-          <p:cNvPr id="27" name="Design card v4"/>
-          <p:cNvSpPr/>
-          <p:nvPr/>
-        </p:nvSpPr>
-        <p:spPr>
-          <a:xfrm>
-            <a:off x="7242048" y="1463040"/>
-            <a:ext cx="2084832" cy="3520440"/>
-          </a:xfrm>
-          <a:prstGeom prst="roundRect">
-            <a:avLst>
-              <a:gd name="adj" fmla="val 3509"/>
-            </a:avLst>
-          </a:prstGeom>
-          <a:solidFill>
-            <a:schemeClr val="bg2"/>
-          </a:solidFill>
-          <a:ln w="12700">
-            <a:solidFill>
-              <a:schemeClr val="bg2"/>
-            </a:solidFill>
-            <a:prstDash val="solid"/>
-          </a:ln>
-        </p:spPr>
-      </p:sp>
-      <p:sp>
-        <p:nvSpPr>
-          <p:cNvPr id="28" name="Badge v4"/>
-          <p:cNvSpPr/>
-          <p:nvPr/>
-        </p:nvSpPr>
-        <p:spPr>
-          <a:xfrm>
-            <a:off x="7424928" y="1645920"/>
-            <a:ext cx="640080" cy="640080"/>
-          </a:xfrm>
-          <a:prstGeom prst="ellipse">
-            <a:avLst/>
-          </a:prstGeom>
-          <a:solidFill>
-            <a:schemeClr val="accent1"/>
-          </a:solidFill>
-          <a:ln w="12700">
-            <a:solidFill>
-              <a:schemeClr val="accent1"/>
-            </a:solidFill>
-            <a:prstDash val="solid"/>
-          </a:ln>
-        </p:spPr>
-      </p:sp>
-      <p:sp>
-        <p:nvSpPr>
-          <p:cNvPr id="29" name="Badge text v4"/>
-          <p:cNvSpPr txBox="1"/>
-          <p:nvPr/>
-        </p:nvSpPr>
-        <p:spPr>
-          <a:xfrm>
-            <a:off x="7424928" y="1645920"/>
-            <a:ext cx="640080" cy="640080"/>
-          </a:xfrm>
-          <a:prstGeom prst="rect">
-            <a:avLst/>
-          </a:prstGeom>
-          <a:noFill/>
-          <a:ln/>
-        </p:spPr>
-        <p:txBody>
-          <a:bodyPr wrap="square" lIns="0" tIns="0" rIns="0" bIns="0" rtlCol="0" anchor="ctr"/>
-          <a:lstStyle/>
-          <a:p>
-            <a:pPr algn="ctr" indent="0" marL="0">
-              <a:buNone/>
-            </a:pPr>
-            <a:r>
-              <a:rPr lang="en-US" sz="1800" b="1" dirty="0">
+              <a:rPr lang="en-US" sz="2600" b="1" dirty="0">
                 <a:solidFill>
                   <a:schemeClr val="bg1"/>
-                </a:solidFill>
-              </a:rPr>
-              <a:t>v4</a:t>
-            </a:r>
-            <a:endParaRPr lang="en-US" sz="1800" dirty="0"/>
-          </a:p>
-        </p:txBody>
-      </p:sp>
-      <p:sp>
-        <p:nvSpPr>
-          <p:cNvPr id="30" name="Shown v4"/>
-          <p:cNvSpPr txBox="1"/>
-          <p:nvPr/>
-        </p:nvSpPr>
-        <p:spPr>
-          <a:xfrm>
-            <a:off x="7424928" y="2423160"/>
-            <a:ext cx="1737360" cy="914400"/>
-          </a:xfrm>
-          <a:prstGeom prst="rect">
-            <a:avLst/>
-          </a:prstGeom>
-          <a:noFill/>
-          <a:ln/>
-        </p:spPr>
-        <p:txBody>
-          <a:bodyPr wrap="square" lIns="0" tIns="0" rIns="0" bIns="0" rtlCol="0" anchor="t"/>
-          <a:lstStyle/>
-          <a:p>
-            <a:pPr indent="0" marL="0">
-              <a:buNone/>
-            </a:pPr>
-            <a:r>
-              <a:rPr lang="en-US" sz="1500" b="1" dirty="0">
-                <a:solidFill>
-                  <a:schemeClr val="tx1"/>
-                </a:solidFill>
-              </a:rPr>
-              <a:t>v3, and the edit is checked first</a:t>
-            </a:r>
-            <a:endParaRPr lang="en-US" sz="1500" dirty="0"/>
-          </a:p>
-        </p:txBody>
-      </p:sp>
-      <p:sp>
-        <p:nvSpPr>
-          <p:cNvPr id="31" name="Time v4"/>
-          <p:cNvSpPr txBox="1"/>
-          <p:nvPr/>
-        </p:nvSpPr>
-        <p:spPr>
-          <a:xfrm>
-            <a:off x="7424928" y="3383280"/>
-            <a:ext cx="1737360" cy="457200"/>
-          </a:xfrm>
-          <a:prstGeom prst="rect">
-            <a:avLst/>
-          </a:prstGeom>
-          <a:noFill/>
-          <a:ln/>
-        </p:spPr>
-        <p:txBody>
-          <a:bodyPr wrap="square" lIns="0" tIns="0" rIns="0" bIns="0" rtlCol="0" anchor="t"/>
-          <a:lstStyle/>
-          <a:p>
-            <a:pPr indent="0" marL="0">
-              <a:buNone/>
-            </a:pPr>
-            <a:r>
-              <a:rPr lang="en-US" sz="2400" b="1" dirty="0">
-                <a:solidFill>
-                  <a:schemeClr val="accent1"/>
                 </a:solidFill>
                 <a:latin typeface="Cambria" pitchFamily="34" charset="0"/>
                 <a:ea typeface="Cambria" pitchFamily="34" charset="-122"/>
                 <a:cs typeface="Cambria" pitchFamily="34" charset="-120"/>
               </a:rPr>
-              <a:t>1,495 µs</a:t>
-            </a:r>
-            <a:endParaRPr lang="en-US" sz="2400" dirty="0"/>
-          </a:p>
-        </p:txBody>
-      </p:sp>
-      <p:sp>
-        <p:nvSpPr>
-          <p:cNvPr id="32" name="Time label v4"/>
-          <p:cNvSpPr txBox="1"/>
-          <p:nvPr/>
-        </p:nvSpPr>
-        <p:spPr>
-          <a:xfrm>
-            <a:off x="7424928" y="3822192"/>
-            <a:ext cx="1737360" cy="274320"/>
-          </a:xfrm>
-          <a:prstGeom prst="rect">
-            <a:avLst/>
-          </a:prstGeom>
-          <a:noFill/>
-          <a:ln/>
-        </p:spPr>
-        <p:txBody>
-          <a:bodyPr wrap="square" lIns="0" tIns="0" rIns="0" bIns="0" rtlCol="0" anchor="t"/>
+              <a:t>905.8 µs</a:t>
+            </a:r>
+            <a:endParaRPr lang="en-US" sz="2600" dirty="0"/>
+          </a:p>
+        </p:txBody>
+      </p:sp>
+      <p:sp>
+        <p:nvSpPr>
+          <p:cNvPr id="27" name="Profile label 1"/>
+          <p:cNvSpPr txBox="1"/>
+          <p:nvPr/>
+        </p:nvSpPr>
+        <p:spPr>
+          <a:xfrm>
+            <a:off x="9509760" y="2743200"/>
+            <a:ext cx="1920240" cy="640080"/>
+          </a:xfrm>
+          <a:prstGeom prst="rect">
+            <a:avLst/>
+          </a:prstGeom>
+          <a:noFill/>
+          <a:ln/>
+        </p:spPr>
+        <p:txBody>
+          <a:bodyPr wrap="square" lIns="0" tIns="0" rIns="0" bIns="0" rtlCol="0" anchor="ctr"/>
           <a:lstStyle/>
           <a:p>
             <a:pPr indent="0" marL="0">
               <a:buNone/>
             </a:pPr>
             <a:r>
-              <a:rPr lang="en-US" sz="1100" dirty="0">
-                <a:solidFill>
-                  <a:schemeClr val="tx2"/>
-                </a:solidFill>
-              </a:rPr>
-              <a:t>median final time</a:t>
-            </a:r>
-            <a:endParaRPr lang="en-US" sz="1100" dirty="0"/>
-          </a:p>
-        </p:txBody>
-      </p:sp>
-      <p:sp>
-        <p:nvSpPr>
-          <p:cNvPr id="33" name="Wasted v4"/>
-          <p:cNvSpPr txBox="1"/>
-          <p:nvPr/>
-        </p:nvSpPr>
-        <p:spPr>
-          <a:xfrm>
-            <a:off x="7424928" y="4160520"/>
-            <a:ext cx="1737360" cy="365760"/>
-          </a:xfrm>
-          <a:prstGeom prst="rect">
-            <a:avLst/>
-          </a:prstGeom>
-          <a:noFill/>
-          <a:ln/>
-        </p:spPr>
-        <p:txBody>
-          <a:bodyPr wrap="square" lIns="0" tIns="0" rIns="0" bIns="0" rtlCol="0" anchor="t"/>
+              <a:rPr lang="en-US" sz="1400" dirty="0">
+                <a:solidFill>
+                  <a:schemeClr val="accent5"/>
+                </a:solidFill>
+              </a:rPr>
+              <a:t>time on the chip</a:t>
+            </a:r>
+            <a:endParaRPr lang="en-US" sz="1400" dirty="0"/>
+          </a:p>
+        </p:txBody>
+      </p:sp>
+      <p:sp>
+        <p:nvSpPr>
+          <p:cNvPr id="28" name="Profile value 2"/>
+          <p:cNvSpPr txBox="1"/>
+          <p:nvPr/>
+        </p:nvSpPr>
+        <p:spPr>
+          <a:xfrm>
+            <a:off x="7589520" y="3547872"/>
+            <a:ext cx="1920240" cy="640080"/>
+          </a:xfrm>
+          <a:prstGeom prst="rect">
+            <a:avLst/>
+          </a:prstGeom>
+          <a:noFill/>
+          <a:ln/>
+        </p:spPr>
+        <p:txBody>
+          <a:bodyPr wrap="square" lIns="0" tIns="0" rIns="0" bIns="0" rtlCol="0" anchor="ctr"/>
           <a:lstStyle/>
           <a:p>
             <a:pPr indent="0" marL="0">
               <a:buNone/>
             </a:pPr>
             <a:r>
-              <a:rPr lang="en-US" sz="1800" b="1" dirty="0">
-                <a:solidFill>
-                  <a:schemeClr val="tx1"/>
-                </a:solidFill>
-              </a:rPr>
-              <a:t>2 of 100</a:t>
-            </a:r>
-            <a:endParaRPr lang="en-US" sz="1800" dirty="0"/>
-          </a:p>
-        </p:txBody>
-      </p:sp>
-      <p:sp>
-        <p:nvSpPr>
-          <p:cNvPr id="34" name="Wasted label v4"/>
-          <p:cNvSpPr txBox="1"/>
-          <p:nvPr/>
-        </p:nvSpPr>
-        <p:spPr>
-          <a:xfrm>
-            <a:off x="7424928" y="4526280"/>
-            <a:ext cx="1737360" cy="365760"/>
-          </a:xfrm>
-          <a:prstGeom prst="rect">
-            <a:avLst/>
-          </a:prstGeom>
-          <a:noFill/>
-          <a:ln/>
-        </p:spPr>
-        <p:txBody>
-          <a:bodyPr wrap="square" lIns="0" tIns="0" rIns="0" bIns="0" rtlCol="0" anchor="t"/>
-          <a:lstStyle/>
-          <a:p>
-            <a:pPr indent="0" marL="0">
-              <a:buNone/>
-            </a:pPr>
-            <a:r>
-              <a:rPr lang="en-US" sz="1100" dirty="0">
-                <a:solidFill>
-                  <a:schemeClr val="tx2"/>
-                </a:solidFill>
-              </a:rPr>
-              <a:t>attempts with no measurement</a:t>
-            </a:r>
-            <a:endParaRPr lang="en-US" sz="1100" dirty="0"/>
-          </a:p>
-        </p:txBody>
-      </p:sp>
-      <p:sp>
-        <p:nvSpPr>
-          <p:cNvPr id="35" name="Design card v5"/>
-          <p:cNvSpPr/>
-          <p:nvPr/>
-        </p:nvSpPr>
-        <p:spPr>
-          <a:xfrm>
-            <a:off x="9473184" y="1463040"/>
-            <a:ext cx="2084832" cy="3520440"/>
-          </a:xfrm>
-          <a:prstGeom prst="roundRect">
-            <a:avLst>
-              <a:gd name="adj" fmla="val 3509"/>
-            </a:avLst>
-          </a:prstGeom>
-          <a:solidFill>
-            <a:schemeClr val="bg2"/>
-          </a:solidFill>
-          <a:ln w="12700">
-            <a:solidFill>
-              <a:schemeClr val="bg2"/>
-            </a:solidFill>
-            <a:prstDash val="solid"/>
-          </a:ln>
-        </p:spPr>
-      </p:sp>
-      <p:sp>
-        <p:nvSpPr>
-          <p:cNvPr id="36" name="Badge v5"/>
-          <p:cNvSpPr/>
-          <p:nvPr/>
-        </p:nvSpPr>
-        <p:spPr>
-          <a:xfrm>
-            <a:off x="9656064" y="1645920"/>
-            <a:ext cx="640080" cy="640080"/>
-          </a:xfrm>
-          <a:prstGeom prst="ellipse">
-            <a:avLst/>
-          </a:prstGeom>
-          <a:solidFill>
-            <a:schemeClr val="accent1"/>
-          </a:solidFill>
-          <a:ln w="12700">
-            <a:solidFill>
-              <a:schemeClr val="accent1"/>
-            </a:solidFill>
-            <a:prstDash val="solid"/>
-          </a:ln>
-        </p:spPr>
-      </p:sp>
-      <p:sp>
-        <p:nvSpPr>
-          <p:cNvPr id="37" name="Badge text v5"/>
-          <p:cNvSpPr txBox="1"/>
-          <p:nvPr/>
-        </p:nvSpPr>
-        <p:spPr>
-          <a:xfrm>
-            <a:off x="9656064" y="1645920"/>
-            <a:ext cx="640080" cy="640080"/>
-          </a:xfrm>
-          <a:prstGeom prst="rect">
-            <a:avLst/>
-          </a:prstGeom>
-          <a:noFill/>
-          <a:ln/>
-        </p:spPr>
-        <p:txBody>
-          <a:bodyPr wrap="square" lIns="0" tIns="0" rIns="0" bIns="0" rtlCol="0" anchor="ctr"/>
-          <a:lstStyle/>
-          <a:p>
-            <a:pPr algn="ctr" indent="0" marL="0">
-              <a:buNone/>
-            </a:pPr>
-            <a:r>
-              <a:rPr lang="en-US" sz="1800" b="1" dirty="0">
+              <a:rPr lang="en-US" sz="2600" b="1" dirty="0">
                 <a:solidFill>
                   <a:schemeClr val="bg1"/>
-                </a:solidFill>
-              </a:rPr>
-              <a:t>v5</a:t>
-            </a:r>
-            <a:endParaRPr lang="en-US" sz="1800" dirty="0"/>
-          </a:p>
-        </p:txBody>
-      </p:sp>
-      <p:sp>
-        <p:nvSpPr>
-          <p:cNvPr id="38" name="Shown v5"/>
-          <p:cNvSpPr txBox="1"/>
-          <p:nvPr/>
-        </p:nvSpPr>
-        <p:spPr>
-          <a:xfrm>
-            <a:off x="9656064" y="2423160"/>
-            <a:ext cx="1737360" cy="914400"/>
-          </a:xfrm>
-          <a:prstGeom prst="rect">
-            <a:avLst/>
-          </a:prstGeom>
-          <a:noFill/>
-          <a:ln/>
-        </p:spPr>
-        <p:txBody>
-          <a:bodyPr wrap="square" lIns="0" tIns="0" rIns="0" bIns="0" rtlCol="0" anchor="t"/>
-          <a:lstStyle/>
-          <a:p>
-            <a:pPr indent="0" marL="0">
-              <a:buNone/>
-            </a:pPr>
-            <a:r>
-              <a:rPr lang="en-US" sz="1500" b="1" dirty="0">
-                <a:solidFill>
-                  <a:schemeClr val="tx1"/>
-                </a:solidFill>
-              </a:rPr>
-              <a:t>v4, with far moves; names its move</a:t>
-            </a:r>
-            <a:endParaRPr lang="en-US" sz="1500" dirty="0"/>
-          </a:p>
-        </p:txBody>
-      </p:sp>
-      <p:sp>
-        <p:nvSpPr>
-          <p:cNvPr id="39" name="Time v5"/>
-          <p:cNvSpPr txBox="1"/>
-          <p:nvPr/>
-        </p:nvSpPr>
-        <p:spPr>
-          <a:xfrm>
-            <a:off x="9656064" y="3383280"/>
-            <a:ext cx="1737360" cy="457200"/>
-          </a:xfrm>
-          <a:prstGeom prst="rect">
-            <a:avLst/>
-          </a:prstGeom>
-          <a:noFill/>
-          <a:ln/>
-        </p:spPr>
-        <p:txBody>
-          <a:bodyPr wrap="square" lIns="0" tIns="0" rIns="0" bIns="0" rtlCol="0" anchor="t"/>
-          <a:lstStyle/>
-          <a:p>
-            <a:pPr indent="0" marL="0">
-              <a:buNone/>
-            </a:pPr>
-            <a:r>
-              <a:rPr lang="en-US" sz="2400" b="1" dirty="0">
-                <a:solidFill>
-                  <a:schemeClr val="accent1"/>
                 </a:solidFill>
                 <a:latin typeface="Cambria" pitchFamily="34" charset="0"/>
                 <a:ea typeface="Cambria" pitchFamily="34" charset="-122"/>
                 <a:cs typeface="Cambria" pitchFamily="34" charset="-120"/>
               </a:rPr>
-              <a:t>1,494 µs</a:t>
-            </a:r>
-            <a:endParaRPr lang="en-US" sz="2400" dirty="0"/>
-          </a:p>
-        </p:txBody>
-      </p:sp>
-      <p:sp>
-        <p:nvSpPr>
-          <p:cNvPr id="40" name="Time label v5"/>
-          <p:cNvSpPr txBox="1"/>
-          <p:nvPr/>
-        </p:nvSpPr>
-        <p:spPr>
-          <a:xfrm>
-            <a:off x="9656064" y="3822192"/>
-            <a:ext cx="1737360" cy="274320"/>
-          </a:xfrm>
-          <a:prstGeom prst="rect">
-            <a:avLst/>
-          </a:prstGeom>
-          <a:noFill/>
-          <a:ln/>
-        </p:spPr>
-        <p:txBody>
-          <a:bodyPr wrap="square" lIns="0" tIns="0" rIns="0" bIns="0" rtlCol="0" anchor="t"/>
+              <a:t>97.5%</a:t>
+            </a:r>
+            <a:endParaRPr lang="en-US" sz="2600" dirty="0"/>
+          </a:p>
+        </p:txBody>
+      </p:sp>
+      <p:sp>
+        <p:nvSpPr>
+          <p:cNvPr id="29" name="Profile label 2"/>
+          <p:cNvSpPr txBox="1"/>
+          <p:nvPr/>
+        </p:nvSpPr>
+        <p:spPr>
+          <a:xfrm>
+            <a:off x="9509760" y="3547872"/>
+            <a:ext cx="1920240" cy="640080"/>
+          </a:xfrm>
+          <a:prstGeom prst="rect">
+            <a:avLst/>
+          </a:prstGeom>
+          <a:noFill/>
+          <a:ln/>
+        </p:spPr>
+        <p:txBody>
+          <a:bodyPr wrap="square" lIns="0" tIns="0" rIns="0" bIns="0" rtlCol="0" anchor="ctr"/>
           <a:lstStyle/>
           <a:p>
             <a:pPr indent="0" marL="0">
               <a:buNone/>
             </a:pPr>
             <a:r>
-              <a:rPr lang="en-US" sz="1100" dirty="0">
-                <a:solidFill>
-                  <a:schemeClr val="tx2"/>
-                </a:solidFill>
-              </a:rPr>
-              <a:t>median final time</a:t>
-            </a:r>
-            <a:endParaRPr lang="en-US" sz="1100" dirty="0"/>
-          </a:p>
-        </p:txBody>
-      </p:sp>
-      <p:sp>
-        <p:nvSpPr>
-          <p:cNvPr id="41" name="Wasted v5"/>
-          <p:cNvSpPr txBox="1"/>
-          <p:nvPr/>
-        </p:nvSpPr>
-        <p:spPr>
-          <a:xfrm>
-            <a:off x="9656064" y="4160520"/>
-            <a:ext cx="1737360" cy="365760"/>
-          </a:xfrm>
-          <a:prstGeom prst="rect">
-            <a:avLst/>
-          </a:prstGeom>
-          <a:noFill/>
-          <a:ln/>
-        </p:spPr>
-        <p:txBody>
-          <a:bodyPr wrap="square" lIns="0" tIns="0" rIns="0" bIns="0" rtlCol="0" anchor="t"/>
+              <a:rPr lang="en-US" sz="1400" dirty="0">
+                <a:solidFill>
+                  <a:schemeClr val="accent5"/>
+                </a:solidFill>
+              </a:rPr>
+              <a:t>tensor engine busy</a:t>
+            </a:r>
+            <a:endParaRPr lang="en-US" sz="1400" dirty="0"/>
+          </a:p>
+        </p:txBody>
+      </p:sp>
+      <p:sp>
+        <p:nvSpPr>
+          <p:cNvPr id="30" name="Profile value 3"/>
+          <p:cNvSpPr txBox="1"/>
+          <p:nvPr/>
+        </p:nvSpPr>
+        <p:spPr>
+          <a:xfrm>
+            <a:off x="7589520" y="4352544"/>
+            <a:ext cx="1920240" cy="640080"/>
+          </a:xfrm>
+          <a:prstGeom prst="rect">
+            <a:avLst/>
+          </a:prstGeom>
+          <a:noFill/>
+          <a:ln/>
+        </p:spPr>
+        <p:txBody>
+          <a:bodyPr wrap="square" lIns="0" tIns="0" rIns="0" bIns="0" rtlCol="0" anchor="ctr"/>
           <a:lstStyle/>
           <a:p>
             <a:pPr indent="0" marL="0">
               <a:buNone/>
             </a:pPr>
             <a:r>
-              <a:rPr lang="en-US" sz="1800" b="1" dirty="0">
-                <a:solidFill>
-                  <a:schemeClr val="tx1"/>
-                </a:solidFill>
-              </a:rPr>
-              <a:t>0 of 100</a:t>
-            </a:r>
-            <a:endParaRPr lang="en-US" sz="1800" dirty="0"/>
-          </a:p>
-        </p:txBody>
-      </p:sp>
-      <p:sp>
-        <p:nvSpPr>
-          <p:cNvPr id="42" name="Wasted label v5"/>
-          <p:cNvSpPr txBox="1"/>
-          <p:nvPr/>
-        </p:nvSpPr>
-        <p:spPr>
-          <a:xfrm>
-            <a:off x="9656064" y="4526280"/>
-            <a:ext cx="1737360" cy="365760"/>
-          </a:xfrm>
-          <a:prstGeom prst="rect">
-            <a:avLst/>
-          </a:prstGeom>
-          <a:noFill/>
-          <a:ln/>
-        </p:spPr>
-        <p:txBody>
-          <a:bodyPr wrap="square" lIns="0" tIns="0" rIns="0" bIns="0" rtlCol="0" anchor="t"/>
+              <a:rPr lang="en-US" sz="2600" b="1" dirty="0">
+                <a:solidFill>
+                  <a:schemeClr val="bg1"/>
+                </a:solidFill>
+                <a:latin typeface="Cambria" pitchFamily="34" charset="0"/>
+                <a:ea typeface="Cambria" pitchFamily="34" charset="-122"/>
+                <a:cs typeface="Cambria" pitchFamily="34" charset="-120"/>
+              </a:rPr>
+              <a:t>21.7%</a:t>
+            </a:r>
+            <a:endParaRPr lang="en-US" sz="2600" dirty="0"/>
+          </a:p>
+        </p:txBody>
+      </p:sp>
+      <p:sp>
+        <p:nvSpPr>
+          <p:cNvPr id="31" name="Profile label 3"/>
+          <p:cNvSpPr txBox="1"/>
+          <p:nvPr/>
+        </p:nvSpPr>
+        <p:spPr>
+          <a:xfrm>
+            <a:off x="9509760" y="4352544"/>
+            <a:ext cx="1920240" cy="640080"/>
+          </a:xfrm>
+          <a:prstGeom prst="rect">
+            <a:avLst/>
+          </a:prstGeom>
+          <a:noFill/>
+          <a:ln/>
+        </p:spPr>
+        <p:txBody>
+          <a:bodyPr wrap="square" lIns="0" tIns="0" rIns="0" bIns="0" rtlCol="0" anchor="ctr"/>
           <a:lstStyle/>
           <a:p>
             <a:pPr indent="0" marL="0">
               <a:buNone/>
             </a:pPr>
             <a:r>
-              <a:rPr lang="en-US" sz="1100" dirty="0">
-                <a:solidFill>
-                  <a:schemeClr val="tx2"/>
-                </a:solidFill>
-              </a:rPr>
-              <a:t>attempts with no measurement</a:t>
-            </a:r>
-            <a:endParaRPr lang="en-US" sz="1100" dirty="0"/>
-          </a:p>
-        </p:txBody>
-      </p:sp>
-      <p:sp>
-        <p:nvSpPr>
-          <p:cNvPr id="43" name="Design caption"/>
-          <p:cNvSpPr txBox="1"/>
-          <p:nvPr/>
-        </p:nvSpPr>
-        <p:spPr>
-          <a:xfrm>
-            <a:off x="548640" y="5257800"/>
-            <a:ext cx="11064240" cy="731520"/>
-          </a:xfrm>
-          <a:prstGeom prst="rect">
-            <a:avLst/>
-          </a:prstGeom>
-          <a:noFill/>
-          <a:ln/>
-        </p:spPr>
-        <p:txBody>
-          <a:bodyPr wrap="square" lIns="0" tIns="0" rIns="0" bIns="0" rtlCol="0" anchor="t"/>
+              <a:rPr lang="en-US" sz="1400" dirty="0">
+                <a:solidFill>
+                  <a:schemeClr val="accent5"/>
+                </a:solidFill>
+              </a:rPr>
+              <a:t>data movement busy</a:t>
+            </a:r>
+            <a:endParaRPr lang="en-US" sz="1400" dirty="0"/>
+          </a:p>
+        </p:txBody>
+      </p:sp>
+      <p:sp>
+        <p:nvSpPr>
+          <p:cNvPr id="32" name="Profile value 4"/>
+          <p:cNvSpPr txBox="1"/>
+          <p:nvPr/>
+        </p:nvSpPr>
+        <p:spPr>
+          <a:xfrm>
+            <a:off x="7589520" y="5157216"/>
+            <a:ext cx="1920240" cy="640080"/>
+          </a:xfrm>
+          <a:prstGeom prst="rect">
+            <a:avLst/>
+          </a:prstGeom>
+          <a:noFill/>
+          <a:ln/>
+        </p:spPr>
+        <p:txBody>
+          <a:bodyPr wrap="square" lIns="0" tIns="0" rIns="0" bIns="0" rtlCol="0" anchor="ctr"/>
           <a:lstStyle/>
           <a:p>
             <a:pPr indent="0" marL="0">
               <a:buNone/>
             </a:pPr>
             <a:r>
-              <a:rPr lang="en-US" sz="1500" dirty="0">
-                <a:solidFill>
-                  <a:schemeClr val="tx2"/>
-                </a:solidFill>
-              </a:rPr>
-              <a:t>Each design fixes a failure we read in the previous one's log. The model, Qwen3-8B, never changed. Adapter-style shape, 10 starting points: best possible 1,361 µs, random guessing 1,467 µs.</a:t>
-            </a:r>
-            <a:endParaRPr lang="en-US" sz="1500" dirty="0"/>
+              <a:rPr lang="en-US" sz="2600" b="1" dirty="0">
+                <a:solidFill>
+                  <a:schemeClr val="bg1"/>
+                </a:solidFill>
+                <a:latin typeface="Cambria" pitchFamily="34" charset="0"/>
+                <a:ea typeface="Cambria" pitchFamily="34" charset="-122"/>
+                <a:cs typeface="Cambria" pitchFamily="34" charset="-120"/>
+              </a:rPr>
+              <a:t>67.1 MB</a:t>
+            </a:r>
+            <a:endParaRPr lang="en-US" sz="2600" dirty="0"/>
+          </a:p>
+        </p:txBody>
+      </p:sp>
+      <p:sp>
+        <p:nvSpPr>
+          <p:cNvPr id="33" name="Profile label 4"/>
+          <p:cNvSpPr txBox="1"/>
+          <p:nvPr/>
+        </p:nvSpPr>
+        <p:spPr>
+          <a:xfrm>
+            <a:off x="9509760" y="5157216"/>
+            <a:ext cx="1920240" cy="640080"/>
+          </a:xfrm>
+          <a:prstGeom prst="rect">
+            <a:avLst/>
+          </a:prstGeom>
+          <a:noFill/>
+          <a:ln/>
+        </p:spPr>
+        <p:txBody>
+          <a:bodyPr wrap="square" lIns="0" tIns="0" rIns="0" bIns="0" rtlCol="0" anchor="ctr"/>
+          <a:lstStyle/>
+          <a:p>
+            <a:pPr indent="0" marL="0">
+              <a:buNone/>
+            </a:pPr>
+            <a:r>
+              <a:rPr lang="en-US" sz="1400" dirty="0">
+                <a:solidFill>
+                  <a:schemeClr val="accent5"/>
+                </a:solidFill>
+              </a:rPr>
+              <a:t>moved in 96 transfers</a:t>
+            </a:r>
+            <a:endParaRPr lang="en-US" sz="1400" dirty="0"/>
           </a:p>
         </p:txBody>
       </p:sp>
@@ -5582,50 +5348,26 @@
                   <a:schemeClr val="tx1"/>
                 </a:solidFill>
               </a:rPr>
-              <a:t>What we got: the checker decides, not the model</a:t>
+              <a:t>What we tried: five checker designs, one model</a:t>
             </a:r>
             <a:endParaRPr lang="en-US" sz="3600" dirty="0"/>
           </a:p>
         </p:txBody>
       </p:sp>
-      <p:pic>
-        <p:nvPicPr>
-          <p:cNvPr id="3" name="Chart: best time against attempts, 30 starts" descr="Line chart of best kernel time found against attempts on the chip, for each approach, at the adapter shape">    </p:cNvPr>
-          <p:cNvPicPr>
-            <a:picLocks noChangeAspect="1"/>
-          </p:cNvPicPr>
-          <p:nvPr/>
-        </p:nvPicPr>
-        <p:blipFill>
-          <a:blip r:embed="rId1"/>
-          <a:stretch>
-            <a:fillRect/>
-          </a:stretch>
-        </p:blipFill>
-        <p:spPr>
-          <a:xfrm>
-            <a:off x="548640" y="1417320"/>
-            <a:ext cx="6766560" cy="4663440"/>
-          </a:xfrm>
-          <a:prstGeom prst="rect">
-            <a:avLst/>
-          </a:prstGeom>
-        </p:spPr>
-      </p:pic>
-      <p:sp>
-        <p:nvSpPr>
-          <p:cNvPr id="4" name="Result card 1"/>
+      <p:sp>
+        <p:nvSpPr>
+          <p:cNvPr id="3" name="Design card v1"/>
           <p:cNvSpPr/>
           <p:nvPr/>
         </p:nvSpPr>
         <p:spPr>
           <a:xfrm>
-            <a:off x="7589520" y="1417320"/>
-            <a:ext cx="4023360" cy="1417320"/>
+            <a:off x="548640" y="1463040"/>
+            <a:ext cx="2084832" cy="3520440"/>
           </a:xfrm>
           <a:prstGeom prst="roundRect">
             <a:avLst>
-              <a:gd name="adj" fmla="val 5161"/>
+              <a:gd name="adj" fmla="val 3509"/>
             </a:avLst>
           </a:prstGeom>
           <a:solidFill>
@@ -5641,14 +5383,39 @@
       </p:sp>
       <p:sp>
         <p:nvSpPr>
-          <p:cNvPr id="5" name="Result 1"/>
-          <p:cNvSpPr txBox="1"/>
-          <p:nvPr/>
-        </p:nvSpPr>
-        <p:spPr>
-          <a:xfrm>
-            <a:off x="7818120" y="1554480"/>
-            <a:ext cx="3566160" cy="566928"/>
+          <p:cNvPr id="4" name="Badge v1"/>
+          <p:cNvSpPr/>
+          <p:nvPr/>
+        </p:nvSpPr>
+        <p:spPr>
+          <a:xfrm>
+            <a:off x="731520" y="1645920"/>
+            <a:ext cx="640080" cy="640080"/>
+          </a:xfrm>
+          <a:prstGeom prst="ellipse">
+            <a:avLst/>
+          </a:prstGeom>
+          <a:solidFill>
+            <a:schemeClr val="accent4"/>
+          </a:solidFill>
+          <a:ln w="12700">
+            <a:solidFill>
+              <a:schemeClr val="accent4"/>
+            </a:solidFill>
+            <a:prstDash val="solid"/>
+          </a:ln>
+        </p:spPr>
+      </p:sp>
+      <p:sp>
+        <p:nvSpPr>
+          <p:cNvPr id="5" name="Badge text v1"/>
+          <p:cNvSpPr txBox="1"/>
+          <p:nvPr/>
+        </p:nvSpPr>
+        <p:spPr>
+          <a:xfrm>
+            <a:off x="731520" y="1645920"/>
+            <a:ext cx="640080" cy="640080"/>
           </a:xfrm>
           <a:prstGeom prst="rect">
             <a:avLst/>
@@ -5660,34 +5427,106 @@
           <a:bodyPr wrap="square" lIns="0" tIns="0" rIns="0" bIns="0" rtlCol="0" anchor="ctr"/>
           <a:lstStyle/>
           <a:p>
+            <a:pPr algn="ctr" indent="0" marL="0">
+              <a:buNone/>
+            </a:pPr>
+            <a:r>
+              <a:rPr lang="en-US" sz="1800" b="1" dirty="0">
+                <a:solidFill>
+                  <a:schemeClr val="bg1"/>
+                </a:solidFill>
+              </a:rPr>
+              <a:t>v1</a:t>
+            </a:r>
+            <a:endParaRPr lang="en-US" sz="1800" dirty="0"/>
+          </a:p>
+        </p:txBody>
+      </p:sp>
+      <p:sp>
+        <p:nvSpPr>
+          <p:cNvPr id="6" name="Shown v1"/>
+          <p:cNvSpPr txBox="1"/>
+          <p:nvPr/>
+        </p:nvSpPr>
+        <p:spPr>
+          <a:xfrm>
+            <a:off x="731520" y="2423160"/>
+            <a:ext cx="1737360" cy="914400"/>
+          </a:xfrm>
+          <a:prstGeom prst="rect">
+            <a:avLst/>
+          </a:prstGeom>
+          <a:noFill/>
+          <a:ln/>
+        </p:spPr>
+        <p:txBody>
+          <a:bodyPr wrap="square" lIns="0" tIns="0" rIns="0" bIns="0" rtlCol="0" anchor="t"/>
+          <a:lstStyle/>
+          <a:p>
             <a:pPr indent="0" marL="0">
               <a:buNone/>
             </a:pPr>
             <a:r>
-              <a:rPr lang="en-US" sz="3000" b="1" dirty="0">
-                <a:solidFill>
-                  <a:schemeClr val="accent1"/>
+              <a:rPr lang="en-US" sz="1500" b="1" dirty="0">
+                <a:solidFill>
+                  <a:schemeClr val="tx1"/>
+                </a:solidFill>
+              </a:rPr>
+              <a:t>Raw profile numbers</a:t>
+            </a:r>
+            <a:endParaRPr lang="en-US" sz="1500" dirty="0"/>
+          </a:p>
+        </p:txBody>
+      </p:sp>
+      <p:sp>
+        <p:nvSpPr>
+          <p:cNvPr id="7" name="Time v1"/>
+          <p:cNvSpPr txBox="1"/>
+          <p:nvPr/>
+        </p:nvSpPr>
+        <p:spPr>
+          <a:xfrm>
+            <a:off x="731520" y="3383280"/>
+            <a:ext cx="1737360" cy="457200"/>
+          </a:xfrm>
+          <a:prstGeom prst="rect">
+            <a:avLst/>
+          </a:prstGeom>
+          <a:noFill/>
+          <a:ln/>
+        </p:spPr>
+        <p:txBody>
+          <a:bodyPr wrap="square" lIns="0" tIns="0" rIns="0" bIns="0" rtlCol="0" anchor="t"/>
+          <a:lstStyle/>
+          <a:p>
+            <a:pPr indent="0" marL="0">
+              <a:buNone/>
+            </a:pPr>
+            <a:r>
+              <a:rPr lang="en-US" sz="2400" b="1" dirty="0">
+                <a:solidFill>
+                  <a:schemeClr val="accent4"/>
                 </a:solidFill>
                 <a:latin typeface="Cambria" pitchFamily="34" charset="0"/>
                 <a:ea typeface="Cambria" pitchFamily="34" charset="-122"/>
                 <a:cs typeface="Cambria" pitchFamily="34" charset="-120"/>
               </a:rPr>
-              <a:t>3 → 29 of 30</a:t>
-            </a:r>
-            <a:endParaRPr lang="en-US" sz="3000" dirty="0"/>
-          </a:p>
-        </p:txBody>
-      </p:sp>
-      <p:sp>
-        <p:nvSpPr>
-          <p:cNvPr id="6" name="Result label 1"/>
-          <p:cNvSpPr txBox="1"/>
-          <p:nvPr/>
-        </p:nvSpPr>
-        <p:spPr>
-          <a:xfrm>
-            <a:off x="7818120" y="2148840"/>
-            <a:ext cx="3566160" cy="594360"/>
+              <a:t>2,285 µs</a:t>
+            </a:r>
+            <a:endParaRPr lang="en-US" sz="2400" dirty="0"/>
+          </a:p>
+        </p:txBody>
+      </p:sp>
+      <p:sp>
+        <p:nvSpPr>
+          <p:cNvPr id="8" name="Time label v1"/>
+          <p:cNvSpPr txBox="1"/>
+          <p:nvPr/>
+        </p:nvSpPr>
+        <p:spPr>
+          <a:xfrm>
+            <a:off x="731520" y="3822192"/>
+            <a:ext cx="1737360" cy="274320"/>
           </a:xfrm>
           <a:prstGeom prst="rect">
             <a:avLst/>
@@ -5703,31 +5542,103 @@
               <a:buNone/>
             </a:pPr>
             <a:r>
-              <a:rPr lang="en-US" sz="1300" dirty="0">
+              <a:rPr lang="en-US" sz="1100" dirty="0">
                 <a:solidFill>
                   <a:schemeClr val="tx2"/>
                 </a:solidFill>
               </a:rPr>
-              <a:t>runs within 10% of the best, first checker to last, same model</a:t>
-            </a:r>
-            <a:endParaRPr lang="en-US" sz="1300" dirty="0"/>
-          </a:p>
-        </p:txBody>
-      </p:sp>
-      <p:sp>
-        <p:nvSpPr>
-          <p:cNvPr id="7" name="Result card 2"/>
+              <a:t>median final time</a:t>
+            </a:r>
+            <a:endParaRPr lang="en-US" sz="1100" dirty="0"/>
+          </a:p>
+        </p:txBody>
+      </p:sp>
+      <p:sp>
+        <p:nvSpPr>
+          <p:cNvPr id="9" name="Wasted v1"/>
+          <p:cNvSpPr txBox="1"/>
+          <p:nvPr/>
+        </p:nvSpPr>
+        <p:spPr>
+          <a:xfrm>
+            <a:off x="731520" y="4160520"/>
+            <a:ext cx="1737360" cy="365760"/>
+          </a:xfrm>
+          <a:prstGeom prst="rect">
+            <a:avLst/>
+          </a:prstGeom>
+          <a:noFill/>
+          <a:ln/>
+        </p:spPr>
+        <p:txBody>
+          <a:bodyPr wrap="square" lIns="0" tIns="0" rIns="0" bIns="0" rtlCol="0" anchor="t"/>
+          <a:lstStyle/>
+          <a:p>
+            <a:pPr indent="0" marL="0">
+              <a:buNone/>
+            </a:pPr>
+            <a:r>
+              <a:rPr lang="en-US" sz="1800" b="1" dirty="0">
+                <a:solidFill>
+                  <a:schemeClr val="tx1"/>
+                </a:solidFill>
+              </a:rPr>
+              <a:t>66 of 100</a:t>
+            </a:r>
+            <a:endParaRPr lang="en-US" sz="1800" dirty="0"/>
+          </a:p>
+        </p:txBody>
+      </p:sp>
+      <p:sp>
+        <p:nvSpPr>
+          <p:cNvPr id="10" name="Wasted label v1"/>
+          <p:cNvSpPr txBox="1"/>
+          <p:nvPr/>
+        </p:nvSpPr>
+        <p:spPr>
+          <a:xfrm>
+            <a:off x="731520" y="4526280"/>
+            <a:ext cx="1737360" cy="365760"/>
+          </a:xfrm>
+          <a:prstGeom prst="rect">
+            <a:avLst/>
+          </a:prstGeom>
+          <a:noFill/>
+          <a:ln/>
+        </p:spPr>
+        <p:txBody>
+          <a:bodyPr wrap="square" lIns="0" tIns="0" rIns="0" bIns="0" rtlCol="0" anchor="t"/>
+          <a:lstStyle/>
+          <a:p>
+            <a:pPr indent="0" marL="0">
+              <a:buNone/>
+            </a:pPr>
+            <a:r>
+              <a:rPr lang="en-US" sz="1100" dirty="0">
+                <a:solidFill>
+                  <a:schemeClr val="tx2"/>
+                </a:solidFill>
+              </a:rPr>
+              <a:t>attempts with no measurement</a:t>
+            </a:r>
+            <a:endParaRPr lang="en-US" sz="1100" dirty="0"/>
+          </a:p>
+        </p:txBody>
+      </p:sp>
+      <p:sp>
+        <p:nvSpPr>
+          <p:cNvPr id="11" name="Design card v2"/>
           <p:cNvSpPr/>
           <p:nvPr/>
         </p:nvSpPr>
         <p:spPr>
           <a:xfrm>
-            <a:off x="7589520" y="2990088"/>
-            <a:ext cx="4023360" cy="1417320"/>
+            <a:off x="2779776" y="1463040"/>
+            <a:ext cx="2084832" cy="3520440"/>
           </a:xfrm>
           <a:prstGeom prst="roundRect">
             <a:avLst>
-              <a:gd name="adj" fmla="val 5161"/>
+              <a:gd name="adj" fmla="val 3509"/>
             </a:avLst>
           </a:prstGeom>
           <a:solidFill>
@@ -5743,14 +5654,39 @@
       </p:sp>
       <p:sp>
         <p:nvSpPr>
-          <p:cNvPr id="8" name="Result 2"/>
-          <p:cNvSpPr txBox="1"/>
-          <p:nvPr/>
-        </p:nvSpPr>
-        <p:spPr>
-          <a:xfrm>
-            <a:off x="7818120" y="3127248"/>
-            <a:ext cx="3566160" cy="566928"/>
+          <p:cNvPr id="12" name="Badge v2"/>
+          <p:cNvSpPr/>
+          <p:nvPr/>
+        </p:nvSpPr>
+        <p:spPr>
+          <a:xfrm>
+            <a:off x="2962656" y="1645920"/>
+            <a:ext cx="640080" cy="640080"/>
+          </a:xfrm>
+          <a:prstGeom prst="ellipse">
+            <a:avLst/>
+          </a:prstGeom>
+          <a:solidFill>
+            <a:schemeClr val="accent2"/>
+          </a:solidFill>
+          <a:ln w="12700">
+            <a:solidFill>
+              <a:schemeClr val="accent2"/>
+            </a:solidFill>
+            <a:prstDash val="solid"/>
+          </a:ln>
+        </p:spPr>
+      </p:sp>
+      <p:sp>
+        <p:nvSpPr>
+          <p:cNvPr id="13" name="Badge text v2"/>
+          <p:cNvSpPr txBox="1"/>
+          <p:nvPr/>
+        </p:nvSpPr>
+        <p:spPr>
+          <a:xfrm>
+            <a:off x="2962656" y="1645920"/>
+            <a:ext cx="640080" cy="640080"/>
           </a:xfrm>
           <a:prstGeom prst="rect">
             <a:avLst/>
@@ -5762,34 +5698,106 @@
           <a:bodyPr wrap="square" lIns="0" tIns="0" rIns="0" bIns="0" rtlCol="0" anchor="ctr"/>
           <a:lstStyle/>
           <a:p>
+            <a:pPr algn="ctr" indent="0" marL="0">
+              <a:buNone/>
+            </a:pPr>
+            <a:r>
+              <a:rPr lang="en-US" sz="1800" b="1" dirty="0">
+                <a:solidFill>
+                  <a:schemeClr val="bg1"/>
+                </a:solidFill>
+              </a:rPr>
+              <a:t>v2</a:t>
+            </a:r>
+            <a:endParaRPr lang="en-US" sz="1800" dirty="0"/>
+          </a:p>
+        </p:txBody>
+      </p:sp>
+      <p:sp>
+        <p:nvSpPr>
+          <p:cNvPr id="14" name="Shown v2"/>
+          <p:cNvSpPr txBox="1"/>
+          <p:nvPr/>
+        </p:nvSpPr>
+        <p:spPr>
+          <a:xfrm>
+            <a:off x="2962656" y="2423160"/>
+            <a:ext cx="1737360" cy="914400"/>
+          </a:xfrm>
+          <a:prstGeom prst="rect">
+            <a:avLst/>
+          </a:prstGeom>
+          <a:noFill/>
+          <a:ln/>
+        </p:spPr>
+        <p:txBody>
+          <a:bodyPr wrap="square" lIns="0" tIns="0" rIns="0" bIns="0" rtlCol="0" anchor="t"/>
+          <a:lstStyle/>
+          <a:p>
             <a:pPr indent="0" marL="0">
               <a:buNone/>
             </a:pPr>
             <a:r>
-              <a:rPr lang="en-US" sz="3000" b="1" dirty="0">
-                <a:solidFill>
-                  <a:schemeClr val="accent3"/>
+              <a:rPr lang="en-US" sz="1500" b="1" dirty="0">
+                <a:solidFill>
+                  <a:schemeClr val="tx1"/>
+                </a:solidFill>
+              </a:rPr>
+              <a:t>Comparisons worked out in code</a:t>
+            </a:r>
+            <a:endParaRPr lang="en-US" sz="1500" dirty="0"/>
+          </a:p>
+        </p:txBody>
+      </p:sp>
+      <p:sp>
+        <p:nvSpPr>
+          <p:cNvPr id="15" name="Time v2"/>
+          <p:cNvSpPr txBox="1"/>
+          <p:nvPr/>
+        </p:nvSpPr>
+        <p:spPr>
+          <a:xfrm>
+            <a:off x="2962656" y="3383280"/>
+            <a:ext cx="1737360" cy="457200"/>
+          </a:xfrm>
+          <a:prstGeom prst="rect">
+            <a:avLst/>
+          </a:prstGeom>
+          <a:noFill/>
+          <a:ln/>
+        </p:spPr>
+        <p:txBody>
+          <a:bodyPr wrap="square" lIns="0" tIns="0" rIns="0" bIns="0" rtlCol="0" anchor="t"/>
+          <a:lstStyle/>
+          <a:p>
+            <a:pPr indent="0" marL="0">
+              <a:buNone/>
+            </a:pPr>
+            <a:r>
+              <a:rPr lang="en-US" sz="2400" b="1" dirty="0">
+                <a:solidFill>
+                  <a:schemeClr val="accent2"/>
                 </a:solidFill>
                 <a:latin typeface="Cambria" pitchFamily="34" charset="0"/>
                 <a:ea typeface="Cambria" pitchFamily="34" charset="-122"/>
                 <a:cs typeface="Cambria" pitchFamily="34" charset="-120"/>
               </a:rPr>
-              <a:t>73%</a:t>
-            </a:r>
-            <a:endParaRPr lang="en-US" sz="3000" dirty="0"/>
-          </a:p>
-        </p:txBody>
-      </p:sp>
-      <p:sp>
-        <p:nvSpPr>
-          <p:cNvPr id="9" name="Result label 2"/>
-          <p:cNvSpPr txBox="1"/>
-          <p:nvPr/>
-        </p:nvSpPr>
-        <p:spPr>
-          <a:xfrm>
-            <a:off x="7818120" y="3721608"/>
-            <a:ext cx="3566160" cy="594360"/>
+              <a:t>1,553 µs</a:t>
+            </a:r>
+            <a:endParaRPr lang="en-US" sz="2400" dirty="0"/>
+          </a:p>
+        </p:txBody>
+      </p:sp>
+      <p:sp>
+        <p:nvSpPr>
+          <p:cNvPr id="16" name="Time label v2"/>
+          <p:cNvSpPr txBox="1"/>
+          <p:nvPr/>
+        </p:nvSpPr>
+        <p:spPr>
+          <a:xfrm>
+            <a:off x="2962656" y="3822192"/>
+            <a:ext cx="1737360" cy="274320"/>
           </a:xfrm>
           <a:prstGeom prst="rect">
             <a:avLst/>
@@ -5805,31 +5813,103 @@
               <a:buNone/>
             </a:pPr>
             <a:r>
-              <a:rPr lang="en-US" sz="1300" dirty="0">
+              <a:rPr lang="en-US" sz="1100" dirty="0">
                 <a:solidFill>
                   <a:schemeClr val="tx2"/>
                 </a:solidFill>
               </a:rPr>
-              <a:t>of runs within 10% of the best for random guessing</a:t>
-            </a:r>
-            <a:endParaRPr lang="en-US" sz="1300" dirty="0"/>
-          </a:p>
-        </p:txBody>
-      </p:sp>
-      <p:sp>
-        <p:nvSpPr>
-          <p:cNvPr id="10" name="Result card 3"/>
+              <a:t>median final time</a:t>
+            </a:r>
+            <a:endParaRPr lang="en-US" sz="1100" dirty="0"/>
+          </a:p>
+        </p:txBody>
+      </p:sp>
+      <p:sp>
+        <p:nvSpPr>
+          <p:cNvPr id="17" name="Wasted v2"/>
+          <p:cNvSpPr txBox="1"/>
+          <p:nvPr/>
+        </p:nvSpPr>
+        <p:spPr>
+          <a:xfrm>
+            <a:off x="2962656" y="4160520"/>
+            <a:ext cx="1737360" cy="365760"/>
+          </a:xfrm>
+          <a:prstGeom prst="rect">
+            <a:avLst/>
+          </a:prstGeom>
+          <a:noFill/>
+          <a:ln/>
+        </p:spPr>
+        <p:txBody>
+          <a:bodyPr wrap="square" lIns="0" tIns="0" rIns="0" bIns="0" rtlCol="0" anchor="t"/>
+          <a:lstStyle/>
+          <a:p>
+            <a:pPr indent="0" marL="0">
+              <a:buNone/>
+            </a:pPr>
+            <a:r>
+              <a:rPr lang="en-US" sz="1800" b="1" dirty="0">
+                <a:solidFill>
+                  <a:schemeClr val="tx1"/>
+                </a:solidFill>
+              </a:rPr>
+              <a:t>70 of 100</a:t>
+            </a:r>
+            <a:endParaRPr lang="en-US" sz="1800" dirty="0"/>
+          </a:p>
+        </p:txBody>
+      </p:sp>
+      <p:sp>
+        <p:nvSpPr>
+          <p:cNvPr id="18" name="Wasted label v2"/>
+          <p:cNvSpPr txBox="1"/>
+          <p:nvPr/>
+        </p:nvSpPr>
+        <p:spPr>
+          <a:xfrm>
+            <a:off x="2962656" y="4526280"/>
+            <a:ext cx="1737360" cy="365760"/>
+          </a:xfrm>
+          <a:prstGeom prst="rect">
+            <a:avLst/>
+          </a:prstGeom>
+          <a:noFill/>
+          <a:ln/>
+        </p:spPr>
+        <p:txBody>
+          <a:bodyPr wrap="square" lIns="0" tIns="0" rIns="0" bIns="0" rtlCol="0" anchor="t"/>
+          <a:lstStyle/>
+          <a:p>
+            <a:pPr indent="0" marL="0">
+              <a:buNone/>
+            </a:pPr>
+            <a:r>
+              <a:rPr lang="en-US" sz="1100" dirty="0">
+                <a:solidFill>
+                  <a:schemeClr val="tx2"/>
+                </a:solidFill>
+              </a:rPr>
+              <a:t>attempts with no measurement</a:t>
+            </a:r>
+            <a:endParaRPr lang="en-US" sz="1100" dirty="0"/>
+          </a:p>
+        </p:txBody>
+      </p:sp>
+      <p:sp>
+        <p:nvSpPr>
+          <p:cNvPr id="19" name="Design card v3"/>
           <p:cNvSpPr/>
           <p:nvPr/>
         </p:nvSpPr>
         <p:spPr>
           <a:xfrm>
-            <a:off x="7589520" y="4562856"/>
-            <a:ext cx="4023360" cy="1417320"/>
+            <a:off x="5010912" y="1463040"/>
+            <a:ext cx="2084832" cy="3520440"/>
           </a:xfrm>
           <a:prstGeom prst="roundRect">
             <a:avLst>
-              <a:gd name="adj" fmla="val 5161"/>
+              <a:gd name="adj" fmla="val 3509"/>
             </a:avLst>
           </a:prstGeom>
           <a:solidFill>
@@ -5845,14 +5925,39 @@
       </p:sp>
       <p:sp>
         <p:nvSpPr>
-          <p:cNvPr id="11" name="Result 3"/>
-          <p:cNvSpPr txBox="1"/>
-          <p:nvPr/>
-        </p:nvSpPr>
-        <p:spPr>
-          <a:xfrm>
-            <a:off x="7818120" y="4700016"/>
-            <a:ext cx="3566160" cy="566928"/>
+          <p:cNvPr id="20" name="Badge v3"/>
+          <p:cNvSpPr/>
+          <p:nvPr/>
+        </p:nvSpPr>
+        <p:spPr>
+          <a:xfrm>
+            <a:off x="5193792" y="1645920"/>
+            <a:ext cx="640080" cy="640080"/>
+          </a:xfrm>
+          <a:prstGeom prst="ellipse">
+            <a:avLst/>
+          </a:prstGeom>
+          <a:solidFill>
+            <a:schemeClr val="accent3"/>
+          </a:solidFill>
+          <a:ln w="12700">
+            <a:solidFill>
+              <a:schemeClr val="accent3"/>
+            </a:solidFill>
+            <a:prstDash val="solid"/>
+          </a:ln>
+        </p:spPr>
+      </p:sp>
+      <p:sp>
+        <p:nvSpPr>
+          <p:cNvPr id="21" name="Badge text v3"/>
+          <p:cNvSpPr txBox="1"/>
+          <p:nvPr/>
+        </p:nvSpPr>
+        <p:spPr>
+          <a:xfrm>
+            <a:off x="5193792" y="1645920"/>
+            <a:ext cx="640080" cy="640080"/>
           </a:xfrm>
           <a:prstGeom prst="rect">
             <a:avLst/>
@@ -5864,34 +5969,106 @@
           <a:bodyPr wrap="square" lIns="0" tIns="0" rIns="0" bIns="0" rtlCol="0" anchor="ctr"/>
           <a:lstStyle/>
           <a:p>
+            <a:pPr algn="ctr" indent="0" marL="0">
+              <a:buNone/>
+            </a:pPr>
+            <a:r>
+              <a:rPr lang="en-US" sz="1800" b="1" dirty="0">
+                <a:solidFill>
+                  <a:schemeClr val="bg1"/>
+                </a:solidFill>
+              </a:rPr>
+              <a:t>v3</a:t>
+            </a:r>
+            <a:endParaRPr lang="en-US" sz="1800" dirty="0"/>
+          </a:p>
+        </p:txBody>
+      </p:sp>
+      <p:sp>
+        <p:nvSpPr>
+          <p:cNvPr id="22" name="Shown v3"/>
+          <p:cNvSpPr txBox="1"/>
+          <p:nvPr/>
+        </p:nvSpPr>
+        <p:spPr>
+          <a:xfrm>
+            <a:off x="5193792" y="2423160"/>
+            <a:ext cx="1737360" cy="914400"/>
+          </a:xfrm>
+          <a:prstGeom prst="rect">
+            <a:avLst/>
+          </a:prstGeom>
+          <a:noFill/>
+          <a:ln/>
+        </p:spPr>
+        <p:txBody>
+          <a:bodyPr wrap="square" lIns="0" tIns="0" rIns="0" bIns="0" rtlCol="0" anchor="t"/>
+          <a:lstStyle/>
+          <a:p>
             <a:pPr indent="0" marL="0">
               <a:buNone/>
             </a:pPr>
             <a:r>
-              <a:rPr lang="en-US" sz="3000" b="1" dirty="0">
-                <a:solidFill>
-                  <a:schemeClr val="accent2"/>
+              <a:rPr lang="en-US" sz="1500" b="1" dirty="0">
+                <a:solidFill>
+                  <a:schemeClr val="tx1"/>
+                </a:solidFill>
+              </a:rPr>
+              <a:t>A menu of measured moves</a:t>
+            </a:r>
+            <a:endParaRPr lang="en-US" sz="1500" dirty="0"/>
+          </a:p>
+        </p:txBody>
+      </p:sp>
+      <p:sp>
+        <p:nvSpPr>
+          <p:cNvPr id="23" name="Time v3"/>
+          <p:cNvSpPr txBox="1"/>
+          <p:nvPr/>
+        </p:nvSpPr>
+        <p:spPr>
+          <a:xfrm>
+            <a:off x="5193792" y="3383280"/>
+            <a:ext cx="1737360" cy="457200"/>
+          </a:xfrm>
+          <a:prstGeom prst="rect">
+            <a:avLst/>
+          </a:prstGeom>
+          <a:noFill/>
+          <a:ln/>
+        </p:spPr>
+        <p:txBody>
+          <a:bodyPr wrap="square" lIns="0" tIns="0" rIns="0" bIns="0" rtlCol="0" anchor="t"/>
+          <a:lstStyle/>
+          <a:p>
+            <a:pPr indent="0" marL="0">
+              <a:buNone/>
+            </a:pPr>
+            <a:r>
+              <a:rPr lang="en-US" sz="2400" b="1" dirty="0">
+                <a:solidFill>
+                  <a:schemeClr val="accent3"/>
                 </a:solidFill>
                 <a:latin typeface="Cambria" pitchFamily="34" charset="0"/>
                 <a:ea typeface="Cambria" pitchFamily="34" charset="-122"/>
                 <a:cs typeface="Cambria" pitchFamily="34" charset="-120"/>
               </a:rPr>
-              <a:t>71% vs 50%</a:t>
-            </a:r>
-            <a:endParaRPr lang="en-US" sz="3000" dirty="0"/>
-          </a:p>
-        </p:txBody>
-      </p:sp>
-      <p:sp>
-        <p:nvSpPr>
-          <p:cNvPr id="12" name="Result label 3"/>
-          <p:cNvSpPr txBox="1"/>
-          <p:nvPr/>
-        </p:nvSpPr>
-        <p:spPr>
-          <a:xfrm>
-            <a:off x="7818120" y="5294376"/>
-            <a:ext cx="3566160" cy="594360"/>
+              <a:t>1,492 µs</a:t>
+            </a:r>
+            <a:endParaRPr lang="en-US" sz="2400" dirty="0"/>
+          </a:p>
+        </p:txBody>
+      </p:sp>
+      <p:sp>
+        <p:nvSpPr>
+          <p:cNvPr id="24" name="Time label v3"/>
+          <p:cNvSpPr txBox="1"/>
+          <p:nvPr/>
+        </p:nvSpPr>
+        <p:spPr>
+          <a:xfrm>
+            <a:off x="5193792" y="3822192"/>
+            <a:ext cx="1737360" cy="274320"/>
           </a:xfrm>
           <a:prstGeom prst="rect">
             <a:avLst/>
@@ -5907,14 +6084,664 @@
               <a:buNone/>
             </a:pPr>
             <a:r>
-              <a:rPr lang="en-US" sz="1300" dirty="0">
+              <a:rPr lang="en-US" sz="1100" dirty="0">
                 <a:solidFill>
                   <a:schemeClr val="tx2"/>
                 </a:solidFill>
               </a:rPr>
-              <a:t>runs that find the best: a one-line rule on our menu against the 8B model (random 38%)</a:t>
-            </a:r>
-            <a:endParaRPr lang="en-US" sz="1300" dirty="0"/>
+              <a:t>median final time</a:t>
+            </a:r>
+            <a:endParaRPr lang="en-US" sz="1100" dirty="0"/>
+          </a:p>
+        </p:txBody>
+      </p:sp>
+      <p:sp>
+        <p:nvSpPr>
+          <p:cNvPr id="25" name="Wasted v3"/>
+          <p:cNvSpPr txBox="1"/>
+          <p:nvPr/>
+        </p:nvSpPr>
+        <p:spPr>
+          <a:xfrm>
+            <a:off x="5193792" y="4160520"/>
+            <a:ext cx="1737360" cy="365760"/>
+          </a:xfrm>
+          <a:prstGeom prst="rect">
+            <a:avLst/>
+          </a:prstGeom>
+          <a:noFill/>
+          <a:ln/>
+        </p:spPr>
+        <p:txBody>
+          <a:bodyPr wrap="square" lIns="0" tIns="0" rIns="0" bIns="0" rtlCol="0" anchor="t"/>
+          <a:lstStyle/>
+          <a:p>
+            <a:pPr indent="0" marL="0">
+              <a:buNone/>
+            </a:pPr>
+            <a:r>
+              <a:rPr lang="en-US" sz="1800" b="1" dirty="0">
+                <a:solidFill>
+                  <a:schemeClr val="tx1"/>
+                </a:solidFill>
+              </a:rPr>
+              <a:t>25 of 100</a:t>
+            </a:r>
+            <a:endParaRPr lang="en-US" sz="1800" dirty="0"/>
+          </a:p>
+        </p:txBody>
+      </p:sp>
+      <p:sp>
+        <p:nvSpPr>
+          <p:cNvPr id="26" name="Wasted label v3"/>
+          <p:cNvSpPr txBox="1"/>
+          <p:nvPr/>
+        </p:nvSpPr>
+        <p:spPr>
+          <a:xfrm>
+            <a:off x="5193792" y="4526280"/>
+            <a:ext cx="1737360" cy="365760"/>
+          </a:xfrm>
+          <a:prstGeom prst="rect">
+            <a:avLst/>
+          </a:prstGeom>
+          <a:noFill/>
+          <a:ln/>
+        </p:spPr>
+        <p:txBody>
+          <a:bodyPr wrap="square" lIns="0" tIns="0" rIns="0" bIns="0" rtlCol="0" anchor="t"/>
+          <a:lstStyle/>
+          <a:p>
+            <a:pPr indent="0" marL="0">
+              <a:buNone/>
+            </a:pPr>
+            <a:r>
+              <a:rPr lang="en-US" sz="1100" dirty="0">
+                <a:solidFill>
+                  <a:schemeClr val="tx2"/>
+                </a:solidFill>
+              </a:rPr>
+              <a:t>attempts with no measurement</a:t>
+            </a:r>
+            <a:endParaRPr lang="en-US" sz="1100" dirty="0"/>
+          </a:p>
+        </p:txBody>
+      </p:sp>
+      <p:sp>
+        <p:nvSpPr>
+          <p:cNvPr id="27" name="Design card v4"/>
+          <p:cNvSpPr/>
+          <p:nvPr/>
+        </p:nvSpPr>
+        <p:spPr>
+          <a:xfrm>
+            <a:off x="7242048" y="1463040"/>
+            <a:ext cx="2084832" cy="3520440"/>
+          </a:xfrm>
+          <a:prstGeom prst="roundRect">
+            <a:avLst>
+              <a:gd name="adj" fmla="val 3509"/>
+            </a:avLst>
+          </a:prstGeom>
+          <a:solidFill>
+            <a:schemeClr val="bg2"/>
+          </a:solidFill>
+          <a:ln w="12700">
+            <a:solidFill>
+              <a:schemeClr val="bg2"/>
+            </a:solidFill>
+            <a:prstDash val="solid"/>
+          </a:ln>
+        </p:spPr>
+      </p:sp>
+      <p:sp>
+        <p:nvSpPr>
+          <p:cNvPr id="28" name="Badge v4"/>
+          <p:cNvSpPr/>
+          <p:nvPr/>
+        </p:nvSpPr>
+        <p:spPr>
+          <a:xfrm>
+            <a:off x="7424928" y="1645920"/>
+            <a:ext cx="640080" cy="640080"/>
+          </a:xfrm>
+          <a:prstGeom prst="ellipse">
+            <a:avLst/>
+          </a:prstGeom>
+          <a:solidFill>
+            <a:schemeClr val="accent1"/>
+          </a:solidFill>
+          <a:ln w="12700">
+            <a:solidFill>
+              <a:schemeClr val="accent1"/>
+            </a:solidFill>
+            <a:prstDash val="solid"/>
+          </a:ln>
+        </p:spPr>
+      </p:sp>
+      <p:sp>
+        <p:nvSpPr>
+          <p:cNvPr id="29" name="Badge text v4"/>
+          <p:cNvSpPr txBox="1"/>
+          <p:nvPr/>
+        </p:nvSpPr>
+        <p:spPr>
+          <a:xfrm>
+            <a:off x="7424928" y="1645920"/>
+            <a:ext cx="640080" cy="640080"/>
+          </a:xfrm>
+          <a:prstGeom prst="rect">
+            <a:avLst/>
+          </a:prstGeom>
+          <a:noFill/>
+          <a:ln/>
+        </p:spPr>
+        <p:txBody>
+          <a:bodyPr wrap="square" lIns="0" tIns="0" rIns="0" bIns="0" rtlCol="0" anchor="ctr"/>
+          <a:lstStyle/>
+          <a:p>
+            <a:pPr algn="ctr" indent="0" marL="0">
+              <a:buNone/>
+            </a:pPr>
+            <a:r>
+              <a:rPr lang="en-US" sz="1800" b="1" dirty="0">
+                <a:solidFill>
+                  <a:schemeClr val="bg1"/>
+                </a:solidFill>
+              </a:rPr>
+              <a:t>v4</a:t>
+            </a:r>
+            <a:endParaRPr lang="en-US" sz="1800" dirty="0"/>
+          </a:p>
+        </p:txBody>
+      </p:sp>
+      <p:sp>
+        <p:nvSpPr>
+          <p:cNvPr id="30" name="Shown v4"/>
+          <p:cNvSpPr txBox="1"/>
+          <p:nvPr/>
+        </p:nvSpPr>
+        <p:spPr>
+          <a:xfrm>
+            <a:off x="7424928" y="2423160"/>
+            <a:ext cx="1737360" cy="914400"/>
+          </a:xfrm>
+          <a:prstGeom prst="rect">
+            <a:avLst/>
+          </a:prstGeom>
+          <a:noFill/>
+          <a:ln/>
+        </p:spPr>
+        <p:txBody>
+          <a:bodyPr wrap="square" lIns="0" tIns="0" rIns="0" bIns="0" rtlCol="0" anchor="t"/>
+          <a:lstStyle/>
+          <a:p>
+            <a:pPr indent="0" marL="0">
+              <a:buNone/>
+            </a:pPr>
+            <a:r>
+              <a:rPr lang="en-US" sz="1500" b="1" dirty="0">
+                <a:solidFill>
+                  <a:schemeClr val="tx1"/>
+                </a:solidFill>
+              </a:rPr>
+              <a:t>v3, and the edit is checked first</a:t>
+            </a:r>
+            <a:endParaRPr lang="en-US" sz="1500" dirty="0"/>
+          </a:p>
+        </p:txBody>
+      </p:sp>
+      <p:sp>
+        <p:nvSpPr>
+          <p:cNvPr id="31" name="Time v4"/>
+          <p:cNvSpPr txBox="1"/>
+          <p:nvPr/>
+        </p:nvSpPr>
+        <p:spPr>
+          <a:xfrm>
+            <a:off x="7424928" y="3383280"/>
+            <a:ext cx="1737360" cy="457200"/>
+          </a:xfrm>
+          <a:prstGeom prst="rect">
+            <a:avLst/>
+          </a:prstGeom>
+          <a:noFill/>
+          <a:ln/>
+        </p:spPr>
+        <p:txBody>
+          <a:bodyPr wrap="square" lIns="0" tIns="0" rIns="0" bIns="0" rtlCol="0" anchor="t"/>
+          <a:lstStyle/>
+          <a:p>
+            <a:pPr indent="0" marL="0">
+              <a:buNone/>
+            </a:pPr>
+            <a:r>
+              <a:rPr lang="en-US" sz="2400" b="1" dirty="0">
+                <a:solidFill>
+                  <a:schemeClr val="accent1"/>
+                </a:solidFill>
+                <a:latin typeface="Cambria" pitchFamily="34" charset="0"/>
+                <a:ea typeface="Cambria" pitchFamily="34" charset="-122"/>
+                <a:cs typeface="Cambria" pitchFamily="34" charset="-120"/>
+              </a:rPr>
+              <a:t>1,495 µs</a:t>
+            </a:r>
+            <a:endParaRPr lang="en-US" sz="2400" dirty="0"/>
+          </a:p>
+        </p:txBody>
+      </p:sp>
+      <p:sp>
+        <p:nvSpPr>
+          <p:cNvPr id="32" name="Time label v4"/>
+          <p:cNvSpPr txBox="1"/>
+          <p:nvPr/>
+        </p:nvSpPr>
+        <p:spPr>
+          <a:xfrm>
+            <a:off x="7424928" y="3822192"/>
+            <a:ext cx="1737360" cy="274320"/>
+          </a:xfrm>
+          <a:prstGeom prst="rect">
+            <a:avLst/>
+          </a:prstGeom>
+          <a:noFill/>
+          <a:ln/>
+        </p:spPr>
+        <p:txBody>
+          <a:bodyPr wrap="square" lIns="0" tIns="0" rIns="0" bIns="0" rtlCol="0" anchor="t"/>
+          <a:lstStyle/>
+          <a:p>
+            <a:pPr indent="0" marL="0">
+              <a:buNone/>
+            </a:pPr>
+            <a:r>
+              <a:rPr lang="en-US" sz="1100" dirty="0">
+                <a:solidFill>
+                  <a:schemeClr val="tx2"/>
+                </a:solidFill>
+              </a:rPr>
+              <a:t>median final time</a:t>
+            </a:r>
+            <a:endParaRPr lang="en-US" sz="1100" dirty="0"/>
+          </a:p>
+        </p:txBody>
+      </p:sp>
+      <p:sp>
+        <p:nvSpPr>
+          <p:cNvPr id="33" name="Wasted v4"/>
+          <p:cNvSpPr txBox="1"/>
+          <p:nvPr/>
+        </p:nvSpPr>
+        <p:spPr>
+          <a:xfrm>
+            <a:off x="7424928" y="4160520"/>
+            <a:ext cx="1737360" cy="365760"/>
+          </a:xfrm>
+          <a:prstGeom prst="rect">
+            <a:avLst/>
+          </a:prstGeom>
+          <a:noFill/>
+          <a:ln/>
+        </p:spPr>
+        <p:txBody>
+          <a:bodyPr wrap="square" lIns="0" tIns="0" rIns="0" bIns="0" rtlCol="0" anchor="t"/>
+          <a:lstStyle/>
+          <a:p>
+            <a:pPr indent="0" marL="0">
+              <a:buNone/>
+            </a:pPr>
+            <a:r>
+              <a:rPr lang="en-US" sz="1800" b="1" dirty="0">
+                <a:solidFill>
+                  <a:schemeClr val="tx1"/>
+                </a:solidFill>
+              </a:rPr>
+              <a:t>2 of 100</a:t>
+            </a:r>
+            <a:endParaRPr lang="en-US" sz="1800" dirty="0"/>
+          </a:p>
+        </p:txBody>
+      </p:sp>
+      <p:sp>
+        <p:nvSpPr>
+          <p:cNvPr id="34" name="Wasted label v4"/>
+          <p:cNvSpPr txBox="1"/>
+          <p:nvPr/>
+        </p:nvSpPr>
+        <p:spPr>
+          <a:xfrm>
+            <a:off x="7424928" y="4526280"/>
+            <a:ext cx="1737360" cy="365760"/>
+          </a:xfrm>
+          <a:prstGeom prst="rect">
+            <a:avLst/>
+          </a:prstGeom>
+          <a:noFill/>
+          <a:ln/>
+        </p:spPr>
+        <p:txBody>
+          <a:bodyPr wrap="square" lIns="0" tIns="0" rIns="0" bIns="0" rtlCol="0" anchor="t"/>
+          <a:lstStyle/>
+          <a:p>
+            <a:pPr indent="0" marL="0">
+              <a:buNone/>
+            </a:pPr>
+            <a:r>
+              <a:rPr lang="en-US" sz="1100" dirty="0">
+                <a:solidFill>
+                  <a:schemeClr val="tx2"/>
+                </a:solidFill>
+              </a:rPr>
+              <a:t>attempts with no measurement</a:t>
+            </a:r>
+            <a:endParaRPr lang="en-US" sz="1100" dirty="0"/>
+          </a:p>
+        </p:txBody>
+      </p:sp>
+      <p:sp>
+        <p:nvSpPr>
+          <p:cNvPr id="35" name="Design card v5"/>
+          <p:cNvSpPr/>
+          <p:nvPr/>
+        </p:nvSpPr>
+        <p:spPr>
+          <a:xfrm>
+            <a:off x="9473184" y="1463040"/>
+            <a:ext cx="2084832" cy="3520440"/>
+          </a:xfrm>
+          <a:prstGeom prst="roundRect">
+            <a:avLst>
+              <a:gd name="adj" fmla="val 3509"/>
+            </a:avLst>
+          </a:prstGeom>
+          <a:solidFill>
+            <a:schemeClr val="bg2"/>
+          </a:solidFill>
+          <a:ln w="12700">
+            <a:solidFill>
+              <a:schemeClr val="bg2"/>
+            </a:solidFill>
+            <a:prstDash val="solid"/>
+          </a:ln>
+        </p:spPr>
+      </p:sp>
+      <p:sp>
+        <p:nvSpPr>
+          <p:cNvPr id="36" name="Badge v5"/>
+          <p:cNvSpPr/>
+          <p:nvPr/>
+        </p:nvSpPr>
+        <p:spPr>
+          <a:xfrm>
+            <a:off x="9656064" y="1645920"/>
+            <a:ext cx="640080" cy="640080"/>
+          </a:xfrm>
+          <a:prstGeom prst="ellipse">
+            <a:avLst/>
+          </a:prstGeom>
+          <a:solidFill>
+            <a:schemeClr val="accent1"/>
+          </a:solidFill>
+          <a:ln w="12700">
+            <a:solidFill>
+              <a:schemeClr val="accent1"/>
+            </a:solidFill>
+            <a:prstDash val="solid"/>
+          </a:ln>
+        </p:spPr>
+      </p:sp>
+      <p:sp>
+        <p:nvSpPr>
+          <p:cNvPr id="37" name="Badge text v5"/>
+          <p:cNvSpPr txBox="1"/>
+          <p:nvPr/>
+        </p:nvSpPr>
+        <p:spPr>
+          <a:xfrm>
+            <a:off x="9656064" y="1645920"/>
+            <a:ext cx="640080" cy="640080"/>
+          </a:xfrm>
+          <a:prstGeom prst="rect">
+            <a:avLst/>
+          </a:prstGeom>
+          <a:noFill/>
+          <a:ln/>
+        </p:spPr>
+        <p:txBody>
+          <a:bodyPr wrap="square" lIns="0" tIns="0" rIns="0" bIns="0" rtlCol="0" anchor="ctr"/>
+          <a:lstStyle/>
+          <a:p>
+            <a:pPr algn="ctr" indent="0" marL="0">
+              <a:buNone/>
+            </a:pPr>
+            <a:r>
+              <a:rPr lang="en-US" sz="1800" b="1" dirty="0">
+                <a:solidFill>
+                  <a:schemeClr val="bg1"/>
+                </a:solidFill>
+              </a:rPr>
+              <a:t>v5</a:t>
+            </a:r>
+            <a:endParaRPr lang="en-US" sz="1800" dirty="0"/>
+          </a:p>
+        </p:txBody>
+      </p:sp>
+      <p:sp>
+        <p:nvSpPr>
+          <p:cNvPr id="38" name="Shown v5"/>
+          <p:cNvSpPr txBox="1"/>
+          <p:nvPr/>
+        </p:nvSpPr>
+        <p:spPr>
+          <a:xfrm>
+            <a:off x="9656064" y="2423160"/>
+            <a:ext cx="1737360" cy="914400"/>
+          </a:xfrm>
+          <a:prstGeom prst="rect">
+            <a:avLst/>
+          </a:prstGeom>
+          <a:noFill/>
+          <a:ln/>
+        </p:spPr>
+        <p:txBody>
+          <a:bodyPr wrap="square" lIns="0" tIns="0" rIns="0" bIns="0" rtlCol="0" anchor="t"/>
+          <a:lstStyle/>
+          <a:p>
+            <a:pPr indent="0" marL="0">
+              <a:buNone/>
+            </a:pPr>
+            <a:r>
+              <a:rPr lang="en-US" sz="1500" b="1" dirty="0">
+                <a:solidFill>
+                  <a:schemeClr val="tx1"/>
+                </a:solidFill>
+              </a:rPr>
+              <a:t>v4, with far moves; names its move</a:t>
+            </a:r>
+            <a:endParaRPr lang="en-US" sz="1500" dirty="0"/>
+          </a:p>
+        </p:txBody>
+      </p:sp>
+      <p:sp>
+        <p:nvSpPr>
+          <p:cNvPr id="39" name="Time v5"/>
+          <p:cNvSpPr txBox="1"/>
+          <p:nvPr/>
+        </p:nvSpPr>
+        <p:spPr>
+          <a:xfrm>
+            <a:off x="9656064" y="3383280"/>
+            <a:ext cx="1737360" cy="457200"/>
+          </a:xfrm>
+          <a:prstGeom prst="rect">
+            <a:avLst/>
+          </a:prstGeom>
+          <a:noFill/>
+          <a:ln/>
+        </p:spPr>
+        <p:txBody>
+          <a:bodyPr wrap="square" lIns="0" tIns="0" rIns="0" bIns="0" rtlCol="0" anchor="t"/>
+          <a:lstStyle/>
+          <a:p>
+            <a:pPr indent="0" marL="0">
+              <a:buNone/>
+            </a:pPr>
+            <a:r>
+              <a:rPr lang="en-US" sz="2400" b="1" dirty="0">
+                <a:solidFill>
+                  <a:schemeClr val="accent1"/>
+                </a:solidFill>
+                <a:latin typeface="Cambria" pitchFamily="34" charset="0"/>
+                <a:ea typeface="Cambria" pitchFamily="34" charset="-122"/>
+                <a:cs typeface="Cambria" pitchFamily="34" charset="-120"/>
+              </a:rPr>
+              <a:t>1,494 µs</a:t>
+            </a:r>
+            <a:endParaRPr lang="en-US" sz="2400" dirty="0"/>
+          </a:p>
+        </p:txBody>
+      </p:sp>
+      <p:sp>
+        <p:nvSpPr>
+          <p:cNvPr id="40" name="Time label v5"/>
+          <p:cNvSpPr txBox="1"/>
+          <p:nvPr/>
+        </p:nvSpPr>
+        <p:spPr>
+          <a:xfrm>
+            <a:off x="9656064" y="3822192"/>
+            <a:ext cx="1737360" cy="274320"/>
+          </a:xfrm>
+          <a:prstGeom prst="rect">
+            <a:avLst/>
+          </a:prstGeom>
+          <a:noFill/>
+          <a:ln/>
+        </p:spPr>
+        <p:txBody>
+          <a:bodyPr wrap="square" lIns="0" tIns="0" rIns="0" bIns="0" rtlCol="0" anchor="t"/>
+          <a:lstStyle/>
+          <a:p>
+            <a:pPr indent="0" marL="0">
+              <a:buNone/>
+            </a:pPr>
+            <a:r>
+              <a:rPr lang="en-US" sz="1100" dirty="0">
+                <a:solidFill>
+                  <a:schemeClr val="tx2"/>
+                </a:solidFill>
+              </a:rPr>
+              <a:t>median final time</a:t>
+            </a:r>
+            <a:endParaRPr lang="en-US" sz="1100" dirty="0"/>
+          </a:p>
+        </p:txBody>
+      </p:sp>
+      <p:sp>
+        <p:nvSpPr>
+          <p:cNvPr id="41" name="Wasted v5"/>
+          <p:cNvSpPr txBox="1"/>
+          <p:nvPr/>
+        </p:nvSpPr>
+        <p:spPr>
+          <a:xfrm>
+            <a:off x="9656064" y="4160520"/>
+            <a:ext cx="1737360" cy="365760"/>
+          </a:xfrm>
+          <a:prstGeom prst="rect">
+            <a:avLst/>
+          </a:prstGeom>
+          <a:noFill/>
+          <a:ln/>
+        </p:spPr>
+        <p:txBody>
+          <a:bodyPr wrap="square" lIns="0" tIns="0" rIns="0" bIns="0" rtlCol="0" anchor="t"/>
+          <a:lstStyle/>
+          <a:p>
+            <a:pPr indent="0" marL="0">
+              <a:buNone/>
+            </a:pPr>
+            <a:r>
+              <a:rPr lang="en-US" sz="1800" b="1" dirty="0">
+                <a:solidFill>
+                  <a:schemeClr val="tx1"/>
+                </a:solidFill>
+              </a:rPr>
+              <a:t>0 of 100</a:t>
+            </a:r>
+            <a:endParaRPr lang="en-US" sz="1800" dirty="0"/>
+          </a:p>
+        </p:txBody>
+      </p:sp>
+      <p:sp>
+        <p:nvSpPr>
+          <p:cNvPr id="42" name="Wasted label v5"/>
+          <p:cNvSpPr txBox="1"/>
+          <p:nvPr/>
+        </p:nvSpPr>
+        <p:spPr>
+          <a:xfrm>
+            <a:off x="9656064" y="4526280"/>
+            <a:ext cx="1737360" cy="365760"/>
+          </a:xfrm>
+          <a:prstGeom prst="rect">
+            <a:avLst/>
+          </a:prstGeom>
+          <a:noFill/>
+          <a:ln/>
+        </p:spPr>
+        <p:txBody>
+          <a:bodyPr wrap="square" lIns="0" tIns="0" rIns="0" bIns="0" rtlCol="0" anchor="t"/>
+          <a:lstStyle/>
+          <a:p>
+            <a:pPr indent="0" marL="0">
+              <a:buNone/>
+            </a:pPr>
+            <a:r>
+              <a:rPr lang="en-US" sz="1100" dirty="0">
+                <a:solidFill>
+                  <a:schemeClr val="tx2"/>
+                </a:solidFill>
+              </a:rPr>
+              <a:t>attempts with no measurement</a:t>
+            </a:r>
+            <a:endParaRPr lang="en-US" sz="1100" dirty="0"/>
+          </a:p>
+        </p:txBody>
+      </p:sp>
+      <p:sp>
+        <p:nvSpPr>
+          <p:cNvPr id="43" name="Design caption"/>
+          <p:cNvSpPr txBox="1"/>
+          <p:nvPr/>
+        </p:nvSpPr>
+        <p:spPr>
+          <a:xfrm>
+            <a:off x="548640" y="5257800"/>
+            <a:ext cx="11064240" cy="731520"/>
+          </a:xfrm>
+          <a:prstGeom prst="rect">
+            <a:avLst/>
+          </a:prstGeom>
+          <a:noFill/>
+          <a:ln/>
+        </p:spPr>
+        <p:txBody>
+          <a:bodyPr wrap="square" lIns="0" tIns="0" rIns="0" bIns="0" rtlCol="0" anchor="t"/>
+          <a:lstStyle/>
+          <a:p>
+            <a:pPr indent="0" marL="0">
+              <a:buNone/>
+            </a:pPr>
+            <a:r>
+              <a:rPr lang="en-US" sz="1500" dirty="0">
+                <a:solidFill>
+                  <a:schemeClr val="tx2"/>
+                </a:solidFill>
+              </a:rPr>
+              <a:t>Each design fixes a failure we read in the previous one's log. The model, Qwen3-8B, never changed. Adapter-style shape, 10 starting points: best possible 1,361 µs, random guessing 1,467 µs.</a:t>
+            </a:r>
+            <a:endParaRPr lang="en-US" sz="1500" dirty="0"/>
           </a:p>
         </p:txBody>
       </p:sp>
@@ -6020,54 +6847,112 @@
                   <a:schemeClr val="tx1"/>
                 </a:solidFill>
               </a:rPr>
-              <a:t>Tuned, the kernel is level with AWS's compiler</a:t>
+              <a:t>What we got: the checker decides, not the model</a:t>
             </a:r>
             <a:endParaRPr lang="en-US" sz="3600" dirty="0"/>
           </a:p>
         </p:txBody>
       </p:sp>
-      <p:graphicFrame>
-        <p:nvGraphicFramePr>
-          <p:cNvPr id="3" name="Chart: 32-bit layer totals" descr=""/>
-          <p:cNvGraphicFramePr/>
-          <p:nvPr/>
-        </p:nvGraphicFramePr>
-        <p:xfrm>
-          <a:off x="548640" y="1417320"/>
-          <a:ext cx="5486400" cy="3931920"/>
-        </p:xfrm>
-        <a:graphic xmlns:a="http://schemas.openxmlformats.org/drawingml/2006/main">
-          <a:graphicData uri="http://schemas.openxmlformats.org/drawingml/2006/chart">
-            <c:chart xmlns:c="http://schemas.openxmlformats.org/drawingml/2006/chart" r:id="rId1"/>
-          </a:graphicData>
-        </a:graphic>
-      </p:graphicFrame>
-      <p:graphicFrame>
-        <p:nvGraphicFramePr>
-          <p:cNvPr id="4" name="Chart: 16-bit feed-forward block" descr=""/>
-          <p:cNvGraphicFramePr/>
-          <p:nvPr/>
-        </p:nvGraphicFramePr>
-        <p:xfrm>
-          <a:off x="6172200" y="1417320"/>
-          <a:ext cx="5486400" cy="3931920"/>
-        </p:xfrm>
-        <a:graphic xmlns:a="http://schemas.openxmlformats.org/drawingml/2006/main">
-          <a:graphicData uri="http://schemas.openxmlformats.org/drawingml/2006/chart">
-            <c:chart xmlns:c="http://schemas.openxmlformats.org/drawingml/2006/chart" r:id="rId2"/>
-          </a:graphicData>
-        </a:graphic>
-      </p:graphicFrame>
-      <p:sp>
-        <p:nvSpPr>
-          <p:cNvPr id="5" name="Chart caption"/>
-          <p:cNvSpPr txBox="1"/>
-          <p:nvPr/>
-        </p:nvSpPr>
-        <p:spPr>
-          <a:xfrm>
-            <a:off x="548640" y="5440680"/>
-            <a:ext cx="11064240" cy="777240"/>
+      <p:pic>
+        <p:nvPicPr>
+          <p:cNvPr id="3" name="Chart: best time against attempts, 30 starts" descr="Line chart of best kernel time found against attempts on the chip, for each approach, at the adapter shape">    </p:cNvPr>
+          <p:cNvPicPr>
+            <a:picLocks noChangeAspect="1"/>
+          </p:cNvPicPr>
+          <p:nvPr/>
+        </p:nvPicPr>
+        <p:blipFill>
+          <a:blip r:embed="rId1"/>
+          <a:stretch>
+            <a:fillRect/>
+          </a:stretch>
+        </p:blipFill>
+        <p:spPr>
+          <a:xfrm>
+            <a:off x="548640" y="1417320"/>
+            <a:ext cx="6766560" cy="4663440"/>
+          </a:xfrm>
+          <a:prstGeom prst="rect">
+            <a:avLst/>
+          </a:prstGeom>
+        </p:spPr>
+      </p:pic>
+      <p:sp>
+        <p:nvSpPr>
+          <p:cNvPr id="4" name="Result card 1"/>
+          <p:cNvSpPr/>
+          <p:nvPr/>
+        </p:nvSpPr>
+        <p:spPr>
+          <a:xfrm>
+            <a:off x="7589520" y="1417320"/>
+            <a:ext cx="4023360" cy="1417320"/>
+          </a:xfrm>
+          <a:prstGeom prst="roundRect">
+            <a:avLst>
+              <a:gd name="adj" fmla="val 5161"/>
+            </a:avLst>
+          </a:prstGeom>
+          <a:solidFill>
+            <a:schemeClr val="bg2"/>
+          </a:solidFill>
+          <a:ln w="12700">
+            <a:solidFill>
+              <a:schemeClr val="bg2"/>
+            </a:solidFill>
+            <a:prstDash val="solid"/>
+          </a:ln>
+        </p:spPr>
+      </p:sp>
+      <p:sp>
+        <p:nvSpPr>
+          <p:cNvPr id="5" name="Result 1"/>
+          <p:cNvSpPr txBox="1"/>
+          <p:nvPr/>
+        </p:nvSpPr>
+        <p:spPr>
+          <a:xfrm>
+            <a:off x="7818120" y="1554480"/>
+            <a:ext cx="3566160" cy="566928"/>
+          </a:xfrm>
+          <a:prstGeom prst="rect">
+            <a:avLst/>
+          </a:prstGeom>
+          <a:noFill/>
+          <a:ln/>
+        </p:spPr>
+        <p:txBody>
+          <a:bodyPr wrap="square" lIns="0" tIns="0" rIns="0" bIns="0" rtlCol="0" anchor="ctr"/>
+          <a:lstStyle/>
+          <a:p>
+            <a:pPr indent="0" marL="0">
+              <a:buNone/>
+            </a:pPr>
+            <a:r>
+              <a:rPr lang="en-US" sz="3000" b="1" dirty="0">
+                <a:solidFill>
+                  <a:schemeClr val="accent1"/>
+                </a:solidFill>
+                <a:latin typeface="Cambria" pitchFamily="34" charset="0"/>
+                <a:ea typeface="Cambria" pitchFamily="34" charset="-122"/>
+                <a:cs typeface="Cambria" pitchFamily="34" charset="-120"/>
+              </a:rPr>
+              <a:t>3 → 29 of 30</a:t>
+            </a:r>
+            <a:endParaRPr lang="en-US" sz="3000" dirty="0"/>
+          </a:p>
+        </p:txBody>
+      </p:sp>
+      <p:sp>
+        <p:nvSpPr>
+          <p:cNvPr id="6" name="Result label 1"/>
+          <p:cNvSpPr txBox="1"/>
+          <p:nvPr/>
+        </p:nvSpPr>
+        <p:spPr>
+          <a:xfrm>
+            <a:off x="7818120" y="2148840"/>
+            <a:ext cx="3566160" cy="594360"/>
           </a:xfrm>
           <a:prstGeom prst="rect">
             <a:avLst/>
@@ -6083,14 +6968,218 @@
               <a:buNone/>
             </a:pPr>
             <a:r>
-              <a:rPr lang="en-US" sz="1400" dirty="0">
+              <a:rPr lang="en-US" sz="1300" dirty="0">
                 <a:solidFill>
                   <a:schemeClr val="tx2"/>
                 </a:solidFill>
               </a:rPr>
-              <a:t>Left: sums of standalone kernel times, one loop run per layer shape. Right: a small model with random weights at Qwen3-8B's sizes; tuned bar is the median of five loop runs (2.86 to 2.89 ms). Level with the compiler at 32-bit, 4% to 5% behind at 16-bit.</a:t>
-            </a:r>
-            <a:endParaRPr lang="en-US" sz="1400" dirty="0"/>
+              <a:t>runs within 10% of the best, first checker to last, same model</a:t>
+            </a:r>
+            <a:endParaRPr lang="en-US" sz="1300" dirty="0"/>
+          </a:p>
+        </p:txBody>
+      </p:sp>
+      <p:sp>
+        <p:nvSpPr>
+          <p:cNvPr id="7" name="Result card 2"/>
+          <p:cNvSpPr/>
+          <p:nvPr/>
+        </p:nvSpPr>
+        <p:spPr>
+          <a:xfrm>
+            <a:off x="7589520" y="2990088"/>
+            <a:ext cx="4023360" cy="1417320"/>
+          </a:xfrm>
+          <a:prstGeom prst="roundRect">
+            <a:avLst>
+              <a:gd name="adj" fmla="val 5161"/>
+            </a:avLst>
+          </a:prstGeom>
+          <a:solidFill>
+            <a:schemeClr val="bg2"/>
+          </a:solidFill>
+          <a:ln w="12700">
+            <a:solidFill>
+              <a:schemeClr val="bg2"/>
+            </a:solidFill>
+            <a:prstDash val="solid"/>
+          </a:ln>
+        </p:spPr>
+      </p:sp>
+      <p:sp>
+        <p:nvSpPr>
+          <p:cNvPr id="8" name="Result 2"/>
+          <p:cNvSpPr txBox="1"/>
+          <p:nvPr/>
+        </p:nvSpPr>
+        <p:spPr>
+          <a:xfrm>
+            <a:off x="7818120" y="3127248"/>
+            <a:ext cx="3566160" cy="566928"/>
+          </a:xfrm>
+          <a:prstGeom prst="rect">
+            <a:avLst/>
+          </a:prstGeom>
+          <a:noFill/>
+          <a:ln/>
+        </p:spPr>
+        <p:txBody>
+          <a:bodyPr wrap="square" lIns="0" tIns="0" rIns="0" bIns="0" rtlCol="0" anchor="ctr"/>
+          <a:lstStyle/>
+          <a:p>
+            <a:pPr indent="0" marL="0">
+              <a:buNone/>
+            </a:pPr>
+            <a:r>
+              <a:rPr lang="en-US" sz="3000" b="1" dirty="0">
+                <a:solidFill>
+                  <a:schemeClr val="accent3"/>
+                </a:solidFill>
+                <a:latin typeface="Cambria" pitchFamily="34" charset="0"/>
+                <a:ea typeface="Cambria" pitchFamily="34" charset="-122"/>
+                <a:cs typeface="Cambria" pitchFamily="34" charset="-120"/>
+              </a:rPr>
+              <a:t>73%</a:t>
+            </a:r>
+            <a:endParaRPr lang="en-US" sz="3000" dirty="0"/>
+          </a:p>
+        </p:txBody>
+      </p:sp>
+      <p:sp>
+        <p:nvSpPr>
+          <p:cNvPr id="9" name="Result label 2"/>
+          <p:cNvSpPr txBox="1"/>
+          <p:nvPr/>
+        </p:nvSpPr>
+        <p:spPr>
+          <a:xfrm>
+            <a:off x="7818120" y="3721608"/>
+            <a:ext cx="3566160" cy="594360"/>
+          </a:xfrm>
+          <a:prstGeom prst="rect">
+            <a:avLst/>
+          </a:prstGeom>
+          <a:noFill/>
+          <a:ln/>
+        </p:spPr>
+        <p:txBody>
+          <a:bodyPr wrap="square" lIns="0" tIns="0" rIns="0" bIns="0" rtlCol="0" anchor="t"/>
+          <a:lstStyle/>
+          <a:p>
+            <a:pPr indent="0" marL="0">
+              <a:buNone/>
+            </a:pPr>
+            <a:r>
+              <a:rPr lang="en-US" sz="1300" dirty="0">
+                <a:solidFill>
+                  <a:schemeClr val="tx2"/>
+                </a:solidFill>
+              </a:rPr>
+              <a:t>of runs within 10% of the best for random guessing</a:t>
+            </a:r>
+            <a:endParaRPr lang="en-US" sz="1300" dirty="0"/>
+          </a:p>
+        </p:txBody>
+      </p:sp>
+      <p:sp>
+        <p:nvSpPr>
+          <p:cNvPr id="10" name="Result card 3"/>
+          <p:cNvSpPr/>
+          <p:nvPr/>
+        </p:nvSpPr>
+        <p:spPr>
+          <a:xfrm>
+            <a:off x="7589520" y="4562856"/>
+            <a:ext cx="4023360" cy="1417320"/>
+          </a:xfrm>
+          <a:prstGeom prst="roundRect">
+            <a:avLst>
+              <a:gd name="adj" fmla="val 5161"/>
+            </a:avLst>
+          </a:prstGeom>
+          <a:solidFill>
+            <a:schemeClr val="bg2"/>
+          </a:solidFill>
+          <a:ln w="12700">
+            <a:solidFill>
+              <a:schemeClr val="bg2"/>
+            </a:solidFill>
+            <a:prstDash val="solid"/>
+          </a:ln>
+        </p:spPr>
+      </p:sp>
+      <p:sp>
+        <p:nvSpPr>
+          <p:cNvPr id="11" name="Result 3"/>
+          <p:cNvSpPr txBox="1"/>
+          <p:nvPr/>
+        </p:nvSpPr>
+        <p:spPr>
+          <a:xfrm>
+            <a:off x="7818120" y="4700016"/>
+            <a:ext cx="3566160" cy="566928"/>
+          </a:xfrm>
+          <a:prstGeom prst="rect">
+            <a:avLst/>
+          </a:prstGeom>
+          <a:noFill/>
+          <a:ln/>
+        </p:spPr>
+        <p:txBody>
+          <a:bodyPr wrap="square" lIns="0" tIns="0" rIns="0" bIns="0" rtlCol="0" anchor="ctr"/>
+          <a:lstStyle/>
+          <a:p>
+            <a:pPr indent="0" marL="0">
+              <a:buNone/>
+            </a:pPr>
+            <a:r>
+              <a:rPr lang="en-US" sz="3000" b="1" dirty="0">
+                <a:solidFill>
+                  <a:schemeClr val="accent2"/>
+                </a:solidFill>
+                <a:latin typeface="Cambria" pitchFamily="34" charset="0"/>
+                <a:ea typeface="Cambria" pitchFamily="34" charset="-122"/>
+                <a:cs typeface="Cambria" pitchFamily="34" charset="-120"/>
+              </a:rPr>
+              <a:t>71% vs 50%</a:t>
+            </a:r>
+            <a:endParaRPr lang="en-US" sz="3000" dirty="0"/>
+          </a:p>
+        </p:txBody>
+      </p:sp>
+      <p:sp>
+        <p:nvSpPr>
+          <p:cNvPr id="12" name="Result label 3"/>
+          <p:cNvSpPr txBox="1"/>
+          <p:nvPr/>
+        </p:nvSpPr>
+        <p:spPr>
+          <a:xfrm>
+            <a:off x="7818120" y="5294376"/>
+            <a:ext cx="3566160" cy="594360"/>
+          </a:xfrm>
+          <a:prstGeom prst="rect">
+            <a:avLst/>
+          </a:prstGeom>
+          <a:noFill/>
+          <a:ln/>
+        </p:spPr>
+        <p:txBody>
+          <a:bodyPr wrap="square" lIns="0" tIns="0" rIns="0" bIns="0" rtlCol="0" anchor="t"/>
+          <a:lstStyle/>
+          <a:p>
+            <a:pPr indent="0" marL="0">
+              <a:buNone/>
+            </a:pPr>
+            <a:r>
+              <a:rPr lang="en-US" sz="1300" dirty="0">
+                <a:solidFill>
+                  <a:schemeClr val="tx2"/>
+                </a:solidFill>
+              </a:rPr>
+              <a:t>runs that find the best: a one-line rule on our menu against the 8B model (random 38%)</a:t>
+            </a:r>
+            <a:endParaRPr lang="en-US" sz="1300" dirty="0"/>
           </a:p>
         </p:txBody>
       </p:sp>
@@ -6196,6 +7285,182 @@
                   <a:schemeClr val="tx1"/>
                 </a:solidFill>
               </a:rPr>
+              <a:t>Tuned, the kernel is level with AWS's compiler</a:t>
+            </a:r>
+            <a:endParaRPr lang="en-US" sz="3600" dirty="0"/>
+          </a:p>
+        </p:txBody>
+      </p:sp>
+      <p:graphicFrame>
+        <p:nvGraphicFramePr>
+          <p:cNvPr id="3" name="Chart: 32-bit layer totals" descr=""/>
+          <p:cNvGraphicFramePr/>
+          <p:nvPr/>
+        </p:nvGraphicFramePr>
+        <p:xfrm>
+          <a:off x="548640" y="1417320"/>
+          <a:ext cx="5486400" cy="3931920"/>
+        </p:xfrm>
+        <a:graphic xmlns:a="http://schemas.openxmlformats.org/drawingml/2006/main">
+          <a:graphicData uri="http://schemas.openxmlformats.org/drawingml/2006/chart">
+            <c:chart xmlns:c="http://schemas.openxmlformats.org/drawingml/2006/chart" r:id="rId1"/>
+          </a:graphicData>
+        </a:graphic>
+      </p:graphicFrame>
+      <p:graphicFrame>
+        <p:nvGraphicFramePr>
+          <p:cNvPr id="4" name="Chart: 16-bit feed-forward block" descr=""/>
+          <p:cNvGraphicFramePr/>
+          <p:nvPr/>
+        </p:nvGraphicFramePr>
+        <p:xfrm>
+          <a:off x="6172200" y="1417320"/>
+          <a:ext cx="5486400" cy="3931920"/>
+        </p:xfrm>
+        <a:graphic xmlns:a="http://schemas.openxmlformats.org/drawingml/2006/main">
+          <a:graphicData uri="http://schemas.openxmlformats.org/drawingml/2006/chart">
+            <c:chart xmlns:c="http://schemas.openxmlformats.org/drawingml/2006/chart" r:id="rId2"/>
+          </a:graphicData>
+        </a:graphic>
+      </p:graphicFrame>
+      <p:sp>
+        <p:nvSpPr>
+          <p:cNvPr id="5" name="Chart caption"/>
+          <p:cNvSpPr txBox="1"/>
+          <p:nvPr/>
+        </p:nvSpPr>
+        <p:spPr>
+          <a:xfrm>
+            <a:off x="548640" y="5440680"/>
+            <a:ext cx="11064240" cy="777240"/>
+          </a:xfrm>
+          <a:prstGeom prst="rect">
+            <a:avLst/>
+          </a:prstGeom>
+          <a:noFill/>
+          <a:ln/>
+        </p:spPr>
+        <p:txBody>
+          <a:bodyPr wrap="square" lIns="0" tIns="0" rIns="0" bIns="0" rtlCol="0" anchor="t"/>
+          <a:lstStyle/>
+          <a:p>
+            <a:pPr indent="0" marL="0">
+              <a:buNone/>
+            </a:pPr>
+            <a:r>
+              <a:rPr lang="en-US" sz="1400" dirty="0">
+                <a:solidFill>
+                  <a:schemeClr val="tx2"/>
+                </a:solidFill>
+              </a:rPr>
+              <a:t>Left: sums of standalone kernel times, one loop run per layer shape. Right: a small model with random weights at Qwen3-8B's sizes; tuned bar is the median of five loop runs (2.86 to 2.89 ms). Level with the compiler at 32-bit, 4% to 5% behind at 16-bit.</a:t>
+            </a:r>
+            <a:endParaRPr lang="en-US" sz="1400" dirty="0"/>
+          </a:p>
+        </p:txBody>
+      </p:sp>
+      <p:sp>
+        <p:nvSpPr>
+          <p:cNvPr id="25" name="Slide Number Placeholder 0"/>
+          <p:cNvSpPr>
+            <a:spLocks noGrp="1"/>
+          </p:cNvSpPr>
+          <p:nvPr>
+            <p:ph type="sldNum" sz="quarter" idx="4294967295"/>
+          </p:nvPr>
+        </p:nvSpPr>
+        <p:spPr>
+          <a:xfrm>
+            <a:off x="11155680" y="6355080"/>
+            <a:ext cx="457200" cy="274320"/>
+          </a:xfrm>
+          <a:prstGeom prst="rect">
+            <a:avLst/>
+          </a:prstGeom>
+          <a:extLst>
+            <a:ext uri="{C572A759-6A51-4108-AA02-DFA0A04FC94B}">
+              <ma14:wrappingTextBoxFlag xmlns:ma14="http://schemas.microsoft.com/office/mac/drawingml/2011/main" val="0"/>
+            </a:ext>
+          </a:extLst>
+        </p:spPr>
+        <p:txBody>
+          <a:bodyPr/>
+          <a:lstStyle>
+            <a:lvl1pPr>
+              <a:defRPr sz="1000">
+                <a:solidFill>
+                  <a:srgbClr val="5B6B7A"/>
+                </a:solidFill>
+              </a:defRPr>
+            </a:lvl1pPr>
+          </a:lstStyle>
+          <a:p>
+            <a:pPr algn="r"/>
+            <a:fld id="{F7021451-1387-4CA6-816F-3879F97B5CBC}" type="slidenum">
+              <a:rPr b="0" lang="en-US"/>
+              <a:t>8</a:t>
+            </a:fld>
+            <a:endParaRPr lang="en-US"/>
+          </a:p>
+        </p:txBody>
+      </p:sp>
+    </p:spTree>
+  </p:cSld>
+  <p:clrMapOvr>
+    <a:masterClrMapping/>
+  </p:clrMapOvr>
+</p:sld>
+</file>
+
+<file path=ppt/slides/slide9.xml><?xml version="1.0" encoding="utf-8"?>
+<p:sld xmlns:a="http://schemas.openxmlformats.org/drawingml/2006/main" xmlns:r="http://schemas.openxmlformats.org/officeDocument/2006/relationships" xmlns:p="http://schemas.openxmlformats.org/presentationml/2006/main">
+  <p:cSld name="Slide 9">
+    <p:spTree>
+      <p:nvGrpSpPr>
+        <p:cNvPr id="1" name=""/>
+        <p:cNvGrpSpPr/>
+        <p:nvPr/>
+      </p:nvGrpSpPr>
+      <p:grpSpPr>
+        <a:xfrm>
+          <a:off x="0" y="0"/>
+          <a:ext cx="0" cy="0"/>
+          <a:chOff x="0" y="0"/>
+          <a:chExt cx="0" cy="0"/>
+        </a:xfrm>
+      </p:grpSpPr>
+      <p:sp>
+        <p:nvSpPr>
+          <p:cNvPr id="2" name="Text 0"/>
+          <p:cNvSpPr/>
+          <p:nvPr>
+            <p:ph idx="100" type="title" hasCustomPrompt="1"/>
+          </p:nvPr>
+        </p:nvSpPr>
+        <p:spPr>
+          <a:xfrm>
+            <a:off x="548640" y="411480"/>
+            <a:ext cx="11064240" cy="822960"/>
+          </a:xfrm>
+          <a:prstGeom prst="rect">
+            <a:avLst/>
+          </a:prstGeom>
+          <a:noFill/>
+          <a:ln/>
+        </p:spPr>
+        <p:txBody>
+          <a:bodyPr wrap="square" lIns="0" tIns="0" rIns="0" bIns="0" rtlCol="0" anchor="ctr"/>
+          <a:lstStyle/>
+          <a:p>
+            <a:pPr algn="l" indent="0" marL="0">
+              <a:buNone/>
+            </a:pPr>
+            <a:r>
+              <a:rPr lang="en-US" sz="3600" b="1" dirty="0">
+                <a:solidFill>
+                  <a:schemeClr val="tx1"/>
+                </a:solidFill>
+              </a:rPr>
               <a:t>What we do not claim, and what comes next</a:t>
             </a:r>
             <a:endParaRPr lang="en-US" sz="3600" dirty="0"/>
@@ -6536,7 +7801,7 @@
             <a:pPr algn="r"/>
             <a:fld id="{F7021451-1387-4CA6-816F-3879F97B5CBC}" type="slidenum">
               <a:rPr b="0" lang="en-US"/>
-              <a:t>8</a:t>
+              <a:t>9</a:t>
             </a:fld>
             <a:endParaRPr lang="en-US"/>
           </a:p>

</xml_diff>